<commit_message>
New features for telemetry extract and Starlink424
</commit_message>
<xml_diff>
--- a/Launch_Vehicle_Optimization_GitHub_Current.pptx
+++ b/Launch_Vehicle_Optimization_GitHub_Current.pptx
@@ -2,31 +2,31 @@
 <file path=ppt/presentation.xml><?xml version="1.0" encoding="utf-8"?>
 <p:presentation xmlns:p="http://schemas.openxmlformats.org/presentationml/2006/main">
   <p:sldMasterIdLst>
-    <p:sldMasterId xmlns:r="http://schemas.openxmlformats.org/officeDocument/2006/relationships" id="2147483648" r:id="Rd36c3c50263c473f"/>
+    <p:sldMasterId xmlns:r="http://schemas.openxmlformats.org/officeDocument/2006/relationships" id="2147483648" r:id="Raf58be010de644d2"/>
   </p:sldMasterIdLst>
   <p:notesMasterIdLst>
-    <p:notesMasterId xmlns:r="http://schemas.openxmlformats.org/officeDocument/2006/relationships" r:id="R01ec52a3cb874d97"/>
+    <p:notesMasterId xmlns:r="http://schemas.openxmlformats.org/officeDocument/2006/relationships" r:id="R5ac9d892919c44f2"/>
   </p:notesMasterIdLst>
   <p:sldIdLst>
-    <p:sldId xmlns:r="http://schemas.openxmlformats.org/officeDocument/2006/relationships" id="256" r:id="R9731210d957146c9"/>
-    <p:sldId xmlns:r="http://schemas.openxmlformats.org/officeDocument/2006/relationships" id="257" r:id="R71c964b00cb9433c"/>
-    <p:sldId xmlns:r="http://schemas.openxmlformats.org/officeDocument/2006/relationships" id="258" r:id="Rd6be38166def4ae8"/>
-    <p:sldId xmlns:r="http://schemas.openxmlformats.org/officeDocument/2006/relationships" id="259" r:id="Rae74dc38f7f3401e"/>
-    <p:sldId xmlns:r="http://schemas.openxmlformats.org/officeDocument/2006/relationships" id="260" r:id="Rdcefd8aaaa714c16"/>
-    <p:sldId xmlns:r="http://schemas.openxmlformats.org/officeDocument/2006/relationships" id="261" r:id="R841fc78b18734e68"/>
-    <p:sldId xmlns:r="http://schemas.openxmlformats.org/officeDocument/2006/relationships" id="262" r:id="Rb3b5870c1ce143ec"/>
-    <p:sldId xmlns:r="http://schemas.openxmlformats.org/officeDocument/2006/relationships" id="263" r:id="R9c31efd3c7ec4579"/>
-    <p:sldId xmlns:r="http://schemas.openxmlformats.org/officeDocument/2006/relationships" id="264" r:id="Ra821ce80b95744bf"/>
-    <p:sldId xmlns:r="http://schemas.openxmlformats.org/officeDocument/2006/relationships" id="265" r:id="Ra678cba823d04cc3"/>
-    <p:sldId xmlns:r="http://schemas.openxmlformats.org/officeDocument/2006/relationships" id="266" r:id="Rbd79d45e990e4ae8"/>
-    <p:sldId xmlns:r="http://schemas.openxmlformats.org/officeDocument/2006/relationships" id="267" r:id="R46907eba6d5d4af4"/>
-    <p:sldId xmlns:r="http://schemas.openxmlformats.org/officeDocument/2006/relationships" id="268" r:id="Rbb721e7364e34732"/>
-    <p:sldId xmlns:r="http://schemas.openxmlformats.org/officeDocument/2006/relationships" id="269" r:id="Raa04abaaa8d34fcd"/>
-    <p:sldId xmlns:r="http://schemas.openxmlformats.org/officeDocument/2006/relationships" id="270" r:id="R7527b2f10b6142f0"/>
-    <p:sldId xmlns:r="http://schemas.openxmlformats.org/officeDocument/2006/relationships" id="271" r:id="Rac7dbf54900d4843"/>
-    <p:sldId xmlns:r="http://schemas.openxmlformats.org/officeDocument/2006/relationships" id="272" r:id="R486c5620c3df4249"/>
-    <p:sldId xmlns:r="http://schemas.openxmlformats.org/officeDocument/2006/relationships" id="273" r:id="R7c6222f68fb14d9b"/>
-    <p:sldId xmlns:r="http://schemas.openxmlformats.org/officeDocument/2006/relationships" id="274" r:id="R0652bca16aca402a"/>
+    <p:sldId xmlns:r="http://schemas.openxmlformats.org/officeDocument/2006/relationships" id="256" r:id="Rbc2068efd9834a0e"/>
+    <p:sldId xmlns:r="http://schemas.openxmlformats.org/officeDocument/2006/relationships" id="257" r:id="R3a0a19f92fdb43b3"/>
+    <p:sldId xmlns:r="http://schemas.openxmlformats.org/officeDocument/2006/relationships" id="258" r:id="R2c6c2437a8194b37"/>
+    <p:sldId xmlns:r="http://schemas.openxmlformats.org/officeDocument/2006/relationships" id="259" r:id="R9d32d99b1dc84fe6"/>
+    <p:sldId xmlns:r="http://schemas.openxmlformats.org/officeDocument/2006/relationships" id="260" r:id="R08369fba43194a61"/>
+    <p:sldId xmlns:r="http://schemas.openxmlformats.org/officeDocument/2006/relationships" id="261" r:id="Rbf677ed548d94dc2"/>
+    <p:sldId xmlns:r="http://schemas.openxmlformats.org/officeDocument/2006/relationships" id="262" r:id="R5300141d9d564bdf"/>
+    <p:sldId xmlns:r="http://schemas.openxmlformats.org/officeDocument/2006/relationships" id="263" r:id="Raf94a5bd9ad74b58"/>
+    <p:sldId xmlns:r="http://schemas.openxmlformats.org/officeDocument/2006/relationships" id="264" r:id="R475d0e6582af4bf2"/>
+    <p:sldId xmlns:r="http://schemas.openxmlformats.org/officeDocument/2006/relationships" id="265" r:id="R6af6dd1982b04fe7"/>
+    <p:sldId xmlns:r="http://schemas.openxmlformats.org/officeDocument/2006/relationships" id="266" r:id="R0de2e85f9601448b"/>
+    <p:sldId xmlns:r="http://schemas.openxmlformats.org/officeDocument/2006/relationships" id="267" r:id="R448318d008a84a81"/>
+    <p:sldId xmlns:r="http://schemas.openxmlformats.org/officeDocument/2006/relationships" id="268" r:id="Rd2bda784c01147f6"/>
+    <p:sldId xmlns:r="http://schemas.openxmlformats.org/officeDocument/2006/relationships" id="269" r:id="Rc43a5cad765d4466"/>
+    <p:sldId xmlns:r="http://schemas.openxmlformats.org/officeDocument/2006/relationships" id="270" r:id="R00c975b5634a4101"/>
+    <p:sldId xmlns:r="http://schemas.openxmlformats.org/officeDocument/2006/relationships" id="271" r:id="Rbd539b2f3b954204"/>
+    <p:sldId xmlns:r="http://schemas.openxmlformats.org/officeDocument/2006/relationships" id="272" r:id="Rb451feb294604ced"/>
+    <p:sldId xmlns:r="http://schemas.openxmlformats.org/officeDocument/2006/relationships" id="273" r:id="Recca3a5c8d7247a8"/>
+    <p:sldId xmlns:r="http://schemas.openxmlformats.org/officeDocument/2006/relationships" id="274" r:id="R6b1c7d0d651b425b"/>
   </p:sldIdLst>
   <p:sldSz cx="12192000" cy="6858000"/>
   <p:notesSz cx="6858000" cy="9144000"/>
@@ -460,7 +460,17 @@
           <a:lstStyle xmlns:a="http://schemas.openxmlformats.org/drawingml/2006/main"/>
           <a:p xmlns:a="http://schemas.openxmlformats.org/drawingml/2006/main">
             <a:r>
-              <a:t>Source: https://github.com/pukmark/LaunchVehicleOptimization/tree/5295f20211b50467d81eac8f47408673b93e9190 . Current default-branch HEAD retrieved October 8, 2026, commit 5295f20 (gui update). Nominal Falcon 9, configuration 1, with unit dispersion factors and zero offsets. Parameter values: LV_Type_scaled.py lines 54–123 and derived initialization 144–151. Phase constraints: LV_Optimization_Type.py lines 125–324. Atmosphere: Atmosphere_Type.py. Values are optimizer inputs. Payload and target orbit remain mission-dependent.</a:t>
+              <a:t>General symbolic formulation based on LaunchVehicleOptimization, implementation snapshot 5295f20211b50467d81eac8f47408673b93e9190. Source: https://github.com/pukmark/LaunchVehicleOptimization/tree/5295f20211b50467d81eac8f47408673b93e9190 . Vehicle properties, engine configurations, phase gates and operational bounds remain input parameters. No Falcon 9 numerical values are assigned.</a:t>
+            </a:r>
+          </a:p>
+          <a:p xmlns:a="http://schemas.openxmlformats.org/drawingml/2006/main">
+            <a:r>
+              <a:t/>
+            </a:r>
+          </a:p>
+          <a:p xmlns:a="http://schemas.openxmlformats.org/drawingml/2006/main">
+            <a:r>
+              <a:t>All parameter symbols are configured per vehicle and mission. Mathematical constants, phase indices and state-vector dimensions remain explicit. Phase gates are feasibility constraints rather than necessarily automatic event triggers. SES-2 uses an analytical tangential impulse and propellant reserve. Heat and dynamic-pressure limits are sampled during post-entry descent and landing in the implementation.</a:t>
             </a:r>
           </a:p>
         </p:txBody>
@@ -530,7 +540,7 @@
           <a:lstStyle xmlns:a="http://schemas.openxmlformats.org/drawingml/2006/main"/>
           <a:p xmlns:a="http://schemas.openxmlformats.org/drawingml/2006/main">
             <a:r>
-              <a:t>Code Phase 3. Both second-stage grids optimize controls and durations. Inclination, parking apsides, and reserve bound are explicit terminal constraints. Quantities r_p and r_a are Earth-center radii.</a:t>
+              <a:t>General symbolic formulation based on LaunchVehicleOptimization, implementation snapshot 5295f20211b50467d81eac8f47408673b93e9190. Source: https://github.com/pukmark/LaunchVehicleOptimization/tree/5295f20211b50467d81eac8f47408673b93e9190 . Vehicle properties, engine configurations, phase gates and operational bounds remain input parameters. No Falcon 9 numerical values are assigned.</a:t>
             </a:r>
           </a:p>
           <a:p xmlns:a="http://schemas.openxmlformats.org/drawingml/2006/main">
@@ -540,7 +550,7 @@
           </a:p>
           <a:p xmlns:a="http://schemas.openxmlformats.org/drawingml/2006/main">
             <a:r>
-              <a:t>Source: https://github.com/pukmark/LaunchVehicleOptimization/tree/5295f20211b50467d81eac8f47408673b93e9190 . Current default-branch HEAD retrieved October 8, 2026, commit 5295f20 (gui update). Nominal Falcon 9, configuration 1, with unit dispersion factors and zero offsets. Parameter values: LV_Type_scaled.py lines 54–123 and derived initialization 144–151. Phase constraints: LV_Optimization_Type.py lines 125–324. Atmosphere: Atmosphere_Type.py. Values are optimizer inputs. Payload and target orbit remain mission-dependent.</a:t>
+              <a:t>All parameter symbols are configured per vehicle and mission. Mathematical constants, phase indices and state-vector dimensions remain explicit. Phase gates are feasibility constraints rather than necessarily automatic event triggers. SES-2 uses an analytical tangential impulse and propellant reserve. Heat and dynamic-pressure limits are sampled during post-entry descent and landing in the implementation.</a:t>
             </a:r>
           </a:p>
           <a:p xmlns:a="http://schemas.openxmlformats.org/drawingml/2006/main">
@@ -585,7 +595,7 @@
           </a:p>
           <a:p xmlns:a="http://schemas.openxmlformats.org/drawingml/2006/main">
             <a:r>
-              <a:t>\begin{aligned}625.878\ \mathrm{kN}&amp;\leq\|\bm F\|\leq981\ \mathrm{kN}\\[2pt]a_{\mathrm{load}}&amp;\leq36.7875\ \mathrm{m/s^2}\\[2pt]r_{a,\mathrm{park}}&amp;=r_{p,\mathrm{target}}\\[2pt]r_{p,\mathrm{park}}&amp;\geq R_E+150\ \mathrm{km}\\[2pt]i_{\mathrm{park}}&amp;=i_{\mathrm{target}}\\[2pt]m_{\mathrm{pre}}&amp;\geq m_{2,\mathrm{dry}}+m_{\mathrm{PL}}+\Delta m\end{aligned}</a:t>
+              <a:t>\begin{aligned}T_{2,\min}&amp;\leq\|\bm F\|\leq T_{2,\max}\\[2pt]a_{\mathrm{load}}&amp;\leq a_{\max}\\[2pt]r_{a,\mathrm{park}}&amp;=r_{p,\mathrm{target}}\\[2pt]r_{p,\mathrm{park}}&amp;\geq R_E+h_{p,\min}\\[2pt]i_{\mathrm{park}}&amp;=i_{\mathrm{target}}\\[2pt]m_{\mathrm{pre}}&amp;\geq m_{2,\mathrm{dry}}+m_{\mathrm{PL}}+\Delta m\end{aligned}</a:t>
             </a:r>
           </a:p>
         </p:txBody>
@@ -655,7 +665,7 @@
           <a:lstStyle xmlns:a="http://schemas.openxmlformats.org/drawingml/2006/main"/>
           <a:p xmlns:a="http://schemas.openxmlformats.org/drawingml/2006/main">
             <a:r>
-              <a:t>This explanatory coast is the physical interpretation of the reserve calculation. No thermal propellant loss or settling/start-up reserve is included in the supplied maneuver model. The apogee radius condition distinguishes apogee from perigee, since radial speed is zero at either apsis.</a:t>
+              <a:t>General symbolic formulation based on LaunchVehicleOptimization, implementation snapshot 5295f20211b50467d81eac8f47408673b93e9190. Source: https://github.com/pukmark/LaunchVehicleOptimization/tree/5295f20211b50467d81eac8f47408673b93e9190 . Vehicle properties, engine configurations, phase gates and operational bounds remain input parameters. No Falcon 9 numerical values are assigned.</a:t>
             </a:r>
           </a:p>
           <a:p xmlns:a="http://schemas.openxmlformats.org/drawingml/2006/main">
@@ -665,7 +675,7 @@
           </a:p>
           <a:p xmlns:a="http://schemas.openxmlformats.org/drawingml/2006/main">
             <a:r>
-              <a:t>Source: https://github.com/pukmark/LaunchVehicleOptimization/tree/5295f20211b50467d81eac8f47408673b93e9190 . Current default-branch HEAD retrieved October 8, 2026, commit 5295f20 (gui update). Nominal Falcon 9, configuration 1, with unit dispersion factors and zero offsets. Parameter values: LV_Type_scaled.py lines 54–123 and derived initialization 144–151. Phase constraints: LV_Optimization_Type.py lines 125–324. Atmosphere: Atmosphere_Type.py. Values are optimizer inputs. Payload and target orbit remain mission-dependent.</a:t>
+              <a:t>All parameter symbols are configured per vehicle and mission. Mathematical constants, phase indices and state-vector dimensions remain explicit. Phase gates are feasibility constraints rather than necessarily automatic event triggers. SES-2 uses an analytical tangential impulse and propellant reserve. Heat and dynamic-pressure limits are sampled during post-entry descent and landing in the implementation.</a:t>
             </a:r>
           </a:p>
           <a:p xmlns:a="http://schemas.openxmlformats.org/drawingml/2006/main">
@@ -780,7 +790,7 @@
           <a:lstStyle xmlns:a="http://schemas.openxmlformats.org/drawingml/2006/main"/>
           <a:p xmlns:a="http://schemas.openxmlformats.org/drawingml/2006/main">
             <a:r>
-              <a:t>Code propellant_mass_for_final_dv uses vis-viva at parking apogee and the rocket equation. The impulse magnitude is determined by the two orbits, not an additional independent optimized control. Direction is tangential; target inclination is already achieved. A finite burn would instead use the upper-stage ECI equations with thrust and throttle limits. Startup and boil-off are not modeled.</a:t>
+              <a:t>General symbolic formulation based on LaunchVehicleOptimization, implementation snapshot 5295f20211b50467d81eac8f47408673b93e9190. Source: https://github.com/pukmark/LaunchVehicleOptimization/tree/5295f20211b50467d81eac8f47408673b93e9190 . Vehicle properties, engine configurations, phase gates and operational bounds remain input parameters. No Falcon 9 numerical values are assigned.</a:t>
             </a:r>
           </a:p>
           <a:p xmlns:a="http://schemas.openxmlformats.org/drawingml/2006/main">
@@ -790,7 +800,7 @@
           </a:p>
           <a:p xmlns:a="http://schemas.openxmlformats.org/drawingml/2006/main">
             <a:r>
-              <a:t>Source: https://github.com/pukmark/LaunchVehicleOptimization/tree/5295f20211b50467d81eac8f47408673b93e9190 . Current default-branch HEAD retrieved October 8, 2026, commit 5295f20 (gui update). Nominal Falcon 9, configuration 1, with unit dispersion factors and zero offsets. Parameter values: LV_Type_scaled.py lines 54–123 and derived initialization 144–151. Phase constraints: LV_Optimization_Type.py lines 125–324. Atmosphere: Atmosphere_Type.py. Values are optimizer inputs. Payload and target orbit remain mission-dependent.</a:t>
+              <a:t>All parameter symbols are configured per vehicle and mission. Mathematical constants, phase indices and state-vector dimensions remain explicit. Phase gates are feasibility constraints rather than necessarily automatic event triggers. SES-2 uses an analytical tangential impulse and propellant reserve. Heat and dynamic-pressure limits are sampled during post-entry descent and landing in the implementation.</a:t>
             </a:r>
           </a:p>
           <a:p xmlns:a="http://schemas.openxmlformats.org/drawingml/2006/main">
@@ -905,7 +915,7 @@
           <a:lstStyle xmlns:a="http://schemas.openxmlformats.org/drawingml/2006/main"/>
           <a:p xmlns:a="http://schemas.openxmlformats.org/drawingml/2006/main">
             <a:r>
-              <a:t>Code uses one thrust vector held over the boostback segment and integrates with substeps. No standalone boostback endpoint is prescribed: its exit state couples to the coast and landing boundaries. Final dry-mass condition is enforced at landing, rather than an explicit boostback path constraint; monotonic consumption makes it an implied lower bound earlier.</a:t>
+              <a:t>General symbolic formulation based on LaunchVehicleOptimization, implementation snapshot 5295f20211b50467d81eac8f47408673b93e9190. Source: https://github.com/pukmark/LaunchVehicleOptimization/tree/5295f20211b50467d81eac8f47408673b93e9190 . Vehicle properties, engine configurations, phase gates and operational bounds remain input parameters. No Falcon 9 numerical values are assigned.</a:t>
             </a:r>
           </a:p>
           <a:p xmlns:a="http://schemas.openxmlformats.org/drawingml/2006/main">
@@ -915,7 +925,7 @@
           </a:p>
           <a:p xmlns:a="http://schemas.openxmlformats.org/drawingml/2006/main">
             <a:r>
-              <a:t>Source: https://github.com/pukmark/LaunchVehicleOptimization/tree/5295f20211b50467d81eac8f47408673b93e9190 . Current default-branch HEAD retrieved October 8, 2026, commit 5295f20 (gui update). Nominal Falcon 9, configuration 1, with unit dispersion factors and zero offsets. Parameter values: LV_Type_scaled.py lines 54–123 and derived initialization 144–151. Phase constraints: LV_Optimization_Type.py lines 125–324. Atmosphere: Atmosphere_Type.py. Values are optimizer inputs. Payload and target orbit remain mission-dependent.</a:t>
+              <a:t>All parameter symbols are configured per vehicle and mission. Mathematical constants, phase indices and state-vector dimensions remain explicit. Phase gates are feasibility constraints rather than necessarily automatic event triggers. SES-2 uses an analytical tangential impulse and propellant reserve. Heat and dynamic-pressure limits are sampled during post-entry descent and landing in the implementation.</a:t>
             </a:r>
           </a:p>
           <a:p xmlns:a="http://schemas.openxmlformats.org/drawingml/2006/main">
@@ -960,7 +970,7 @@
           </a:p>
           <a:p xmlns:a="http://schemas.openxmlformats.org/drawingml/2006/main">
             <a:r>
-              <a:t>\begin{aligned}\|\bm F_B\|&amp;\leq2.742\ \mathrm{MN}\\[2pt]\Delta t_{\mathrm{BB}}&amp;\geq1\ \mathrm{s}\\[2pt]m_{B,f}&amp;\geq m_{B,\mathrm{dry}}\\[2pt]x_{\mathrm{land}}&amp;=x_{\mathrm{launch}}\quad\text{(later boundary)}\end{aligned}</a:t>
+              <a:t>\begin{aligned}\|\bm F_B\|&amp;\leq T_{\mathrm{BB},\max}\\[2pt]\Delta t_{\mathrm{BB}}&amp;\geq t_{\mathrm{BB},\min}\\[2pt]m_{B,f}&amp;\geq m_{B,\mathrm{dry}}\\[2pt]x_{\mathrm{land}}&amp;=x_{\mathrm{launch}}\quad\text{(later boundary)}\end{aligned}</a:t>
             </a:r>
           </a:p>
         </p:txBody>
@@ -1030,7 +1040,7 @@
           <a:lstStyle xmlns:a="http://schemas.openxmlformats.org/drawingml/2006/main"/>
           <a:p xmlns:a="http://schemas.openxmlformats.org/drawingml/2006/main">
             <a:r>
-              <a:t>Code propagates a ballistic segment for an optimized duration &gt;=75 s, then constrains its terminal altitude &gt;=70 km. Dynamic-pressure and heat limits are not sampled explicitly during this pre-entry coast.</a:t>
+              <a:t>General symbolic formulation based on LaunchVehicleOptimization, implementation snapshot 5295f20211b50467d81eac8f47408673b93e9190. Source: https://github.com/pukmark/LaunchVehicleOptimization/tree/5295f20211b50467d81eac8f47408673b93e9190 . Vehicle properties, engine configurations, phase gates and operational bounds remain input parameters. No Falcon 9 numerical values are assigned.</a:t>
             </a:r>
           </a:p>
           <a:p xmlns:a="http://schemas.openxmlformats.org/drawingml/2006/main">
@@ -1040,7 +1050,7 @@
           </a:p>
           <a:p xmlns:a="http://schemas.openxmlformats.org/drawingml/2006/main">
             <a:r>
-              <a:t>Source: https://github.com/pukmark/LaunchVehicleOptimization/tree/5295f20211b50467d81eac8f47408673b93e9190 . Current default-branch HEAD retrieved October 8, 2026, commit 5295f20 (gui update). Nominal Falcon 9, configuration 1, with unit dispersion factors and zero offsets. Parameter values: LV_Type_scaled.py lines 54–123 and derived initialization 144–151. Phase constraints: LV_Optimization_Type.py lines 125–324. Atmosphere: Atmosphere_Type.py. Values are optimizer inputs. Payload and target orbit remain mission-dependent.</a:t>
+              <a:t>All parameter symbols are configured per vehicle and mission. Mathematical constants, phase indices and state-vector dimensions remain explicit. Phase gates are feasibility constraints rather than necessarily automatic event triggers. SES-2 uses an analytical tangential impulse and propellant reserve. Heat and dynamic-pressure limits are sampled during post-entry descent and landing in the implementation.</a:t>
             </a:r>
           </a:p>
           <a:p xmlns:a="http://schemas.openxmlformats.org/drawingml/2006/main">
@@ -1085,7 +1095,7 @@
           </a:p>
           <a:p xmlns:a="http://schemas.openxmlformats.org/drawingml/2006/main">
             <a:r>
-              <a:t>\begin{aligned}\Delta t_{\mathrm{coast}}&amp;\geq75\ \mathrm{s}\\[2pt]h(t_{\mathrm{entry}})&amp;\geq70\ \mathrm{km}\\[2pt]m&amp;=\mathrm{constant}\end{aligned}</a:t>
+              <a:t>\begin{aligned}\Delta t_{\mathrm{coast}}&amp;\geq t_{\mathrm{coast},\min}\\[2pt]h(t_{\mathrm{entry}})&amp;\geq h_{\mathrm{entry},\min}\\[2pt]m&amp;=\mathrm{constant}\end{aligned}</a:t>
             </a:r>
           </a:p>
         </p:txBody>
@@ -1155,7 +1165,7 @@
           <a:lstStyle xmlns:a="http://schemas.openxmlformats.org/drawingml/2006/main"/>
           <a:p xmlns:a="http://schemas.openxmlformats.org/drawingml/2006/main">
             <a:r>
-              <a:t>Code entry throttle bound is normalized by the configured recovery thrust scale, not full nine-engine ascent capacity. q and heat inequalities constrain the subsequent trajectory; this supplied code does not sample these loads within the entry-burn segment. T_B,ref=FirstStage_SL_Thrust/3=2.535 MN. Active return mass-flow uses Isp=282 s without atmospheric or throttle correction.</a:t>
+              <a:t>General symbolic formulation based on LaunchVehicleOptimization, implementation snapshot 5295f20211b50467d81eac8f47408673b93e9190. Source: https://github.com/pukmark/LaunchVehicleOptimization/tree/5295f20211b50467d81eac8f47408673b93e9190 . Vehicle properties, engine configurations, phase gates and operational bounds remain input parameters. No Falcon 9 numerical values are assigned.</a:t>
             </a:r>
           </a:p>
           <a:p xmlns:a="http://schemas.openxmlformats.org/drawingml/2006/main">
@@ -1165,7 +1175,7 @@
           </a:p>
           <a:p xmlns:a="http://schemas.openxmlformats.org/drawingml/2006/main">
             <a:r>
-              <a:t>Source: https://github.com/pukmark/LaunchVehicleOptimization/tree/5295f20211b50467d81eac8f47408673b93e9190 . Current default-branch HEAD retrieved October 8, 2026, commit 5295f20 (gui update). Nominal Falcon 9, configuration 1, with unit dispersion factors and zero offsets. Parameter values: LV_Type_scaled.py lines 54–123 and derived initialization 144–151. Phase constraints: LV_Optimization_Type.py lines 125–324. Atmosphere: Atmosphere_Type.py. Values are optimizer inputs. Payload and target orbit remain mission-dependent.</a:t>
+              <a:t>All parameter symbols are configured per vehicle and mission. Mathematical constants, phase indices and state-vector dimensions remain explicit. Phase gates are feasibility constraints rather than necessarily automatic event triggers. SES-2 uses an analytical tangential impulse and propellant reserve. Heat and dynamic-pressure limits are sampled during post-entry descent and landing in the implementation.</a:t>
             </a:r>
           </a:p>
           <a:p xmlns:a="http://schemas.openxmlformats.org/drawingml/2006/main">
@@ -1200,7 +1210,7 @@
           </a:p>
           <a:p xmlns:a="http://schemas.openxmlformats.org/drawingml/2006/main">
             <a:r>
-              <a:t>\begin{aligned}\dot{\bm r}_L&amp;=\bm v_L\\[4pt]\dot{\bm v}_L&amp;=-\frac{T+D}{m}\bm e_v+\bm g_L\\[4pt]\dot m&amp;=-\frac{f_T T_{B,\mathrm{ref}}}{g_0(282\ \mathrm{s})}\end{aligned}</a:t>
+              <a:t>\begin{aligned}\dot{\bm r}_L&amp;=\bm v_L\\[4pt]\dot{\bm v}_L&amp;=-\frac{T+D}{m}\bm e_v+\bm g_L\\[4pt]\dot m&amp;=-\frac{f_T T_{B,\mathrm{ref}}}{g_0 I_{sp,B}}\end{aligned}</a:t>
             </a:r>
           </a:p>
           <a:p xmlns:a="http://schemas.openxmlformats.org/drawingml/2006/main">
@@ -1210,7 +1220,7 @@
           </a:p>
           <a:p xmlns:a="http://schemas.openxmlformats.org/drawingml/2006/main">
             <a:r>
-              <a:t>\begin{aligned}0.57&amp;\leq f_T\leq0.8\\[2pt]\Delta t_{\mathrm{entry}}&amp;\geq0.1\ \mathrm{s}\\[2pt]q&amp;\leq75\ \mathrm{kPa}\quad\text{(next descent)}\\[2pt]\dot q_c&amp;\leq110\ \mathrm{kW/m^2}\quad\text{(next descent)}\end{aligned}</a:t>
+              <a:t>\begin{aligned}f_{\mathrm{entry},\min}&amp;\leq f_T\leq f_{\mathrm{entry},\max}\\[2pt]\Delta t_{\mathrm{entry}}&amp;\geq t_{\mathrm{entry},\min}\\[2pt]q&amp;\leq q_{B,\max}\quad\text{(next descent)}\\[2pt]\dot q_c&amp;\leq\dot q_{B,\max}\quad\text{(next descent)}\end{aligned}</a:t>
             </a:r>
           </a:p>
         </p:txBody>
@@ -1280,7 +1290,7 @@
           <a:lstStyle xmlns:a="http://schemas.openxmlformats.org/drawingml/2006/main"/>
           <a:p xmlns:a="http://schemas.openxmlformats.org/drawingml/2006/main">
             <a:r>
-              <a:t>Code checks q and heat at 20 intermediate samples during post-entry coast before landing. This is discrete checking, not a continuous path guarantee. No horizontal lift control is present.</a:t>
+              <a:t>General symbolic formulation based on LaunchVehicleOptimization, implementation snapshot 5295f20211b50467d81eac8f47408673b93e9190. Source: https://github.com/pukmark/LaunchVehicleOptimization/tree/5295f20211b50467d81eac8f47408673b93e9190 . Vehicle properties, engine configurations, phase gates and operational bounds remain input parameters. No Falcon 9 numerical values are assigned.</a:t>
             </a:r>
           </a:p>
           <a:p xmlns:a="http://schemas.openxmlformats.org/drawingml/2006/main">
@@ -1290,7 +1300,7 @@
           </a:p>
           <a:p xmlns:a="http://schemas.openxmlformats.org/drawingml/2006/main">
             <a:r>
-              <a:t>Source: https://github.com/pukmark/LaunchVehicleOptimization/tree/5295f20211b50467d81eac8f47408673b93e9190 . Current default-branch HEAD retrieved October 8, 2026, commit 5295f20 (gui update). Nominal Falcon 9, configuration 1, with unit dispersion factors and zero offsets. Parameter values: LV_Type_scaled.py lines 54–123 and derived initialization 144–151. Phase constraints: LV_Optimization_Type.py lines 125–324. Atmosphere: Atmosphere_Type.py. Values are optimizer inputs. Payload and target orbit remain mission-dependent.</a:t>
+              <a:t>All parameter symbols are configured per vehicle and mission. Mathematical constants, phase indices and state-vector dimensions remain explicit. Phase gates are feasibility constraints rather than necessarily automatic event triggers. SES-2 uses an analytical tangential impulse and propellant reserve. Heat and dynamic-pressure limits are sampled during post-entry descent and landing in the implementation.</a:t>
             </a:r>
           </a:p>
           <a:p xmlns:a="http://schemas.openxmlformats.org/drawingml/2006/main">
@@ -1335,7 +1345,7 @@
           </a:p>
           <a:p xmlns:a="http://schemas.openxmlformats.org/drawingml/2006/main">
             <a:r>
-              <a:t>\begin{aligned}q&amp;\leq75\ \mathrm{kPa}\\[2pt]\dot q_c&amp;\leq110\ \mathrm{kW/m^2}\\[2pt]\Delta t_{\mathrm{descent}}&amp;\geq0.1\ \mathrm{s}\end{aligned}</a:t>
+              <a:t>\begin{aligned}q&amp;\leq q_{B,\max}\\[2pt]\dot q_c&amp;\leq\dot q_{B,\max}\\[2pt]\Delta t_{\mathrm{descent}}&amp;\geq t_{\mathrm{descent},\min}\end{aligned}</a:t>
             </a:r>
           </a:p>
         </p:txBody>
@@ -1405,7 +1415,7 @@
           <a:lstStyle xmlns:a="http://schemas.openxmlformats.org/drawingml/2006/main"/>
           <a:p xmlns:a="http://schemas.openxmlformats.org/drawingml/2006/main">
             <a:r>
-              <a:t>Code caps landing throttle at one third of recovery reference, rather than one third of full ascent thrust. Its lower bound is exactly 0.75*(1/3)*25600*g0/2535000=0.02473728878374703. This is the current optimizer formula. T_B,ref=2.535 MN and g0=9.7982854791873 m/s². The displayed rounded minimum is approximately 62.709 kN. Landing duration timestep &gt;=0.1 s. Return load bounds are sampled at landing nodes. RTLS constrains local launch altitude; ASDS constrains geometric zero altitude. The 10 m/s bound is a simplified energy-feasibility endpoint, not an operational touchdown specification.</a:t>
+              <a:t>General symbolic formulation based on LaunchVehicleOptimization, implementation snapshot 5295f20211b50467d81eac8f47408673b93e9190. Source: https://github.com/pukmark/LaunchVehicleOptimization/tree/5295f20211b50467d81eac8f47408673b93e9190 . Vehicle properties, engine configurations, phase gates and operational bounds remain input parameters. No Falcon 9 numerical values are assigned.</a:t>
             </a:r>
           </a:p>
           <a:p xmlns:a="http://schemas.openxmlformats.org/drawingml/2006/main">
@@ -1415,7 +1425,7 @@
           </a:p>
           <a:p xmlns:a="http://schemas.openxmlformats.org/drawingml/2006/main">
             <a:r>
-              <a:t>Source: https://github.com/pukmark/LaunchVehicleOptimization/tree/5295f20211b50467d81eac8f47408673b93e9190 . Current default-branch HEAD retrieved October 8, 2026, commit 5295f20 (gui update). Nominal Falcon 9, configuration 1, with unit dispersion factors and zero offsets. Parameter values: LV_Type_scaled.py lines 54–123 and derived initialization 144–151. Phase constraints: LV_Optimization_Type.py lines 125–324. Atmosphere: Atmosphere_Type.py. Values are optimizer inputs. Payload and target orbit remain mission-dependent.</a:t>
+              <a:t>All parameter symbols are configured per vehicle and mission. Mathematical constants, phase indices and state-vector dimensions remain explicit. Phase gates are feasibility constraints rather than necessarily automatic event triggers. SES-2 uses an analytical tangential impulse and propellant reserve. Heat and dynamic-pressure limits are sampled during post-entry descent and landing in the implementation.</a:t>
             </a:r>
           </a:p>
           <a:p xmlns:a="http://schemas.openxmlformats.org/drawingml/2006/main">
@@ -1450,7 +1460,7 @@
           </a:p>
           <a:p xmlns:a="http://schemas.openxmlformats.org/drawingml/2006/main">
             <a:r>
-              <a:t>\begin{aligned}\dot{\bm r}_L&amp;=\bm v_L\\[4pt]\dot{\bm v}_L&amp;=-\frac{T+D}{m}\bm e_v+\bm g_L\\[4pt]\dot m&amp;=-\frac{f_T T_{B,\mathrm{ref}}}{g_0(282\ \mathrm{s})}\end{aligned}</a:t>
+              <a:t>\begin{aligned}\dot{\bm r}_L&amp;=\bm v_L\\[4pt]\dot{\bm v}_L&amp;=-\frac{T+D}{m}\bm e_v+\bm g_L\\[4pt]\dot m&amp;=-\frac{f_T T_{B,\mathrm{ref}}}{g_0 I_{sp,B}}\end{aligned}</a:t>
             </a:r>
           </a:p>
           <a:p xmlns:a="http://schemas.openxmlformats.org/drawingml/2006/main">
@@ -1460,7 +1470,7 @@
           </a:p>
           <a:p xmlns:a="http://schemas.openxmlformats.org/drawingml/2006/main">
             <a:r>
-              <a:t>\begin{aligned}0.0247373&amp;\lesssim f_T\leq\tfrac13\\[2pt]q&amp;\leq75\ \mathrm{kPa}\\[2pt]\dot q_c&amp;\leq110\ \mathrm{kW/m^2}\\[2pt]\|\bm v_f\|&amp;\leq10\ \mathrm{m/s}\\[2pt]m_f&amp;\geq m_{B,\mathrm{dry}},\quad h_f=h_{\mathrm{land}}\\[2pt]x_f&amp;=x_{\mathrm{launch}}\quad\text{(RTLS)}\end{aligned}</a:t>
+              <a:t>\begin{aligned}f_{\mathrm{land},\min}&amp;\leq f_T\leq f_{\mathrm{land},\max}\\[2pt]q&amp;\leq q_{B,\max}\\[2pt]\dot q_c&amp;\leq\dot q_{B,\max}\\[2pt]\|\bm v_f\|&amp;\leq V_{\mathrm{land},\max}\\[2pt]m_f&amp;\geq m_{B,\mathrm{dry}},\quad h_f=h_{\mathrm{land}}\\[2pt]x_f&amp;=x_{\mathrm{launch}}\quad\text{(RTLS)}\end{aligned}</a:t>
             </a:r>
           </a:p>
         </p:txBody>
@@ -1530,7 +1540,7 @@
           <a:lstStyle xmlns:a="http://schemas.openxmlformats.org/drawingml/2006/main"/>
           <a:p xmlns:a="http://schemas.openxmlformats.org/drawingml/2006/main">
             <a:r>
-              <a:t>The two branches evolve in parallel after separation. A gate is an admissibility condition, not necessarily an automatic state-triggered event. All phase durations are optimized except the 5 s initial rise and prescribed short coast after stage separation. Entry gate h&gt;=70 km occurs after a coast &gt;=75 s. Nominal fairing gate h&gt;=85 km and fairing mass=1.9 t. SES1 follows a 10 s coast. Separation gate q&lt;=0.5 kPa. SES2 is modeled analytically.</a:t>
+              <a:t>General symbolic formulation based on LaunchVehicleOptimization, implementation snapshot 5295f20211b50467d81eac8f47408673b93e9190. Source: https://github.com/pukmark/LaunchVehicleOptimization/tree/5295f20211b50467d81eac8f47408673b93e9190 . Vehicle properties, engine configurations, phase gates and operational bounds remain input parameters. No Falcon 9 numerical values are assigned.</a:t>
             </a:r>
           </a:p>
           <a:p xmlns:a="http://schemas.openxmlformats.org/drawingml/2006/main">
@@ -1540,7 +1550,7 @@
           </a:p>
           <a:p xmlns:a="http://schemas.openxmlformats.org/drawingml/2006/main">
             <a:r>
-              <a:t>Source: https://github.com/pukmark/LaunchVehicleOptimization/tree/5295f20211b50467d81eac8f47408673b93e9190 . Current default-branch HEAD retrieved October 8, 2026, commit 5295f20 (gui update). Nominal Falcon 9, configuration 1, with unit dispersion factors and zero offsets. Parameter values: LV_Type_scaled.py lines 54–123 and derived initialization 144–151. Phase constraints: LV_Optimization_Type.py lines 125–324. Atmosphere: Atmosphere_Type.py. Values are optimizer inputs. Payload and target orbit remain mission-dependent.</a:t>
+              <a:t>All parameter symbols are configured per vehicle and mission. Mathematical constants, phase indices and state-vector dimensions remain explicit. Phase gates are feasibility constraints rather than necessarily automatic event triggers. SES-2 uses an analytical tangential impulse and propellant reserve. Heat and dynamic-pressure limits are sampled during post-entry descent and landing in the implementation.</a:t>
             </a:r>
           </a:p>
           <a:p xmlns:a="http://schemas.openxmlformats.org/drawingml/2006/main">
@@ -1555,7 +1565,7 @@
           </a:p>
           <a:p xmlns:a="http://schemas.openxmlformats.org/drawingml/2006/main">
             <a:r>
-              <a:t>t_0=5\ \mathrm{s}</a:t>
+              <a:t>t_0=t_{\mathrm{rise}}</a:t>
             </a:r>
           </a:p>
           <a:p xmlns:a="http://schemas.openxmlformats.org/drawingml/2006/main">
@@ -1565,7 +1575,7 @@
           </a:p>
           <a:p xmlns:a="http://schemas.openxmlformats.org/drawingml/2006/main">
             <a:r>
-              <a:t>q\leq30\ \mathrm{kPa},\quad |q\alpha|\leq5\ \mathrm{kPa\,rad}</a:t>
+              <a:t>q\leq q_{1,\max},\quad |q\alpha|\leq(q\alpha)_{\max}</a:t>
             </a:r>
           </a:p>
           <a:p xmlns:a="http://schemas.openxmlformats.org/drawingml/2006/main">
@@ -1575,7 +1585,7 @@
           </a:p>
           <a:p xmlns:a="http://schemas.openxmlformats.org/drawingml/2006/main">
             <a:r>
-              <a:t>q_{\mathrm{sep}}\leq0.5\ \mathrm{kPa};\ \text{split upper stage / booster}</a:t>
+              <a:t>q_{\mathrm{sep}}\leq q_{\mathrm{sep},\max};\ \text{split upper stage / booster}</a:t>
             </a:r>
           </a:p>
           <a:p xmlns:a="http://schemas.openxmlformats.org/drawingml/2006/main">
@@ -1585,7 +1595,7 @@
           </a:p>
           <a:p xmlns:a="http://schemas.openxmlformats.org/drawingml/2006/main">
             <a:r>
-              <a:t>\begin{aligned}h\geq85\ \mathrm{km}\\[2pt]m^+=m^--m_{\mathrm{fairing}}\end{aligned}</a:t>
+              <a:t>\begin{aligned}h\geq h_{\mathrm{fair}}\\[2pt]m^+=m^--m_{\mathrm{fairing}}\end{aligned}</a:t>
             </a:r>
           </a:p>
           <a:p xmlns:a="http://schemas.openxmlformats.org/drawingml/2006/main">
@@ -1595,7 +1605,7 @@
           </a:p>
           <a:p xmlns:a="http://schemas.openxmlformats.org/drawingml/2006/main">
             <a:r>
-              <a:t>\begin{aligned}r_{a,\mathrm{park}}=r_{p,\mathrm{target}}\\[2pt]h_{p,\mathrm{park}}\geq150\ \mathrm{km}\\[2pt]i=i_{\mathrm{target}},\ m\geq m_{\mathrm{reserve}}\end{aligned}</a:t>
+              <a:t>\begin{aligned}r_{a,\mathrm{park}}=r_{p,\mathrm{target}}\\[2pt]h_{p,\mathrm{park}}\geq h_{p,\min}\\[2pt]i=i_{\mathrm{target}},\ m\geq m_{\mathrm{reserve}}\end{aligned}</a:t>
             </a:r>
           </a:p>
           <a:p xmlns:a="http://schemas.openxmlformats.org/drawingml/2006/main">
@@ -1625,7 +1635,7 @@
           </a:p>
           <a:p xmlns:a="http://schemas.openxmlformats.org/drawingml/2006/main">
             <a:r>
-              <a:t>\begin{aligned}\|\bm F_B\|\leq2.742\ \mathrm{MN}\\[2pt]\Delta t_{\mathrm{BB}}\geq1\ \mathrm{s}\end{aligned}</a:t>
+              <a:t>\begin{aligned}\|\bm F_B\|\leq T_{\mathrm{BB},\max}\\[2pt]\Delta t_{\mathrm{BB}}\geq t_{\mathrm{BB},\min}\end{aligned}</a:t>
             </a:r>
           </a:p>
           <a:p xmlns:a="http://schemas.openxmlformats.org/drawingml/2006/main">
@@ -1635,7 +1645,7 @@
           </a:p>
           <a:p xmlns:a="http://schemas.openxmlformats.org/drawingml/2006/main">
             <a:r>
-              <a:t>\begin{aligned}\Delta t_{\mathrm{coast}}\geq75\ \mathrm{s}\\[2pt]h_{\mathrm{entry}}\geq70\ \mathrm{km}\end{aligned}</a:t>
+              <a:t>\begin{aligned}\Delta t_{\mathrm{coast}}\geq t_{\mathrm{coast},\min}\\[2pt]h_{\mathrm{entry}}\geq h_{\mathrm{entry},\min}\end{aligned}</a:t>
             </a:r>
           </a:p>
           <a:p xmlns:a="http://schemas.openxmlformats.org/drawingml/2006/main">
@@ -1645,7 +1655,7 @@
           </a:p>
           <a:p xmlns:a="http://schemas.openxmlformats.org/drawingml/2006/main">
             <a:r>
-              <a:t>\begin{aligned}q\leq75\ \mathrm{kPa}\\[2pt]\dot q_c\leq110\ \mathrm{kW/m^2}\end{aligned}</a:t>
+              <a:t>\begin{aligned}q\leq q_{B,\max}\\[2pt]\dot q_c\leq\dot q_{B,\max}\end{aligned}</a:t>
             </a:r>
           </a:p>
           <a:p xmlns:a="http://schemas.openxmlformats.org/drawingml/2006/main">
@@ -1655,7 +1665,7 @@
           </a:p>
           <a:p xmlns:a="http://schemas.openxmlformats.org/drawingml/2006/main">
             <a:r>
-              <a:t>\begin{aligned}h_f=h_{\mathrm{land}}\\[2pt]\|\bm v_f\|\leq10\ \mathrm{m/s}\\[2pt]m_f\geq m_{B,\mathrm{dry}}\end{aligned}</a:t>
+              <a:t>\begin{aligned}h_f=h_{\mathrm{land}}\\[2pt]\|\bm v_f\|\leq V_{\mathrm{land},\max}\\[2pt]m_f\geq m_{B,\mathrm{dry}}\end{aligned}</a:t>
             </a:r>
           </a:p>
         </p:txBody>
@@ -1725,7 +1735,17 @@
           <a:lstStyle xmlns:a="http://schemas.openxmlformats.org/drawingml/2006/main"/>
           <a:p xmlns:a="http://schemas.openxmlformats.org/drawingml/2006/main">
             <a:r>
-              <a:t>Summary of the current optimization architecture. No historical payload result is asserted as a result of this commit. Source: https://github.com/pukmark/LaunchVehicleOptimization/tree/5295f20211b50467d81eac8f47408673b93e9190 . Current default-branch HEAD retrieved October 8, 2026, commit 5295f20 (gui update). Nominal Falcon 9, configuration 1, with unit dispersion factors and zero offsets. Parameter values: LV_Type_scaled.py lines 54–123 and derived initialization 144–151. Phase constraints: LV_Optimization_Type.py lines 125–324. Atmosphere: Atmosphere_Type.py. Values are optimizer inputs. Payload and target orbit remain mission-dependent.</a:t>
+              <a:t>General symbolic formulation based on LaunchVehicleOptimization, implementation snapshot 5295f20211b50467d81eac8f47408673b93e9190. Source: https://github.com/pukmark/LaunchVehicleOptimization/tree/5295f20211b50467d81eac8f47408673b93e9190 . Vehicle properties, engine configurations, phase gates and operational bounds remain input parameters. No Falcon 9 numerical values are assigned.</a:t>
+            </a:r>
+          </a:p>
+          <a:p xmlns:a="http://schemas.openxmlformats.org/drawingml/2006/main">
+            <a:r>
+              <a:t/>
+            </a:r>
+          </a:p>
+          <a:p xmlns:a="http://schemas.openxmlformats.org/drawingml/2006/main">
+            <a:r>
+              <a:t>All parameter symbols are configured per vehicle and mission. Mathematical constants, phase indices and state-vector dimensions remain explicit. Phase gates are feasibility constraints rather than necessarily automatic event triggers. SES-2 uses an analytical tangential impulse and propellant reserve. Heat and dynamic-pressure limits are sampled during post-entry descent and landing in the implementation.</a:t>
             </a:r>
           </a:p>
         </p:txBody>
@@ -1795,7 +1815,7 @@
           <a:lstStyle xmlns:a="http://schemas.openxmlformats.org/drawingml/2006/main"/>
           <a:p xmlns:a="http://schemas.openxmlformats.org/drawingml/2006/main">
             <a:r>
-              <a:t>Active code equations: LV_Type_scaled.py lines 356–372 and 431–439. Ascent mass flow uses the vacuum reference Isp, not the diagnostic Isp_calc output. Upper-stage Isp varies from 339.3 s at minimum throttle to 348 s at full throttle. g0 is computed as mu / R0^2.</a:t>
+              <a:t>General symbolic formulation based on LaunchVehicleOptimization, implementation snapshot 5295f20211b50467d81eac8f47408673b93e9190. Source: https://github.com/pukmark/LaunchVehicleOptimization/tree/5295f20211b50467d81eac8f47408673b93e9190 . Vehicle properties, engine configurations, phase gates and operational bounds remain input parameters. No Falcon 9 numerical values are assigned.</a:t>
             </a:r>
           </a:p>
           <a:p xmlns:a="http://schemas.openxmlformats.org/drawingml/2006/main">
@@ -1805,7 +1825,7 @@
           </a:p>
           <a:p xmlns:a="http://schemas.openxmlformats.org/drawingml/2006/main">
             <a:r>
-              <a:t>Source: https://github.com/pukmark/LaunchVehicleOptimization/tree/5295f20211b50467d81eac8f47408673b93e9190 . Current default-branch HEAD retrieved October 8, 2026, commit 5295f20 (gui update). Nominal Falcon 9, configuration 1, with unit dispersion factors and zero offsets. Parameter values: LV_Type_scaled.py lines 54–123 and derived initialization 144–151. Phase constraints: LV_Optimization_Type.py lines 125–324. Atmosphere: Atmosphere_Type.py. Values are optimizer inputs. Payload and target orbit remain mission-dependent.</a:t>
+              <a:t>All parameter symbols are configured per vehicle and mission. Mathematical constants, phase indices and state-vector dimensions remain explicit. Phase gates are feasibility constraints rather than necessarily automatic event triggers. SES-2 uses an analytical tangential impulse and propellant reserve. Heat and dynamic-pressure limits are sampled during post-entry descent and landing in the implementation.</a:t>
             </a:r>
           </a:p>
           <a:p xmlns:a="http://schemas.openxmlformats.org/drawingml/2006/main">
@@ -1820,7 +1840,7 @@
           </a:p>
           <a:p xmlns:a="http://schemas.openxmlformats.org/drawingml/2006/main">
             <a:r>
-              <a:t>\begin{aligned}T_1 &amp;= f_T\left[T_{1,\mathrm{vac}}-(T_{1,\mathrm{vac}}-T_{1,\mathrm{SL}})\frac{p_a}{p_0}\right]\\[9pt]\dot m_1&amp;=-\frac{f_TT_{1,\mathrm{vac}}}{g_0I_{sp,1,\mathrm{vac}}}\\[9pt]\dot m_2&amp;=-\frac{\|\bm F\|}{g_0I_{sp,2}(f_T)}\\[9pt]I_{sp,2}(f_T)&amp;=348\left[0.975+0.025\frac{f_T-0.638}{1-0.638}\right]\ \mathrm{s}\end{aligned}</a:t>
+              <a:t>\begin{aligned}T_1 &amp;= f_T\left[T_{1,\mathrm{vac}}-(T_{1,\mathrm{vac}}-T_{1,\mathrm{SL}})\frac{p_a}{p_0}\right]\\[9pt]\dot m_1&amp;=-\frac{f_TT_{1,\mathrm{vac}}}{g_0I_{sp,1,\mathrm{vac}}}\\[9pt]\dot m_2&amp;=-\frac{\|\bm F\|}{g_0I_{sp,2}(f_T)}\\[9pt]I_{sp,2}(f_T)&amp;=I_{sp,2,\max}\left[\eta_{2,\min}+(1-\eta_{2,\min})\frac{f_T-f_{2,\min}}{1-f_{2,\min}}\right]\end{aligned}</a:t>
             </a:r>
           </a:p>
         </p:txBody>
@@ -1890,7 +1910,7 @@
           <a:lstStyle xmlns:a="http://schemas.openxmlformats.org/drawingml/2006/main"/>
           <a:p xmlns:a="http://schemas.openxmlformats.org/drawingml/2006/main">
             <a:r>
-              <a:t>Code initializes second stage and recovery branch at separation and applies fairing mass jump. m2,wet includes attached fairing.</a:t>
+              <a:t>General symbolic formulation based on LaunchVehicleOptimization, implementation snapshot 5295f20211b50467d81eac8f47408673b93e9190. Source: https://github.com/pukmark/LaunchVehicleOptimization/tree/5295f20211b50467d81eac8f47408673b93e9190 . Vehicle properties, engine configurations, phase gates and operational bounds remain input parameters. No Falcon 9 numerical values are assigned.</a:t>
             </a:r>
           </a:p>
           <a:p xmlns:a="http://schemas.openxmlformats.org/drawingml/2006/main">
@@ -1900,7 +1920,7 @@
           </a:p>
           <a:p xmlns:a="http://schemas.openxmlformats.org/drawingml/2006/main">
             <a:r>
-              <a:t>Source: https://github.com/pukmark/LaunchVehicleOptimization/tree/5295f20211b50467d81eac8f47408673b93e9190 . Current default-branch HEAD retrieved October 8, 2026, commit 5295f20 (gui update). Nominal Falcon 9, configuration 1, with unit dispersion factors and zero offsets. Parameter values: LV_Type_scaled.py lines 54–123 and derived initialization 144–151. Phase constraints: LV_Optimization_Type.py lines 125–324. Atmosphere: Atmosphere_Type.py. Values are optimizer inputs. Payload and target orbit remain mission-dependent.</a:t>
+              <a:t>All parameter symbols are configured per vehicle and mission. Mathematical constants, phase indices and state-vector dimensions remain explicit. Phase gates are feasibility constraints rather than necessarily automatic event triggers. SES-2 uses an analytical tangential impulse and propellant reserve. Heat and dynamic-pressure limits are sampled during post-entry descent and landing in the implementation.</a:t>
             </a:r>
           </a:p>
           <a:p xmlns:a="http://schemas.openxmlformats.org/drawingml/2006/main">
@@ -1985,7 +2005,7 @@
           <a:lstStyle xmlns:a="http://schemas.openxmlformats.org/drawingml/2006/main"/>
           <a:p xmlns:a="http://schemas.openxmlformats.org/drawingml/2006/main">
             <a:r>
-              <a:t>Active code uses constant CD0=0.5, Cda2=3.0 and CLa=0.5 rather than a Mach-dependent drag fit. Return uses CD0=1.6. LV_Type_scaled.py lines 79–96, 150, 356–357, 554–558. Positive lift convention is normal to velocity, en=[-sin gamma,cos gamma].</a:t>
+              <a:t>General symbolic formulation based on LaunchVehicleOptimization, implementation snapshot 5295f20211b50467d81eac8f47408673b93e9190. Source: https://github.com/pukmark/LaunchVehicleOptimization/tree/5295f20211b50467d81eac8f47408673b93e9190 . Vehicle properties, engine configurations, phase gates and operational bounds remain input parameters. No Falcon 9 numerical values are assigned.</a:t>
             </a:r>
           </a:p>
           <a:p xmlns:a="http://schemas.openxmlformats.org/drawingml/2006/main">
@@ -1995,7 +2015,7 @@
           </a:p>
           <a:p xmlns:a="http://schemas.openxmlformats.org/drawingml/2006/main">
             <a:r>
-              <a:t>Source: https://github.com/pukmark/LaunchVehicleOptimization/tree/5295f20211b50467d81eac8f47408673b93e9190 . Current default-branch HEAD retrieved October 8, 2026, commit 5295f20 (gui update). Nominal Falcon 9, configuration 1, with unit dispersion factors and zero offsets. Parameter values: LV_Type_scaled.py lines 54–123 and derived initialization 144–151. Phase constraints: LV_Optimization_Type.py lines 125–324. Atmosphere: Atmosphere_Type.py. Values are optimizer inputs. Payload and target orbit remain mission-dependent.</a:t>
+              <a:t>All parameter symbols are configured per vehicle and mission. Mathematical constants, phase indices and state-vector dimensions remain explicit. Phase gates are feasibility constraints rather than necessarily automatic event triggers. SES-2 uses an analytical tangential impulse and propellant reserve. Heat and dynamic-pressure limits are sampled during post-entry descent and landing in the implementation.</a:t>
             </a:r>
           </a:p>
           <a:p xmlns:a="http://schemas.openxmlformats.org/drawingml/2006/main">
@@ -2010,7 +2030,7 @@
           </a:p>
           <a:p xmlns:a="http://schemas.openxmlformats.org/drawingml/2006/main">
             <a:r>
-              <a:t>\begin{aligned}q&amp;=\tfrac12\rho(h)V^2\\[9pt]L&amp;=qS(0.5)\alpha\\[9pt]D&amp;=qS\left[0.5+3.0\alpha^2\right]\\[9pt]D_B&amp;=qS(1.6)\\[9pt]|q\alpha|&amp;\leq5\ \mathrm{kPa\,rad}\end{aligned}</a:t>
+              <a:t>\begin{aligned}q&amp;=\tfrac12\rho(h)V^2\\[9pt]L&amp;=qS C_{L_\alpha}\alpha\\[9pt]D&amp;=qS\left[C_{D_0}+C_{D_{\alpha^2}}\alpha^2\right]\\[9pt]D_B&amp;=qS C_{D,B}\\[9pt]|q\alpha|&amp;\leq(q\alpha)_{\max}\end{aligned}</a:t>
             </a:r>
           </a:p>
           <a:p xmlns:a="http://schemas.openxmlformats.org/drawingml/2006/main">
@@ -2090,7 +2110,7 @@
           <a:lstStyle xmlns:a="http://schemas.openxmlformats.org/drawingml/2006/main"/>
           <a:p xmlns:a="http://schemas.openxmlformats.org/drawingml/2006/main">
             <a:r>
-              <a:t>Atmosphere_Type.py lines 32–84 supplies tabulated altitude values from 0 to 1000 km. Density and pressure use log-linear interpolation, sound speed uses linear interpolation.</a:t>
+              <a:t>General symbolic formulation based on LaunchVehicleOptimization, implementation snapshot 5295f20211b50467d81eac8f47408673b93e9190. Source: https://github.com/pukmark/LaunchVehicleOptimization/tree/5295f20211b50467d81eac8f47408673b93e9190 . Vehicle properties, engine configurations, phase gates and operational bounds remain input parameters. No Falcon 9 numerical values are assigned.</a:t>
             </a:r>
           </a:p>
           <a:p xmlns:a="http://schemas.openxmlformats.org/drawingml/2006/main">
@@ -2100,7 +2120,7 @@
           </a:p>
           <a:p xmlns:a="http://schemas.openxmlformats.org/drawingml/2006/main">
             <a:r>
-              <a:t>Source: https://github.com/pukmark/LaunchVehicleOptimization/tree/5295f20211b50467d81eac8f47408673b93e9190 . Current default-branch HEAD retrieved October 8, 2026, commit 5295f20 (gui update). Nominal Falcon 9, configuration 1, with unit dispersion factors and zero offsets. Parameter values: LV_Type_scaled.py lines 54–123 and derived initialization 144–151. Phase constraints: LV_Optimization_Type.py lines 125–324. Atmosphere: Atmosphere_Type.py. Values are optimizer inputs. Payload and target orbit remain mission-dependent.</a:t>
+              <a:t>All parameter symbols are configured per vehicle and mission. Mathematical constants, phase indices and state-vector dimensions remain explicit. Phase gates are feasibility constraints rather than necessarily automatic event triggers. SES-2 uses an analytical tangential impulse and propellant reserve. Heat and dynamic-pressure limits are sampled during post-entry descent and landing in the implementation.</a:t>
             </a:r>
           </a:p>
           <a:p xmlns:a="http://schemas.openxmlformats.org/drawingml/2006/main">
@@ -2185,7 +2205,7 @@
           <a:lstStyle xmlns:a="http://schemas.openxmlformats.org/drawingml/2006/main"/>
           <a:p xmlns:a="http://schemas.openxmlformats.org/drawingml/2006/main">
             <a:r>
-              <a:t>Paper Sections 4.1 and 4.4. z is up at the surface-origin local frame. Vector gravity avoids inconsistent signs in printed component expressions.</a:t>
+              <a:t>General symbolic formulation based on LaunchVehicleOptimization, implementation snapshot 5295f20211b50467d81eac8f47408673b93e9190. Source: https://github.com/pukmark/LaunchVehicleOptimization/tree/5295f20211b50467d81eac8f47408673b93e9190 . Vehicle properties, engine configurations, phase gates and operational bounds remain input parameters. No Falcon 9 numerical values are assigned.</a:t>
             </a:r>
           </a:p>
           <a:p xmlns:a="http://schemas.openxmlformats.org/drawingml/2006/main">
@@ -2195,7 +2215,7 @@
           </a:p>
           <a:p xmlns:a="http://schemas.openxmlformats.org/drawingml/2006/main">
             <a:r>
-              <a:t>Source: https://github.com/pukmark/LaunchVehicleOptimization/tree/5295f20211b50467d81eac8f47408673b93e9190 . Current default-branch HEAD retrieved October 8, 2026, commit 5295f20 (gui update). Nominal Falcon 9, configuration 1, with unit dispersion factors and zero offsets. Parameter values: LV_Type_scaled.py lines 54–123 and derived initialization 144–151. Phase constraints: LV_Optimization_Type.py lines 125–324. Atmosphere: Atmosphere_Type.py. Values are optimizer inputs. Payload and target orbit remain mission-dependent.</a:t>
+              <a:t>All parameter symbols are configured per vehicle and mission. Mathematical constants, phase indices and state-vector dimensions remain explicit. Phase gates are feasibility constraints rather than necessarily automatic event triggers. SES-2 uses an analytical tangential impulse and propellant reserve. Heat and dynamic-pressure limits are sampled during post-entry descent and landing in the implementation.</a:t>
             </a:r>
           </a:p>
           <a:p xmlns:a="http://schemas.openxmlformats.org/drawingml/2006/main">
@@ -2280,7 +2300,7 @@
           <a:lstStyle xmlns:a="http://schemas.openxmlformats.org/drawingml/2006/main"/>
           <a:p xmlns:a="http://schemas.openxmlformats.org/drawingml/2006/main">
             <a:r>
-              <a:t>LV_Type_scaled.py lines 94–96 and 581–582. Heat-flux units are W/m² as used by VehicleDefinitions.py, despite the older Pa comment on the field. Code samples return constraints during post-entry descent and landing, not continuously throughout all recovery segments.</a:t>
+              <a:t>General symbolic formulation based on LaunchVehicleOptimization, implementation snapshot 5295f20211b50467d81eac8f47408673b93e9190. Source: https://github.com/pukmark/LaunchVehicleOptimization/tree/5295f20211b50467d81eac8f47408673b93e9190 . Vehicle properties, engine configurations, phase gates and operational bounds remain input parameters. No Falcon 9 numerical values are assigned.</a:t>
             </a:r>
           </a:p>
           <a:p xmlns:a="http://schemas.openxmlformats.org/drawingml/2006/main">
@@ -2290,7 +2310,7 @@
           </a:p>
           <a:p xmlns:a="http://schemas.openxmlformats.org/drawingml/2006/main">
             <a:r>
-              <a:t>Source: https://github.com/pukmark/LaunchVehicleOptimization/tree/5295f20211b50467d81eac8f47408673b93e9190 . Current default-branch HEAD retrieved October 8, 2026, commit 5295f20 (gui update). Nominal Falcon 9, configuration 1, with unit dispersion factors and zero offsets. Parameter values: LV_Type_scaled.py lines 54–123 and derived initialization 144–151. Phase constraints: LV_Optimization_Type.py lines 125–324. Atmosphere: Atmosphere_Type.py. Values are optimizer inputs. Payload and target orbit remain mission-dependent.</a:t>
+              <a:t>All parameter symbols are configured per vehicle and mission. Mathematical constants, phase indices and state-vector dimensions remain explicit. Phase gates are feasibility constraints rather than necessarily automatic event triggers. SES-2 uses an analytical tangential impulse and propellant reserve. Heat and dynamic-pressure limits are sampled during post-entry descent and landing in the implementation.</a:t>
             </a:r>
           </a:p>
           <a:p xmlns:a="http://schemas.openxmlformats.org/drawingml/2006/main">
@@ -2305,7 +2325,7 @@
           </a:p>
           <a:p xmlns:a="http://schemas.openxmlformats.org/drawingml/2006/main">
             <a:r>
-              <a:t>\begin{aligned}\dot q_c&amp;=\kappa\sqrt{\rho}\,V^3\\[9pt]\dot q_c&amp;\leq\dot q_{B,\max}\\[9pt]q&amp;\leq q_{B,\max}\\[9pt]\dot q_{B,\max}&amp;=110\ \mathrm{kW/m^2}\\[9pt]q_{B,\max}&amp;=75\ \mathrm{kPa}\end{aligned}</a:t>
+              <a:t>\begin{aligned}\dot q_c&amp;=\kappa\sqrt{\rho}\,V^3\\[9pt]\dot q_c&amp;\leq\dot q_{B,\max}\\[9pt]q&amp;\leq q_{B,\max}\end{aligned}</a:t>
             </a:r>
           </a:p>
         </p:txBody>
@@ -2375,7 +2395,7 @@
           <a:lstStyle xmlns:a="http://schemas.openxmlformats.org/drawingml/2006/main"/>
           <a:p xmlns:a="http://schemas.openxmlformats.org/drawingml/2006/main">
             <a:r>
-              <a:t>eT=[cos(gamma+alpha),sin(gamma+alpha)], ev=[cos gamma,sin gamma], en=[-sin gamma,cos gamma]. gamma=atan2(vz,vx). Nominal limits from current GitHub VLType defaults. The payload acceleration field is exactly 3.75*9.81=36.7875 m/s², while dynamics g0=mu/R0²=9.7982854791873 m/s². Maximum alpha=0.1745 rad (9.9981°). a_load is the specific-force/load metric used in the implementation, not net inertial acceleration. The conventional positive-normal lift resolves a printed lift-sign inconsistency. The optimizer input order is throttle then angle. The lower mass limit and coupled recovery branch preserve booster dry mass.</a:t>
+              <a:t>General symbolic formulation based on LaunchVehicleOptimization, implementation snapshot 5295f20211b50467d81eac8f47408673b93e9190. Source: https://github.com/pukmark/LaunchVehicleOptimization/tree/5295f20211b50467d81eac8f47408673b93e9190 . Vehicle properties, engine configurations, phase gates and operational bounds remain input parameters. No Falcon 9 numerical values are assigned.</a:t>
             </a:r>
           </a:p>
           <a:p xmlns:a="http://schemas.openxmlformats.org/drawingml/2006/main">
@@ -2385,7 +2405,7 @@
           </a:p>
           <a:p xmlns:a="http://schemas.openxmlformats.org/drawingml/2006/main">
             <a:r>
-              <a:t>Source: https://github.com/pukmark/LaunchVehicleOptimization/tree/5295f20211b50467d81eac8f47408673b93e9190 . Current default-branch HEAD retrieved October 8, 2026, commit 5295f20 (gui update). Nominal Falcon 9, configuration 1, with unit dispersion factors and zero offsets. Parameter values: LV_Type_scaled.py lines 54–123 and derived initialization 144–151. Phase constraints: LV_Optimization_Type.py lines 125–324. Atmosphere: Atmosphere_Type.py. Values are optimizer inputs. Payload and target orbit remain mission-dependent.</a:t>
+              <a:t>All parameter symbols are configured per vehicle and mission. Mathematical constants, phase indices and state-vector dimensions remain explicit. Phase gates are feasibility constraints rather than necessarily automatic event triggers. SES-2 uses an analytical tangential impulse and propellant reserve. Heat and dynamic-pressure limits are sampled during post-entry descent and landing in the implementation.</a:t>
             </a:r>
           </a:p>
           <a:p xmlns:a="http://schemas.openxmlformats.org/drawingml/2006/main">
@@ -2440,7 +2460,7 @@
           </a:p>
           <a:p xmlns:a="http://schemas.openxmlformats.org/drawingml/2006/main">
             <a:r>
-              <a:t>\begin{aligned}q&amp;\leq30\ \mathrm{kPa}\\[2pt]|q\alpha|&amp;\leq5\ \mathrm{kPa\,rad}\\[2pt]a_{\mathrm{load}}&amp;\leq36.7875\ \mathrm{m/s^2},\quad |\alpha|\leq0.1745\ \mathrm{rad}\\[2pt]0.57&amp;\leq f_T\leq1\\[2pt]q(t_{\mathrm{sep}})&amp;\leq0.5\ \mathrm{kPa}\end{aligned}</a:t>
+              <a:t>\begin{aligned}q&amp;\leq q_{1,\max}\\[2pt]|q\alpha|&amp;\leq(q\alpha)_{\max}\\[2pt]a_{\mathrm{load}}&amp;\leq a_{\max},\quad |\alpha|\leq\alpha_{\max}\\[2pt]f_{1,\min}&amp;\leq f_T\leq1\\[2pt]q(t_{\mathrm{sep}})&amp;\leq q_{\mathrm{sep},\max}\end{aligned}</a:t>
             </a:r>
           </a:p>
         </p:txBody>
@@ -2510,7 +2530,7 @@
           <a:lstStyle xmlns:a="http://schemas.openxmlformats.org/drawingml/2006/main"/>
           <a:p xmlns:a="http://schemas.openxmlformats.org/drawingml/2006/main">
             <a:r>
-              <a:t>Code Phase 2. The paper describes a dynamic-pressure release condition, while this supplied implementation constrains altitude. Nominal configuration 1 uses hfair=85 km, fairing mass=1900 kg and post-separation coast=10 s. Numerical propulsion input T2,vac=981 kN and Isp2=348 s appear in the paper but are not required to define this phase.</a:t>
+              <a:t>General symbolic formulation based on LaunchVehicleOptimization, implementation snapshot 5295f20211b50467d81eac8f47408673b93e9190. Source: https://github.com/pukmark/LaunchVehicleOptimization/tree/5295f20211b50467d81eac8f47408673b93e9190 . Vehicle properties, engine configurations, phase gates and operational bounds remain input parameters. No Falcon 9 numerical values are assigned.</a:t>
             </a:r>
           </a:p>
           <a:p xmlns:a="http://schemas.openxmlformats.org/drawingml/2006/main">
@@ -2520,7 +2540,7 @@
           </a:p>
           <a:p xmlns:a="http://schemas.openxmlformats.org/drawingml/2006/main">
             <a:r>
-              <a:t>Source: https://github.com/pukmark/LaunchVehicleOptimization/tree/5295f20211b50467d81eac8f47408673b93e9190 . Current default-branch HEAD retrieved October 8, 2026, commit 5295f20 (gui update). Nominal Falcon 9, configuration 1, with unit dispersion factors and zero offsets. Parameter values: LV_Type_scaled.py lines 54–123 and derived initialization 144–151. Phase constraints: LV_Optimization_Type.py lines 125–324. Atmosphere: Atmosphere_Type.py. Values are optimizer inputs. Payload and target orbit remain mission-dependent.</a:t>
+              <a:t>All parameter symbols are configured per vehicle and mission. Mathematical constants, phase indices and state-vector dimensions remain explicit. Phase gates are feasibility constraints rather than necessarily automatic event triggers. SES-2 uses an analytical tangential impulse and propellant reserve. Heat and dynamic-pressure limits are sampled during post-entry descent and landing in the implementation.</a:t>
             </a:r>
           </a:p>
           <a:p xmlns:a="http://schemas.openxmlformats.org/drawingml/2006/main">
@@ -2565,7 +2585,7 @@
           </a:p>
           <a:p xmlns:a="http://schemas.openxmlformats.org/drawingml/2006/main">
             <a:r>
-              <a:t>\begin{aligned}625.878\ \mathrm{kN}&amp;\leq\|\bm F\|\leq981\ \mathrm{kN}\\[2pt]h(t_{\mathrm{fair}})&amp;\geq85\ \mathrm{km}\\[2pt]\bm r^+&amp;=\bm r^-,\quad\bm v^+=\bm v^-\\[2pt]m^+&amp;=m^--m_{\mathrm{fairing}}\end{aligned}</a:t>
+              <a:t>\begin{aligned}T_{2,\min}&amp;\leq\|\bm F\|\leq T_{2,\max}\\[2pt]h(t_{\mathrm{fair}})&amp;\geq h_{\mathrm{fair}}\\[2pt]\bm r^+&amp;=\bm r^-,\quad\bm v^+=\bm v^-\\[2pt]m^+&amp;=m^--m_{\mathrm{fairing}}\end{aligned}</a:t>
             </a:r>
           </a:p>
         </p:txBody>
@@ -4378,12 +4398,12 @@
   </p:cSld>
   <p:clrMap bg1="lt1" tx1="dk1" bg2="lt2" tx2="dk2" accent1="accent1" accent2="accent2" accent3="accent3" accent4="accent4" accent5="accent5" accent6="accent6" hlink="hlink" folHlink="folHlink"/>
   <p:sldLayoutIdLst>
-    <p:sldLayoutId xmlns:r="http://schemas.openxmlformats.org/officeDocument/2006/relationships" id="2147483649" r:id="R50bfffb358e74bf1"/>
-    <p:sldLayoutId xmlns:r="http://schemas.openxmlformats.org/officeDocument/2006/relationships" id="2147483650" r:id="Rb6bbae94cf504cb4"/>
-    <p:sldLayoutId xmlns:r="http://schemas.openxmlformats.org/officeDocument/2006/relationships" id="2147483651" r:id="R4bf72be1b6e74156"/>
-    <p:sldLayoutId xmlns:r="http://schemas.openxmlformats.org/officeDocument/2006/relationships" id="2147483652" r:id="R5c81c63f395e43d1"/>
-    <p:sldLayoutId xmlns:r="http://schemas.openxmlformats.org/officeDocument/2006/relationships" id="2147483653" r:id="Rf06168ab59e5431a"/>
-    <p:sldLayoutId xmlns:r="http://schemas.openxmlformats.org/officeDocument/2006/relationships" id="2147483654" r:id="R87bd7188c3254ba3"/>
+    <p:sldLayoutId xmlns:r="http://schemas.openxmlformats.org/officeDocument/2006/relationships" id="2147483649" r:id="Ra540ab8d1b874f85"/>
+    <p:sldLayoutId xmlns:r="http://schemas.openxmlformats.org/officeDocument/2006/relationships" id="2147483650" r:id="R11c5ffc8ecae4157"/>
+    <p:sldLayoutId xmlns:r="http://schemas.openxmlformats.org/officeDocument/2006/relationships" id="2147483651" r:id="Raf652c16cd77430c"/>
+    <p:sldLayoutId xmlns:r="http://schemas.openxmlformats.org/officeDocument/2006/relationships" id="2147483652" r:id="R68f6473d4a99411a"/>
+    <p:sldLayoutId xmlns:r="http://schemas.openxmlformats.org/officeDocument/2006/relationships" id="2147483653" r:id="R1f5d1eedffe34d7a"/>
+    <p:sldLayoutId xmlns:r="http://schemas.openxmlformats.org/officeDocument/2006/relationships" id="2147483654" r:id="Rdce38a103624404c"/>
   </p:sldLayoutIdLst>
   <p:txStyles>
     <p:titleStyle>
@@ -5149,7 +5169,7 @@
                 <a:ea typeface="DejaVu Sans"/>
                 <a:cs typeface="DejaVu Sans"/>
               </a:rPr>
-              <a:t>Falcon 9 case study</a:t>
+              <a:t>General launch vehicle formulation</a:t>
             </a:r>
           </a:p>
         </p:txBody>
@@ -5317,7 +5337,7 @@
           <p:cNvPr id="7" name="">
             <a:extLst xmlns:a="http://schemas.openxmlformats.org/drawingml/2006/main">
               <a:ext uri="{FF2B5EF4-FFF2-40B4-BE49-F238E27FC236}">
-                <a16:creationId xmlns:a16="http://schemas.microsoft.com/office/drawing/2014/main" id="{B592BDD1-179B-46B0-BB4B-285CCACD0390}"/>
+                <a16:creationId xmlns:a16="http://schemas.microsoft.com/office/drawing/2014/main" id="{66D71AF1-8B59-4386-802F-5FC689F06EEB}"/>
               </a:ext>
             </a:extLst>
           </p:cNvPr>
@@ -5412,7 +5432,7 @@
           <p:cNvPr id="13" name="">
             <a:extLst xmlns:a="http://schemas.openxmlformats.org/drawingml/2006/main">
               <a:ext uri="{FF2B5EF4-FFF2-40B4-BE49-F238E27FC236}">
-                <a16:creationId xmlns:a16="http://schemas.microsoft.com/office/drawing/2014/main" id="{F9C86F10-E3B9-4D11-8CAD-FF344DFF1A80}"/>
+                <a16:creationId xmlns:a16="http://schemas.microsoft.com/office/drawing/2014/main" id="{EA1337E4-D4CB-431A-97C1-B0D5B327BF01}"/>
               </a:ext>
             </a:extLst>
           </p:cNvPr>
@@ -5478,7 +5498,7 @@
           <p:cNvPr id="2" name="">
             <a:extLst xmlns:a="http://schemas.openxmlformats.org/drawingml/2006/main">
               <a:ext uri="{FF2B5EF4-FFF2-40B4-BE49-F238E27FC236}">
-                <a16:creationId xmlns:a16="http://schemas.microsoft.com/office/drawing/2014/main" id="{371D4A3F-D3C3-4BA4-A666-832E4BC6FB6E}"/>
+                <a16:creationId xmlns:a16="http://schemas.microsoft.com/office/drawing/2014/main" id="{1F3FC4EF-BFE3-46B2-98D6-F3571AD515AF}"/>
               </a:ext>
             </a:extLst>
           </p:cNvPr>
@@ -5544,7 +5564,7 @@
           <p:cNvPr id="3" name="">
             <a:extLst xmlns:a="http://schemas.openxmlformats.org/drawingml/2006/main">
               <a:ext uri="{FF2B5EF4-FFF2-40B4-BE49-F238E27FC236}">
-                <a16:creationId xmlns:a16="http://schemas.microsoft.com/office/drawing/2014/main" id="{1BC22C51-2452-4041-AC88-6ADDFDCE489D}"/>
+                <a16:creationId xmlns:a16="http://schemas.microsoft.com/office/drawing/2014/main" id="{7FA14575-6AD7-4DDC-A017-C016B37C1957}"/>
               </a:ext>
             </a:extLst>
           </p:cNvPr>
@@ -5610,7 +5630,7 @@
           <p:cNvPr id="4" name="">
             <a:extLst xmlns:a="http://schemas.openxmlformats.org/drawingml/2006/main">
               <a:ext uri="{FF2B5EF4-FFF2-40B4-BE49-F238E27FC236}">
-                <a16:creationId xmlns:a16="http://schemas.microsoft.com/office/drawing/2014/main" id="{138FB944-C1AB-42C0-B1D5-6623637364C1}"/>
+                <a16:creationId xmlns:a16="http://schemas.microsoft.com/office/drawing/2014/main" id="{A5162449-36CA-41B1-A5B9-A42DD997A5E9}"/>
               </a:ext>
             </a:extLst>
           </p:cNvPr>
@@ -5676,7 +5696,7 @@
           <p:cNvPr id="5" name="">
             <a:extLst xmlns:a="http://schemas.openxmlformats.org/drawingml/2006/main">
               <a:ext uri="{FF2B5EF4-FFF2-40B4-BE49-F238E27FC236}">
-                <a16:creationId xmlns:a16="http://schemas.microsoft.com/office/drawing/2014/main" id="{82317F9E-E03F-4FA5-B146-4D308CFCDA08}"/>
+                <a16:creationId xmlns:a16="http://schemas.microsoft.com/office/drawing/2014/main" id="{1D7D6631-DE0E-4C7A-970B-24E0094D83B2}"/>
               </a:ext>
             </a:extLst>
           </p:cNvPr>
@@ -5742,7 +5762,7 @@
           <p:cNvPr id="6" name="">
             <a:extLst xmlns:a="http://schemas.openxmlformats.org/drawingml/2006/main">
               <a:ext uri="{FF2B5EF4-FFF2-40B4-BE49-F238E27FC236}">
-                <a16:creationId xmlns:a16="http://schemas.microsoft.com/office/drawing/2014/main" id="{211D1DF7-27FA-408B-8C42-C2970042B65F}"/>
+                <a16:creationId xmlns:a16="http://schemas.microsoft.com/office/drawing/2014/main" id="{D75CB72C-5B78-4FAC-B46F-3E1614E3D867}"/>
               </a:ext>
             </a:extLst>
           </p:cNvPr>
@@ -5808,7 +5828,7 @@
           <p:cNvPr id="7" name="">
             <a:extLst xmlns:a="http://schemas.openxmlformats.org/drawingml/2006/main">
               <a:ext uri="{FF2B5EF4-FFF2-40B4-BE49-F238E27FC236}">
-                <a16:creationId xmlns:a16="http://schemas.microsoft.com/office/drawing/2014/main" id="{9D8661F5-F8DC-4CFB-8FE3-D5B137925E42}"/>
+                <a16:creationId xmlns:a16="http://schemas.microsoft.com/office/drawing/2014/main" id="{7FA9358D-D3F3-4B1D-8698-FE3F182DC638}"/>
               </a:ext>
             </a:extLst>
           </p:cNvPr>
@@ -5874,7 +5894,7 @@
           <p:cNvPr id="8" name="">
             <a:extLst xmlns:a="http://schemas.openxmlformats.org/drawingml/2006/main">
               <a:ext uri="{FF2B5EF4-FFF2-40B4-BE49-F238E27FC236}">
-                <a16:creationId xmlns:a16="http://schemas.microsoft.com/office/drawing/2014/main" id="{6D656D83-5B9E-4592-81C7-C14362F7E875}"/>
+                <a16:creationId xmlns:a16="http://schemas.microsoft.com/office/drawing/2014/main" id="{DE843D1F-101A-4C00-AD9E-2AEECFCCAA3F}"/>
               </a:ext>
             </a:extLst>
           </p:cNvPr>
@@ -5940,7 +5960,7 @@
           <p:cNvPr id="9" name="">
             <a:extLst xmlns:a="http://schemas.openxmlformats.org/drawingml/2006/main">
               <a:ext uri="{FF2B5EF4-FFF2-40B4-BE49-F238E27FC236}">
-                <a16:creationId xmlns:a16="http://schemas.microsoft.com/office/drawing/2014/main" id="{48C52FAE-9F2F-477E-ACD5-E4FC45F49207}"/>
+                <a16:creationId xmlns:a16="http://schemas.microsoft.com/office/drawing/2014/main" id="{B2E4A89A-37AB-46C6-B56E-66EA1B6C5565}"/>
               </a:ext>
             </a:extLst>
           </p:cNvPr>
@@ -5950,7 +5970,7 @@
           <p:nvPr/>
         </p:nvPicPr>
         <p:blipFill>
-          <a:blip xmlns:r="http://schemas.openxmlformats.org/officeDocument/2006/relationships" xmlns:a="http://schemas.openxmlformats.org/drawingml/2006/main" r:embed="R1a02e0175ba14d31"/>
+          <a:blip xmlns:r="http://schemas.openxmlformats.org/officeDocument/2006/relationships" xmlns:a="http://schemas.openxmlformats.org/drawingml/2006/main" r:embed="R88955cfb00474670"/>
           <a:stretch xmlns:a="http://schemas.openxmlformats.org/drawingml/2006/main"/>
         </p:blipFill>
         <p:spPr>
@@ -5968,7 +5988,7 @@
           <p:cNvPr id="10" name="">
             <a:extLst xmlns:a="http://schemas.openxmlformats.org/drawingml/2006/main">
               <a:ext uri="{FF2B5EF4-FFF2-40B4-BE49-F238E27FC236}">
-                <a16:creationId xmlns:a16="http://schemas.microsoft.com/office/drawing/2014/main" id="{41664C71-6F31-4029-A3A4-04C288F48C23}"/>
+                <a16:creationId xmlns:a16="http://schemas.microsoft.com/office/drawing/2014/main" id="{C5B3FE23-13F0-46D0-99A7-F31EE547476C}"/>
               </a:ext>
             </a:extLst>
           </p:cNvPr>
@@ -5978,7 +5998,7 @@
           <p:nvPr/>
         </p:nvPicPr>
         <p:blipFill>
-          <a:blip xmlns:r="http://schemas.openxmlformats.org/officeDocument/2006/relationships" xmlns:a="http://schemas.openxmlformats.org/drawingml/2006/main" r:embed="R4a90777c0a1749e4"/>
+          <a:blip xmlns:r="http://schemas.openxmlformats.org/officeDocument/2006/relationships" xmlns:a="http://schemas.openxmlformats.org/drawingml/2006/main" r:embed="Rb1bf73910984481b"/>
           <a:stretch xmlns:a="http://schemas.openxmlformats.org/drawingml/2006/main"/>
         </p:blipFill>
         <p:spPr>
@@ -5996,7 +6016,7 @@
           <p:cNvPr id="11" name="">
             <a:extLst xmlns:a="http://schemas.openxmlformats.org/drawingml/2006/main">
               <a:ext uri="{FF2B5EF4-FFF2-40B4-BE49-F238E27FC236}">
-                <a16:creationId xmlns:a16="http://schemas.microsoft.com/office/drawing/2014/main" id="{65EEE293-1D4A-4B34-AF9E-9F28BE13C224}"/>
+                <a16:creationId xmlns:a16="http://schemas.microsoft.com/office/drawing/2014/main" id="{E8F8964B-BFFC-4A35-8FD4-423C5D43FAD0}"/>
               </a:ext>
             </a:extLst>
           </p:cNvPr>
@@ -6006,7 +6026,7 @@
           <p:nvPr/>
         </p:nvPicPr>
         <p:blipFill>
-          <a:blip xmlns:r="http://schemas.openxmlformats.org/officeDocument/2006/relationships" xmlns:a="http://schemas.openxmlformats.org/drawingml/2006/main" r:embed="Re6c7eb6644d74753"/>
+          <a:blip xmlns:r="http://schemas.openxmlformats.org/officeDocument/2006/relationships" xmlns:a="http://schemas.openxmlformats.org/drawingml/2006/main" r:embed="R5ccd1684ee42412f"/>
           <a:stretch xmlns:a="http://schemas.openxmlformats.org/drawingml/2006/main"/>
         </p:blipFill>
         <p:spPr>
@@ -6024,7 +6044,7 @@
           <p:cNvPr id="12" name="">
             <a:extLst xmlns:a="http://schemas.openxmlformats.org/drawingml/2006/main">
               <a:ext uri="{FF2B5EF4-FFF2-40B4-BE49-F238E27FC236}">
-                <a16:creationId xmlns:a16="http://schemas.microsoft.com/office/drawing/2014/main" id="{BDC2CB61-6300-4DD2-B647-44C3100D0953}"/>
+                <a16:creationId xmlns:a16="http://schemas.microsoft.com/office/drawing/2014/main" id="{5EDA4B88-CADF-4D29-A966-E7DC340972D8}"/>
               </a:ext>
             </a:extLst>
           </p:cNvPr>
@@ -6034,13 +6054,13 @@
           <p:nvPr/>
         </p:nvPicPr>
         <p:blipFill>
-          <a:blip xmlns:r="http://schemas.openxmlformats.org/officeDocument/2006/relationships" xmlns:a="http://schemas.openxmlformats.org/drawingml/2006/main" r:embed="R5a30bbda9ae64ec5"/>
+          <a:blip xmlns:r="http://schemas.openxmlformats.org/officeDocument/2006/relationships" xmlns:a="http://schemas.openxmlformats.org/drawingml/2006/main" r:embed="R8d5d217790244c49"/>
           <a:stretch xmlns:a="http://schemas.openxmlformats.org/drawingml/2006/main"/>
         </p:blipFill>
         <p:spPr>
           <a:xfrm xmlns:a="http://schemas.openxmlformats.org/drawingml/2006/main">
             <a:off x="6953250" y="2933700"/>
-            <a:ext cx="3848722" cy="2524125"/>
+            <a:ext cx="3346334" cy="2524125"/>
           </a:xfrm>
           <a:prstGeom xmlns:a="http://schemas.openxmlformats.org/drawingml/2006/main" prst="rect">
             <a:avLst/>
@@ -6050,7 +6070,7 @@
     </p:spTree>
     <p:extLst>
       <p:ext uri="{BB962C8B-B14F-4D97-AF65-F5344CB8AC3E}">
-        <p14:creationId xmlns:p14="http://schemas.microsoft.com/office/powerpoint/2010/main" val="834683319"/>
+        <p14:creationId xmlns:p14="http://schemas.microsoft.com/office/powerpoint/2010/main" val="1262150863"/>
       </p:ext>
     </p:extLst>
   </p:cSld>
@@ -6081,7 +6101,7 @@
           <p:cNvPr id="13" name="">
             <a:extLst xmlns:a="http://schemas.openxmlformats.org/drawingml/2006/main">
               <a:ext uri="{FF2B5EF4-FFF2-40B4-BE49-F238E27FC236}">
-                <a16:creationId xmlns:a16="http://schemas.microsoft.com/office/drawing/2014/main" id="{4ABAD392-7EBA-43C4-B836-CCF803A70D8E}"/>
+                <a16:creationId xmlns:a16="http://schemas.microsoft.com/office/drawing/2014/main" id="{DF8AF9D2-619D-4696-AB57-BF665D7F11F9}"/>
               </a:ext>
             </a:extLst>
           </p:cNvPr>
@@ -6147,7 +6167,7 @@
           <p:cNvPr id="2" name="">
             <a:extLst xmlns:a="http://schemas.openxmlformats.org/drawingml/2006/main">
               <a:ext uri="{FF2B5EF4-FFF2-40B4-BE49-F238E27FC236}">
-                <a16:creationId xmlns:a16="http://schemas.microsoft.com/office/drawing/2014/main" id="{F84202DD-C837-4751-8B3F-0C2782B437E1}"/>
+                <a16:creationId xmlns:a16="http://schemas.microsoft.com/office/drawing/2014/main" id="{F49EA0F7-72F4-47D6-8D8F-97FAB8D9F0EF}"/>
               </a:ext>
             </a:extLst>
           </p:cNvPr>
@@ -6213,7 +6233,7 @@
           <p:cNvPr id="3" name="">
             <a:extLst xmlns:a="http://schemas.openxmlformats.org/drawingml/2006/main">
               <a:ext uri="{FF2B5EF4-FFF2-40B4-BE49-F238E27FC236}">
-                <a16:creationId xmlns:a16="http://schemas.microsoft.com/office/drawing/2014/main" id="{676F8F87-693C-49B5-A3B0-BBEA4EAF203E}"/>
+                <a16:creationId xmlns:a16="http://schemas.microsoft.com/office/drawing/2014/main" id="{550F5799-AFD6-4434-919C-6C14E3BB8189}"/>
               </a:ext>
             </a:extLst>
           </p:cNvPr>
@@ -6279,7 +6299,7 @@
           <p:cNvPr id="4" name="">
             <a:extLst xmlns:a="http://schemas.openxmlformats.org/drawingml/2006/main">
               <a:ext uri="{FF2B5EF4-FFF2-40B4-BE49-F238E27FC236}">
-                <a16:creationId xmlns:a16="http://schemas.microsoft.com/office/drawing/2014/main" id="{93838027-65AF-413D-A72F-123E680744A4}"/>
+                <a16:creationId xmlns:a16="http://schemas.microsoft.com/office/drawing/2014/main" id="{C94C48A0-B72D-4CC8-B7B7-A80BF1FF997B}"/>
               </a:ext>
             </a:extLst>
           </p:cNvPr>
@@ -6345,7 +6365,7 @@
           <p:cNvPr id="5" name="">
             <a:extLst xmlns:a="http://schemas.openxmlformats.org/drawingml/2006/main">
               <a:ext uri="{FF2B5EF4-FFF2-40B4-BE49-F238E27FC236}">
-                <a16:creationId xmlns:a16="http://schemas.microsoft.com/office/drawing/2014/main" id="{E15DD544-EC9F-4AEB-B8C7-A1DE564479B1}"/>
+                <a16:creationId xmlns:a16="http://schemas.microsoft.com/office/drawing/2014/main" id="{6D921BAC-D122-4491-8DFD-CBCE92621987}"/>
               </a:ext>
             </a:extLst>
           </p:cNvPr>
@@ -6411,7 +6431,7 @@
           <p:cNvPr id="6" name="">
             <a:extLst xmlns:a="http://schemas.openxmlformats.org/drawingml/2006/main">
               <a:ext uri="{FF2B5EF4-FFF2-40B4-BE49-F238E27FC236}">
-                <a16:creationId xmlns:a16="http://schemas.microsoft.com/office/drawing/2014/main" id="{5AFA45CC-BCCA-4940-895B-1EE74A741A8A}"/>
+                <a16:creationId xmlns:a16="http://schemas.microsoft.com/office/drawing/2014/main" id="{77EE45E5-61CB-40BB-9A06-D981F3CA8BDC}"/>
               </a:ext>
             </a:extLst>
           </p:cNvPr>
@@ -6477,7 +6497,7 @@
           <p:cNvPr id="7" name="">
             <a:extLst xmlns:a="http://schemas.openxmlformats.org/drawingml/2006/main">
               <a:ext uri="{FF2B5EF4-FFF2-40B4-BE49-F238E27FC236}">
-                <a16:creationId xmlns:a16="http://schemas.microsoft.com/office/drawing/2014/main" id="{A69C2B04-ABBA-4307-BA9E-62C4C53BF5EF}"/>
+                <a16:creationId xmlns:a16="http://schemas.microsoft.com/office/drawing/2014/main" id="{9FDF878D-0D24-40A5-A7A1-22F95ABF99A9}"/>
               </a:ext>
             </a:extLst>
           </p:cNvPr>
@@ -6543,7 +6563,7 @@
           <p:cNvPr id="8" name="">
             <a:extLst xmlns:a="http://schemas.openxmlformats.org/drawingml/2006/main">
               <a:ext uri="{FF2B5EF4-FFF2-40B4-BE49-F238E27FC236}">
-                <a16:creationId xmlns:a16="http://schemas.microsoft.com/office/drawing/2014/main" id="{0FCC5790-515C-4477-872F-4CF247E614E6}"/>
+                <a16:creationId xmlns:a16="http://schemas.microsoft.com/office/drawing/2014/main" id="{E80A041F-8DFE-4F44-9487-E68D870A7964}"/>
               </a:ext>
             </a:extLst>
           </p:cNvPr>
@@ -6609,7 +6629,7 @@
           <p:cNvPr id="9" name="">
             <a:extLst xmlns:a="http://schemas.openxmlformats.org/drawingml/2006/main">
               <a:ext uri="{FF2B5EF4-FFF2-40B4-BE49-F238E27FC236}">
-                <a16:creationId xmlns:a16="http://schemas.microsoft.com/office/drawing/2014/main" id="{3BD4A576-A19F-405A-8C7B-B36893EC38A3}"/>
+                <a16:creationId xmlns:a16="http://schemas.microsoft.com/office/drawing/2014/main" id="{E83F1A9C-2CF7-4662-8D94-725FD4FC4CB4}"/>
               </a:ext>
             </a:extLst>
           </p:cNvPr>
@@ -6619,7 +6639,7 @@
           <p:nvPr/>
         </p:nvPicPr>
         <p:blipFill>
-          <a:blip xmlns:r="http://schemas.openxmlformats.org/officeDocument/2006/relationships" xmlns:a="http://schemas.openxmlformats.org/drawingml/2006/main" r:embed="Rb64fd073b8024bb7"/>
+          <a:blip xmlns:r="http://schemas.openxmlformats.org/officeDocument/2006/relationships" xmlns:a="http://schemas.openxmlformats.org/drawingml/2006/main" r:embed="R8df4141a8e204268"/>
           <a:stretch xmlns:a="http://schemas.openxmlformats.org/drawingml/2006/main"/>
         </p:blipFill>
         <p:spPr>
@@ -6637,7 +6657,7 @@
           <p:cNvPr id="10" name="">
             <a:extLst xmlns:a="http://schemas.openxmlformats.org/drawingml/2006/main">
               <a:ext uri="{FF2B5EF4-FFF2-40B4-BE49-F238E27FC236}">
-                <a16:creationId xmlns:a16="http://schemas.microsoft.com/office/drawing/2014/main" id="{B6AE4529-77EA-4EAF-976B-C069673D5E70}"/>
+                <a16:creationId xmlns:a16="http://schemas.microsoft.com/office/drawing/2014/main" id="{C678423C-B91D-4C0F-9B01-9F1EF7073AB3}"/>
               </a:ext>
             </a:extLst>
           </p:cNvPr>
@@ -6647,7 +6667,7 @@
           <p:nvPr/>
         </p:nvPicPr>
         <p:blipFill>
-          <a:blip xmlns:r="http://schemas.openxmlformats.org/officeDocument/2006/relationships" xmlns:a="http://schemas.openxmlformats.org/drawingml/2006/main" r:embed="Re9473ebf6e1142ff"/>
+          <a:blip xmlns:r="http://schemas.openxmlformats.org/officeDocument/2006/relationships" xmlns:a="http://schemas.openxmlformats.org/drawingml/2006/main" r:embed="R6700a81a96864000"/>
           <a:stretch xmlns:a="http://schemas.openxmlformats.org/drawingml/2006/main"/>
         </p:blipFill>
         <p:spPr>
@@ -6665,7 +6685,7 @@
           <p:cNvPr id="11" name="">
             <a:extLst xmlns:a="http://schemas.openxmlformats.org/drawingml/2006/main">
               <a:ext uri="{FF2B5EF4-FFF2-40B4-BE49-F238E27FC236}">
-                <a16:creationId xmlns:a16="http://schemas.microsoft.com/office/drawing/2014/main" id="{804767CC-F1B2-413F-AB31-FB55FECD858A}"/>
+                <a16:creationId xmlns:a16="http://schemas.microsoft.com/office/drawing/2014/main" id="{26A2E9C1-AB03-4741-8724-46839EBB32C2}"/>
               </a:ext>
             </a:extLst>
           </p:cNvPr>
@@ -6675,7 +6695,7 @@
           <p:nvPr/>
         </p:nvPicPr>
         <p:blipFill>
-          <a:blip xmlns:r="http://schemas.openxmlformats.org/officeDocument/2006/relationships" xmlns:a="http://schemas.openxmlformats.org/drawingml/2006/main" r:embed="R46b991973c034ba8"/>
+          <a:blip xmlns:r="http://schemas.openxmlformats.org/officeDocument/2006/relationships" xmlns:a="http://schemas.openxmlformats.org/drawingml/2006/main" r:embed="Raf1ae136fbca4c02"/>
           <a:stretch xmlns:a="http://schemas.openxmlformats.org/drawingml/2006/main"/>
         </p:blipFill>
         <p:spPr>
@@ -6693,7 +6713,7 @@
           <p:cNvPr id="12" name="">
             <a:extLst xmlns:a="http://schemas.openxmlformats.org/drawingml/2006/main">
               <a:ext uri="{FF2B5EF4-FFF2-40B4-BE49-F238E27FC236}">
-                <a16:creationId xmlns:a16="http://schemas.microsoft.com/office/drawing/2014/main" id="{AB39861C-097D-41E3-B377-61220CE87FB5}"/>
+                <a16:creationId xmlns:a16="http://schemas.microsoft.com/office/drawing/2014/main" id="{6BCB7573-90CB-4B37-8921-40D28A2D35BE}"/>
               </a:ext>
             </a:extLst>
           </p:cNvPr>
@@ -6703,7 +6723,7 @@
           <p:nvPr/>
         </p:nvPicPr>
         <p:blipFill>
-          <a:blip xmlns:r="http://schemas.openxmlformats.org/officeDocument/2006/relationships" xmlns:a="http://schemas.openxmlformats.org/drawingml/2006/main" r:embed="Rb05a21fe4cac42ab"/>
+          <a:blip xmlns:r="http://schemas.openxmlformats.org/officeDocument/2006/relationships" xmlns:a="http://schemas.openxmlformats.org/drawingml/2006/main" r:embed="R4a8b441028b8495a"/>
           <a:stretch xmlns:a="http://schemas.openxmlformats.org/drawingml/2006/main"/>
         </p:blipFill>
         <p:spPr>
@@ -6719,7 +6739,7 @@
     </p:spTree>
     <p:extLst>
       <p:ext uri="{BB962C8B-B14F-4D97-AF65-F5344CB8AC3E}">
-        <p14:creationId xmlns:p14="http://schemas.microsoft.com/office/powerpoint/2010/main" val="421117428"/>
+        <p14:creationId xmlns:p14="http://schemas.microsoft.com/office/powerpoint/2010/main" val="279593097"/>
       </p:ext>
     </p:extLst>
   </p:cSld>
@@ -6750,7 +6770,7 @@
           <p:cNvPr id="13" name="">
             <a:extLst xmlns:a="http://schemas.openxmlformats.org/drawingml/2006/main">
               <a:ext uri="{FF2B5EF4-FFF2-40B4-BE49-F238E27FC236}">
-                <a16:creationId xmlns:a16="http://schemas.microsoft.com/office/drawing/2014/main" id="{FEE63E1A-8BD8-45B2-B38B-8994E65DC050}"/>
+                <a16:creationId xmlns:a16="http://schemas.microsoft.com/office/drawing/2014/main" id="{472A028C-20D4-43D3-B80E-0C026256A076}"/>
               </a:ext>
             </a:extLst>
           </p:cNvPr>
@@ -6816,7 +6836,7 @@
           <p:cNvPr id="2" name="">
             <a:extLst xmlns:a="http://schemas.openxmlformats.org/drawingml/2006/main">
               <a:ext uri="{FF2B5EF4-FFF2-40B4-BE49-F238E27FC236}">
-                <a16:creationId xmlns:a16="http://schemas.microsoft.com/office/drawing/2014/main" id="{1144B1F1-CBB1-4E38-9065-31BDAED4B02C}"/>
+                <a16:creationId xmlns:a16="http://schemas.microsoft.com/office/drawing/2014/main" id="{CBC5E3A6-E95C-460D-B578-944740A8C63B}"/>
               </a:ext>
             </a:extLst>
           </p:cNvPr>
@@ -6882,7 +6902,7 @@
           <p:cNvPr id="3" name="">
             <a:extLst xmlns:a="http://schemas.openxmlformats.org/drawingml/2006/main">
               <a:ext uri="{FF2B5EF4-FFF2-40B4-BE49-F238E27FC236}">
-                <a16:creationId xmlns:a16="http://schemas.microsoft.com/office/drawing/2014/main" id="{89215063-68CA-413C-BE64-1EF503446F86}"/>
+                <a16:creationId xmlns:a16="http://schemas.microsoft.com/office/drawing/2014/main" id="{82D8B520-308A-4CC9-828F-835540E12212}"/>
               </a:ext>
             </a:extLst>
           </p:cNvPr>
@@ -6948,7 +6968,7 @@
           <p:cNvPr id="4" name="">
             <a:extLst xmlns:a="http://schemas.openxmlformats.org/drawingml/2006/main">
               <a:ext uri="{FF2B5EF4-FFF2-40B4-BE49-F238E27FC236}">
-                <a16:creationId xmlns:a16="http://schemas.microsoft.com/office/drawing/2014/main" id="{2F25A252-883B-4B7F-A130-FC0751190D90}"/>
+                <a16:creationId xmlns:a16="http://schemas.microsoft.com/office/drawing/2014/main" id="{F92AFA31-AF86-4EF1-B9DB-939191139698}"/>
               </a:ext>
             </a:extLst>
           </p:cNvPr>
@@ -7014,7 +7034,7 @@
           <p:cNvPr id="5" name="">
             <a:extLst xmlns:a="http://schemas.openxmlformats.org/drawingml/2006/main">
               <a:ext uri="{FF2B5EF4-FFF2-40B4-BE49-F238E27FC236}">
-                <a16:creationId xmlns:a16="http://schemas.microsoft.com/office/drawing/2014/main" id="{D6CC898B-BC52-4285-8DBF-0E56C11D4BC1}"/>
+                <a16:creationId xmlns:a16="http://schemas.microsoft.com/office/drawing/2014/main" id="{9D8CFE6E-80E9-4963-B63F-32488E22F76D}"/>
               </a:ext>
             </a:extLst>
           </p:cNvPr>
@@ -7080,7 +7100,7 @@
           <p:cNvPr id="6" name="">
             <a:extLst xmlns:a="http://schemas.openxmlformats.org/drawingml/2006/main">
               <a:ext uri="{FF2B5EF4-FFF2-40B4-BE49-F238E27FC236}">
-                <a16:creationId xmlns:a16="http://schemas.microsoft.com/office/drawing/2014/main" id="{040771BA-0583-4E22-92D9-BE4672E222BA}"/>
+                <a16:creationId xmlns:a16="http://schemas.microsoft.com/office/drawing/2014/main" id="{DFC0418C-57DF-4838-A411-DE7C25A591D1}"/>
               </a:ext>
             </a:extLst>
           </p:cNvPr>
@@ -7136,7 +7156,7 @@
                 <a:ea typeface="DejaVu Sans"/>
                 <a:cs typeface="DejaVu Sans"/>
               </a:rPr>
-              <a:t>A tangential restart reaches the target apogee. Reserve calculation uses Isp₂ = 348 s.</a:t>
+              <a:t>A tangential restart reaches the target apogee. Reserve calculation uses the configured restart Isp.</a:t>
             </a:r>
           </a:p>
         </p:txBody>
@@ -7146,7 +7166,7 @@
           <p:cNvPr id="7" name="">
             <a:extLst xmlns:a="http://schemas.openxmlformats.org/drawingml/2006/main">
               <a:ext uri="{FF2B5EF4-FFF2-40B4-BE49-F238E27FC236}">
-                <a16:creationId xmlns:a16="http://schemas.microsoft.com/office/drawing/2014/main" id="{D4C49870-F804-4139-9C15-32DC95357E91}"/>
+                <a16:creationId xmlns:a16="http://schemas.microsoft.com/office/drawing/2014/main" id="{44832521-2FA6-4A09-B702-1FEF0ABE0A64}"/>
               </a:ext>
             </a:extLst>
           </p:cNvPr>
@@ -7212,7 +7232,7 @@
           <p:cNvPr id="8" name="">
             <a:extLst xmlns:a="http://schemas.openxmlformats.org/drawingml/2006/main">
               <a:ext uri="{FF2B5EF4-FFF2-40B4-BE49-F238E27FC236}">
-                <a16:creationId xmlns:a16="http://schemas.microsoft.com/office/drawing/2014/main" id="{0024DA67-75F1-404A-90C0-324B864D6EDA}"/>
+                <a16:creationId xmlns:a16="http://schemas.microsoft.com/office/drawing/2014/main" id="{931ABA7C-6E0F-4B43-8C51-45715AC40DBC}"/>
               </a:ext>
             </a:extLst>
           </p:cNvPr>
@@ -7278,7 +7298,7 @@
           <p:cNvPr id="9" name="">
             <a:extLst xmlns:a="http://schemas.openxmlformats.org/drawingml/2006/main">
               <a:ext uri="{FF2B5EF4-FFF2-40B4-BE49-F238E27FC236}">
-                <a16:creationId xmlns:a16="http://schemas.microsoft.com/office/drawing/2014/main" id="{1CA70194-4482-4245-855E-B94D1FE47830}"/>
+                <a16:creationId xmlns:a16="http://schemas.microsoft.com/office/drawing/2014/main" id="{CFD3638B-115E-40BD-AE3F-E57ECAE1C1C2}"/>
               </a:ext>
             </a:extLst>
           </p:cNvPr>
@@ -7288,7 +7308,7 @@
           <p:nvPr/>
         </p:nvPicPr>
         <p:blipFill>
-          <a:blip xmlns:r="http://schemas.openxmlformats.org/officeDocument/2006/relationships" xmlns:a="http://schemas.openxmlformats.org/drawingml/2006/main" r:embed="R6ff30e7dc79046d9"/>
+          <a:blip xmlns:r="http://schemas.openxmlformats.org/officeDocument/2006/relationships" xmlns:a="http://schemas.openxmlformats.org/drawingml/2006/main" r:embed="R07e3f23f6cbb4e53"/>
           <a:stretch xmlns:a="http://schemas.openxmlformats.org/drawingml/2006/main"/>
         </p:blipFill>
         <p:spPr>
@@ -7306,7 +7326,7 @@
           <p:cNvPr id="10" name="">
             <a:extLst xmlns:a="http://schemas.openxmlformats.org/drawingml/2006/main">
               <a:ext uri="{FF2B5EF4-FFF2-40B4-BE49-F238E27FC236}">
-                <a16:creationId xmlns:a16="http://schemas.microsoft.com/office/drawing/2014/main" id="{3407E851-6966-49E9-99D9-11E2CFDC8305}"/>
+                <a16:creationId xmlns:a16="http://schemas.microsoft.com/office/drawing/2014/main" id="{44DA719E-1E69-4B79-BE21-609D8B10FEEB}"/>
               </a:ext>
             </a:extLst>
           </p:cNvPr>
@@ -7316,7 +7336,7 @@
           <p:nvPr/>
         </p:nvPicPr>
         <p:blipFill>
-          <a:blip xmlns:r="http://schemas.openxmlformats.org/officeDocument/2006/relationships" xmlns:a="http://schemas.openxmlformats.org/drawingml/2006/main" r:embed="R51b961aa67314d6b"/>
+          <a:blip xmlns:r="http://schemas.openxmlformats.org/officeDocument/2006/relationships" xmlns:a="http://schemas.openxmlformats.org/drawingml/2006/main" r:embed="R1e7907d9e6044509"/>
           <a:stretch xmlns:a="http://schemas.openxmlformats.org/drawingml/2006/main"/>
         </p:blipFill>
         <p:spPr>
@@ -7334,7 +7354,7 @@
           <p:cNvPr id="11" name="">
             <a:extLst xmlns:a="http://schemas.openxmlformats.org/drawingml/2006/main">
               <a:ext uri="{FF2B5EF4-FFF2-40B4-BE49-F238E27FC236}">
-                <a16:creationId xmlns:a16="http://schemas.microsoft.com/office/drawing/2014/main" id="{64C9F206-C70A-49B8-B221-10127AC5137C}"/>
+                <a16:creationId xmlns:a16="http://schemas.microsoft.com/office/drawing/2014/main" id="{2BA95695-4642-4998-991A-58E56BBE9C57}"/>
               </a:ext>
             </a:extLst>
           </p:cNvPr>
@@ -7344,7 +7364,7 @@
           <p:nvPr/>
         </p:nvPicPr>
         <p:blipFill>
-          <a:blip xmlns:r="http://schemas.openxmlformats.org/officeDocument/2006/relationships" xmlns:a="http://schemas.openxmlformats.org/drawingml/2006/main" r:embed="Re841c7677d2e4599"/>
+          <a:blip xmlns:r="http://schemas.openxmlformats.org/officeDocument/2006/relationships" xmlns:a="http://schemas.openxmlformats.org/drawingml/2006/main" r:embed="R46204792eff54b56"/>
           <a:stretch xmlns:a="http://schemas.openxmlformats.org/drawingml/2006/main"/>
         </p:blipFill>
         <p:spPr>
@@ -7362,7 +7382,7 @@
           <p:cNvPr id="12" name="">
             <a:extLst xmlns:a="http://schemas.openxmlformats.org/drawingml/2006/main">
               <a:ext uri="{FF2B5EF4-FFF2-40B4-BE49-F238E27FC236}">
-                <a16:creationId xmlns:a16="http://schemas.microsoft.com/office/drawing/2014/main" id="{E51B8923-B7E2-4BFC-AB90-736FE5ACCC69}"/>
+                <a16:creationId xmlns:a16="http://schemas.microsoft.com/office/drawing/2014/main" id="{E5B52B19-CD3D-4E4D-98D8-9E199890A175}"/>
               </a:ext>
             </a:extLst>
           </p:cNvPr>
@@ -7372,7 +7392,7 @@
           <p:nvPr/>
         </p:nvPicPr>
         <p:blipFill>
-          <a:blip xmlns:r="http://schemas.openxmlformats.org/officeDocument/2006/relationships" xmlns:a="http://schemas.openxmlformats.org/drawingml/2006/main" r:embed="Rcd5fb1958d97477b"/>
+          <a:blip xmlns:r="http://schemas.openxmlformats.org/officeDocument/2006/relationships" xmlns:a="http://schemas.openxmlformats.org/drawingml/2006/main" r:embed="R9723cb7bd5ad41f6"/>
           <a:stretch xmlns:a="http://schemas.openxmlformats.org/drawingml/2006/main"/>
         </p:blipFill>
         <p:spPr>
@@ -7388,7 +7408,7 @@
     </p:spTree>
     <p:extLst>
       <p:ext uri="{BB962C8B-B14F-4D97-AF65-F5344CB8AC3E}">
-        <p14:creationId xmlns:p14="http://schemas.microsoft.com/office/powerpoint/2010/main" val="1333455566"/>
+        <p14:creationId xmlns:p14="http://schemas.microsoft.com/office/powerpoint/2010/main" val="6795191"/>
       </p:ext>
     </p:extLst>
   </p:cSld>
@@ -7419,7 +7439,7 @@
           <p:cNvPr id="13" name="">
             <a:extLst xmlns:a="http://schemas.openxmlformats.org/drawingml/2006/main">
               <a:ext uri="{FF2B5EF4-FFF2-40B4-BE49-F238E27FC236}">
-                <a16:creationId xmlns:a16="http://schemas.microsoft.com/office/drawing/2014/main" id="{542DCFC5-5C4B-4AD0-9F3D-46AA27BF527B}"/>
+                <a16:creationId xmlns:a16="http://schemas.microsoft.com/office/drawing/2014/main" id="{EAA7724F-5174-471B-99D1-E41A5CB8E2B8}"/>
               </a:ext>
             </a:extLst>
           </p:cNvPr>
@@ -7485,7 +7505,7 @@
           <p:cNvPr id="2" name="">
             <a:extLst xmlns:a="http://schemas.openxmlformats.org/drawingml/2006/main">
               <a:ext uri="{FF2B5EF4-FFF2-40B4-BE49-F238E27FC236}">
-                <a16:creationId xmlns:a16="http://schemas.microsoft.com/office/drawing/2014/main" id="{C0D4C830-9283-4E3C-A963-E420A514B9A1}"/>
+                <a16:creationId xmlns:a16="http://schemas.microsoft.com/office/drawing/2014/main" id="{491E2412-78DF-4E31-A526-A53F3CF07CA4}"/>
               </a:ext>
             </a:extLst>
           </p:cNvPr>
@@ -7551,7 +7571,7 @@
           <p:cNvPr id="3" name="">
             <a:extLst xmlns:a="http://schemas.openxmlformats.org/drawingml/2006/main">
               <a:ext uri="{FF2B5EF4-FFF2-40B4-BE49-F238E27FC236}">
-                <a16:creationId xmlns:a16="http://schemas.microsoft.com/office/drawing/2014/main" id="{753F5429-175B-4B1B-B556-8579CAABDBCE}"/>
+                <a16:creationId xmlns:a16="http://schemas.microsoft.com/office/drawing/2014/main" id="{3F43428F-82D6-49DA-9192-1FD8AC0BF29A}"/>
               </a:ext>
             </a:extLst>
           </p:cNvPr>
@@ -7617,7 +7637,7 @@
           <p:cNvPr id="4" name="">
             <a:extLst xmlns:a="http://schemas.openxmlformats.org/drawingml/2006/main">
               <a:ext uri="{FF2B5EF4-FFF2-40B4-BE49-F238E27FC236}">
-                <a16:creationId xmlns:a16="http://schemas.microsoft.com/office/drawing/2014/main" id="{DC803D9D-2670-419B-A28C-2C172392A46D}"/>
+                <a16:creationId xmlns:a16="http://schemas.microsoft.com/office/drawing/2014/main" id="{EC044EE6-BEC3-45B1-996F-43EF72DEE5B3}"/>
               </a:ext>
             </a:extLst>
           </p:cNvPr>
@@ -7683,7 +7703,7 @@
           <p:cNvPr id="5" name="">
             <a:extLst xmlns:a="http://schemas.openxmlformats.org/drawingml/2006/main">
               <a:ext uri="{FF2B5EF4-FFF2-40B4-BE49-F238E27FC236}">
-                <a16:creationId xmlns:a16="http://schemas.microsoft.com/office/drawing/2014/main" id="{B511460F-EA4E-4E8E-8414-92D621F16325}"/>
+                <a16:creationId xmlns:a16="http://schemas.microsoft.com/office/drawing/2014/main" id="{0E408150-4D9D-4594-8F76-F60FFC381C5C}"/>
               </a:ext>
             </a:extLst>
           </p:cNvPr>
@@ -7749,7 +7769,7 @@
           <p:cNvPr id="6" name="">
             <a:extLst xmlns:a="http://schemas.openxmlformats.org/drawingml/2006/main">
               <a:ext uri="{FF2B5EF4-FFF2-40B4-BE49-F238E27FC236}">
-                <a16:creationId xmlns:a16="http://schemas.microsoft.com/office/drawing/2014/main" id="{A952F4A5-DAB8-41BE-B304-A23CA0C318CE}"/>
+                <a16:creationId xmlns:a16="http://schemas.microsoft.com/office/drawing/2014/main" id="{DD92B663-0C8E-4DAB-94ED-FF5BC19BAAB8}"/>
               </a:ext>
             </a:extLst>
           </p:cNvPr>
@@ -7815,7 +7835,7 @@
           <p:cNvPr id="7" name="">
             <a:extLst xmlns:a="http://schemas.openxmlformats.org/drawingml/2006/main">
               <a:ext uri="{FF2B5EF4-FFF2-40B4-BE49-F238E27FC236}">
-                <a16:creationId xmlns:a16="http://schemas.microsoft.com/office/drawing/2014/main" id="{339891BB-2D52-4296-98BA-E6FD79BBAF41}"/>
+                <a16:creationId xmlns:a16="http://schemas.microsoft.com/office/drawing/2014/main" id="{610B1CF3-A2A1-4C24-AC2C-7AF95FDCB64C}"/>
               </a:ext>
             </a:extLst>
           </p:cNvPr>
@@ -7871,7 +7891,7 @@
                 <a:ea typeface="DejaVu Sans"/>
                 <a:cs typeface="DejaVu Sans"/>
               </a:rPr>
-              <a:t>RTLS boostback uses 3-engine vacuum thrust (2.742 MN), Isp = 305 s. ASDS starts with coast.</a:t>
+              <a:t>RTLS uses boostback. Configured engine capacity sets thrust and Isp. ASDS starts with coast.</a:t>
             </a:r>
           </a:p>
         </p:txBody>
@@ -7881,7 +7901,7 @@
           <p:cNvPr id="8" name="">
             <a:extLst xmlns:a="http://schemas.openxmlformats.org/drawingml/2006/main">
               <a:ext uri="{FF2B5EF4-FFF2-40B4-BE49-F238E27FC236}">
-                <a16:creationId xmlns:a16="http://schemas.microsoft.com/office/drawing/2014/main" id="{3E30DA59-9E37-4FB7-AF6B-8F24A8D731F2}"/>
+                <a16:creationId xmlns:a16="http://schemas.microsoft.com/office/drawing/2014/main" id="{5205DF01-4389-4944-AEE2-2EE0ABDA08F4}"/>
               </a:ext>
             </a:extLst>
           </p:cNvPr>
@@ -7947,7 +7967,7 @@
           <p:cNvPr id="9" name="">
             <a:extLst xmlns:a="http://schemas.openxmlformats.org/drawingml/2006/main">
               <a:ext uri="{FF2B5EF4-FFF2-40B4-BE49-F238E27FC236}">
-                <a16:creationId xmlns:a16="http://schemas.microsoft.com/office/drawing/2014/main" id="{924856FE-3C34-497C-8F92-59737CC07EF6}"/>
+                <a16:creationId xmlns:a16="http://schemas.microsoft.com/office/drawing/2014/main" id="{7B4F38BF-C3FE-470D-AEB6-8915DB7D0C81}"/>
               </a:ext>
             </a:extLst>
           </p:cNvPr>
@@ -7957,7 +7977,7 @@
           <p:nvPr/>
         </p:nvPicPr>
         <p:blipFill>
-          <a:blip xmlns:r="http://schemas.openxmlformats.org/officeDocument/2006/relationships" xmlns:a="http://schemas.openxmlformats.org/drawingml/2006/main" r:embed="Rb6adba28111549dc"/>
+          <a:blip xmlns:r="http://schemas.openxmlformats.org/officeDocument/2006/relationships" xmlns:a="http://schemas.openxmlformats.org/drawingml/2006/main" r:embed="R445ddba4e9954620"/>
           <a:stretch xmlns:a="http://schemas.openxmlformats.org/drawingml/2006/main"/>
         </p:blipFill>
         <p:spPr>
@@ -7975,7 +7995,7 @@
           <p:cNvPr id="10" name="">
             <a:extLst xmlns:a="http://schemas.openxmlformats.org/drawingml/2006/main">
               <a:ext uri="{FF2B5EF4-FFF2-40B4-BE49-F238E27FC236}">
-                <a16:creationId xmlns:a16="http://schemas.microsoft.com/office/drawing/2014/main" id="{59E3CD92-AE26-437C-BB08-FDDAC7EABDB8}"/>
+                <a16:creationId xmlns:a16="http://schemas.microsoft.com/office/drawing/2014/main" id="{9FDDCDE8-C871-4763-AB87-5B60974F9E32}"/>
               </a:ext>
             </a:extLst>
           </p:cNvPr>
@@ -7985,7 +8005,7 @@
           <p:nvPr/>
         </p:nvPicPr>
         <p:blipFill>
-          <a:blip xmlns:r="http://schemas.openxmlformats.org/officeDocument/2006/relationships" xmlns:a="http://schemas.openxmlformats.org/drawingml/2006/main" r:embed="R330aa240d9e44b43"/>
+          <a:blip xmlns:r="http://schemas.openxmlformats.org/officeDocument/2006/relationships" xmlns:a="http://schemas.openxmlformats.org/drawingml/2006/main" r:embed="R01384c885f0846df"/>
           <a:stretch xmlns:a="http://schemas.openxmlformats.org/drawingml/2006/main"/>
         </p:blipFill>
         <p:spPr>
@@ -8003,7 +8023,7 @@
           <p:cNvPr id="11" name="">
             <a:extLst xmlns:a="http://schemas.openxmlformats.org/drawingml/2006/main">
               <a:ext uri="{FF2B5EF4-FFF2-40B4-BE49-F238E27FC236}">
-                <a16:creationId xmlns:a16="http://schemas.microsoft.com/office/drawing/2014/main" id="{0DBF1C60-5F3A-42C3-9DCE-96EC29E71F43}"/>
+                <a16:creationId xmlns:a16="http://schemas.microsoft.com/office/drawing/2014/main" id="{3D244CBB-47F2-463B-AF19-74419ECB37CD}"/>
               </a:ext>
             </a:extLst>
           </p:cNvPr>
@@ -8013,7 +8033,7 @@
           <p:nvPr/>
         </p:nvPicPr>
         <p:blipFill>
-          <a:blip xmlns:r="http://schemas.openxmlformats.org/officeDocument/2006/relationships" xmlns:a="http://schemas.openxmlformats.org/drawingml/2006/main" r:embed="R97cbe88491a3448b"/>
+          <a:blip xmlns:r="http://schemas.openxmlformats.org/officeDocument/2006/relationships" xmlns:a="http://schemas.openxmlformats.org/drawingml/2006/main" r:embed="R9f73a35770ad4d36"/>
           <a:stretch xmlns:a="http://schemas.openxmlformats.org/drawingml/2006/main"/>
         </p:blipFill>
         <p:spPr>
@@ -8031,7 +8051,7 @@
           <p:cNvPr id="12" name="">
             <a:extLst xmlns:a="http://schemas.openxmlformats.org/drawingml/2006/main">
               <a:ext uri="{FF2B5EF4-FFF2-40B4-BE49-F238E27FC236}">
-                <a16:creationId xmlns:a16="http://schemas.microsoft.com/office/drawing/2014/main" id="{7B0EEBED-435A-4894-A9E3-00EAD94963FE}"/>
+                <a16:creationId xmlns:a16="http://schemas.microsoft.com/office/drawing/2014/main" id="{839D2F33-6463-47C2-85A3-BD685EE04E56}"/>
               </a:ext>
             </a:extLst>
           </p:cNvPr>
@@ -8041,7 +8061,7 @@
           <p:nvPr/>
         </p:nvPicPr>
         <p:blipFill>
-          <a:blip xmlns:r="http://schemas.openxmlformats.org/officeDocument/2006/relationships" xmlns:a="http://schemas.openxmlformats.org/drawingml/2006/main" r:embed="R0ba4cb2cecb04958"/>
+          <a:blip xmlns:r="http://schemas.openxmlformats.org/officeDocument/2006/relationships" xmlns:a="http://schemas.openxmlformats.org/drawingml/2006/main" r:embed="Rfa016aa6d01447a0"/>
           <a:stretch xmlns:a="http://schemas.openxmlformats.org/drawingml/2006/main"/>
         </p:blipFill>
         <p:spPr>
@@ -8057,7 +8077,7 @@
     </p:spTree>
     <p:extLst>
       <p:ext uri="{BB962C8B-B14F-4D97-AF65-F5344CB8AC3E}">
-        <p14:creationId xmlns:p14="http://schemas.microsoft.com/office/powerpoint/2010/main" val="339668100"/>
+        <p14:creationId xmlns:p14="http://schemas.microsoft.com/office/powerpoint/2010/main" val="1562949531"/>
       </p:ext>
     </p:extLst>
   </p:cSld>
@@ -8088,7 +8108,7 @@
           <p:cNvPr id="13" name="">
             <a:extLst xmlns:a="http://schemas.openxmlformats.org/drawingml/2006/main">
               <a:ext uri="{FF2B5EF4-FFF2-40B4-BE49-F238E27FC236}">
-                <a16:creationId xmlns:a16="http://schemas.microsoft.com/office/drawing/2014/main" id="{404A792A-9263-45E8-9D5C-DF48AEE6D768}"/>
+                <a16:creationId xmlns:a16="http://schemas.microsoft.com/office/drawing/2014/main" id="{8C1305F6-1326-4CD0-8FF5-5D28909AC1D8}"/>
               </a:ext>
             </a:extLst>
           </p:cNvPr>
@@ -8154,7 +8174,7 @@
           <p:cNvPr id="2" name="">
             <a:extLst xmlns:a="http://schemas.openxmlformats.org/drawingml/2006/main">
               <a:ext uri="{FF2B5EF4-FFF2-40B4-BE49-F238E27FC236}">
-                <a16:creationId xmlns:a16="http://schemas.microsoft.com/office/drawing/2014/main" id="{C061CE3E-5F58-4F50-B3A6-96567203E70E}"/>
+                <a16:creationId xmlns:a16="http://schemas.microsoft.com/office/drawing/2014/main" id="{905F9952-D7DB-4432-84AD-4B5ABE9ABE4F}"/>
               </a:ext>
             </a:extLst>
           </p:cNvPr>
@@ -8220,7 +8240,7 @@
           <p:cNvPr id="3" name="">
             <a:extLst xmlns:a="http://schemas.openxmlformats.org/drawingml/2006/main">
               <a:ext uri="{FF2B5EF4-FFF2-40B4-BE49-F238E27FC236}">
-                <a16:creationId xmlns:a16="http://schemas.microsoft.com/office/drawing/2014/main" id="{2E20E14B-6D0E-4331-8DDE-B4107FEAB72D}"/>
+                <a16:creationId xmlns:a16="http://schemas.microsoft.com/office/drawing/2014/main" id="{F0FEB610-EA38-456C-8C88-BDC81675F141}"/>
               </a:ext>
             </a:extLst>
           </p:cNvPr>
@@ -8286,7 +8306,7 @@
           <p:cNvPr id="4" name="">
             <a:extLst xmlns:a="http://schemas.openxmlformats.org/drawingml/2006/main">
               <a:ext uri="{FF2B5EF4-FFF2-40B4-BE49-F238E27FC236}">
-                <a16:creationId xmlns:a16="http://schemas.microsoft.com/office/drawing/2014/main" id="{DB2E0FEE-772C-436B-BF6A-0F0255C63843}"/>
+                <a16:creationId xmlns:a16="http://schemas.microsoft.com/office/drawing/2014/main" id="{7D2A8F95-324C-4B30-92F6-50DBCB75AC44}"/>
               </a:ext>
             </a:extLst>
           </p:cNvPr>
@@ -8352,7 +8372,7 @@
           <p:cNvPr id="5" name="">
             <a:extLst xmlns:a="http://schemas.openxmlformats.org/drawingml/2006/main">
               <a:ext uri="{FF2B5EF4-FFF2-40B4-BE49-F238E27FC236}">
-                <a16:creationId xmlns:a16="http://schemas.microsoft.com/office/drawing/2014/main" id="{6BFD1EFF-0844-4E93-8D70-C6F24C9E532D}"/>
+                <a16:creationId xmlns:a16="http://schemas.microsoft.com/office/drawing/2014/main" id="{103AB7BC-D623-43B8-902D-1A6D15DC090D}"/>
               </a:ext>
             </a:extLst>
           </p:cNvPr>
@@ -8418,7 +8438,7 @@
           <p:cNvPr id="6" name="">
             <a:extLst xmlns:a="http://schemas.openxmlformats.org/drawingml/2006/main">
               <a:ext uri="{FF2B5EF4-FFF2-40B4-BE49-F238E27FC236}">
-                <a16:creationId xmlns:a16="http://schemas.microsoft.com/office/drawing/2014/main" id="{A694AE0F-1FEF-4DBE-86FD-63153898F9C3}"/>
+                <a16:creationId xmlns:a16="http://schemas.microsoft.com/office/drawing/2014/main" id="{6BBBABA9-F9B1-4F7B-82C9-D957F50BF9D6}"/>
               </a:ext>
             </a:extLst>
           </p:cNvPr>
@@ -8484,7 +8504,7 @@
           <p:cNvPr id="7" name="">
             <a:extLst xmlns:a="http://schemas.openxmlformats.org/drawingml/2006/main">
               <a:ext uri="{FF2B5EF4-FFF2-40B4-BE49-F238E27FC236}">
-                <a16:creationId xmlns:a16="http://schemas.microsoft.com/office/drawing/2014/main" id="{DA67A065-0FC9-4AF0-963B-B91D0F3706E2}"/>
+                <a16:creationId xmlns:a16="http://schemas.microsoft.com/office/drawing/2014/main" id="{30C348A1-5D92-4477-94DC-5A83FBD6AF49}"/>
               </a:ext>
             </a:extLst>
           </p:cNvPr>
@@ -8550,7 +8570,7 @@
           <p:cNvPr id="8" name="">
             <a:extLst xmlns:a="http://schemas.openxmlformats.org/drawingml/2006/main">
               <a:ext uri="{FF2B5EF4-FFF2-40B4-BE49-F238E27FC236}">
-                <a16:creationId xmlns:a16="http://schemas.microsoft.com/office/drawing/2014/main" id="{3B5830BC-B718-4CD6-96BA-4DCC1B00C958}"/>
+                <a16:creationId xmlns:a16="http://schemas.microsoft.com/office/drawing/2014/main" id="{71DB4788-DF19-4E77-A5CE-775F653563B6}"/>
               </a:ext>
             </a:extLst>
           </p:cNvPr>
@@ -8616,7 +8636,7 @@
           <p:cNvPr id="9" name="">
             <a:extLst xmlns:a="http://schemas.openxmlformats.org/drawingml/2006/main">
               <a:ext uri="{FF2B5EF4-FFF2-40B4-BE49-F238E27FC236}">
-                <a16:creationId xmlns:a16="http://schemas.microsoft.com/office/drawing/2014/main" id="{F6456D8F-2838-43F4-B0AD-9007559A585C}"/>
+                <a16:creationId xmlns:a16="http://schemas.microsoft.com/office/drawing/2014/main" id="{F8619DFB-6692-42C8-AA20-1DB883D70950}"/>
               </a:ext>
             </a:extLst>
           </p:cNvPr>
@@ -8626,7 +8646,7 @@
           <p:nvPr/>
         </p:nvPicPr>
         <p:blipFill>
-          <a:blip xmlns:r="http://schemas.openxmlformats.org/officeDocument/2006/relationships" xmlns:a="http://schemas.openxmlformats.org/drawingml/2006/main" r:embed="R64214fbb18fd4643"/>
+          <a:blip xmlns:r="http://schemas.openxmlformats.org/officeDocument/2006/relationships" xmlns:a="http://schemas.openxmlformats.org/drawingml/2006/main" r:embed="R2d278f22c4304b47"/>
           <a:stretch xmlns:a="http://schemas.openxmlformats.org/drawingml/2006/main"/>
         </p:blipFill>
         <p:spPr>
@@ -8644,7 +8664,7 @@
           <p:cNvPr id="10" name="">
             <a:extLst xmlns:a="http://schemas.openxmlformats.org/drawingml/2006/main">
               <a:ext uri="{FF2B5EF4-FFF2-40B4-BE49-F238E27FC236}">
-                <a16:creationId xmlns:a16="http://schemas.microsoft.com/office/drawing/2014/main" id="{2A73961A-A834-478E-B1B5-C6BDE5719A78}"/>
+                <a16:creationId xmlns:a16="http://schemas.microsoft.com/office/drawing/2014/main" id="{C1A98B78-D6A8-4CA4-890C-32F07F5EDA2C}"/>
               </a:ext>
             </a:extLst>
           </p:cNvPr>
@@ -8654,7 +8674,7 @@
           <p:nvPr/>
         </p:nvPicPr>
         <p:blipFill>
-          <a:blip xmlns:r="http://schemas.openxmlformats.org/officeDocument/2006/relationships" xmlns:a="http://schemas.openxmlformats.org/drawingml/2006/main" r:embed="R7958f4dbe0144835"/>
+          <a:blip xmlns:r="http://schemas.openxmlformats.org/officeDocument/2006/relationships" xmlns:a="http://schemas.openxmlformats.org/drawingml/2006/main" r:embed="R8ae8d5e38f4e4d79"/>
           <a:stretch xmlns:a="http://schemas.openxmlformats.org/drawingml/2006/main"/>
         </p:blipFill>
         <p:spPr>
@@ -8672,7 +8692,7 @@
           <p:cNvPr id="11" name="">
             <a:extLst xmlns:a="http://schemas.openxmlformats.org/drawingml/2006/main">
               <a:ext uri="{FF2B5EF4-FFF2-40B4-BE49-F238E27FC236}">
-                <a16:creationId xmlns:a16="http://schemas.microsoft.com/office/drawing/2014/main" id="{8C726252-8598-49B4-AC1C-8E39B8C2D07E}"/>
+                <a16:creationId xmlns:a16="http://schemas.microsoft.com/office/drawing/2014/main" id="{AAF402D5-93C0-4B31-BDAD-35870D48A1EA}"/>
               </a:ext>
             </a:extLst>
           </p:cNvPr>
@@ -8682,7 +8702,7 @@
           <p:nvPr/>
         </p:nvPicPr>
         <p:blipFill>
-          <a:blip xmlns:r="http://schemas.openxmlformats.org/officeDocument/2006/relationships" xmlns:a="http://schemas.openxmlformats.org/drawingml/2006/main" r:embed="R1c0e0a904c1e4ec9"/>
+          <a:blip xmlns:r="http://schemas.openxmlformats.org/officeDocument/2006/relationships" xmlns:a="http://schemas.openxmlformats.org/drawingml/2006/main" r:embed="R76dad9476b434835"/>
           <a:stretch xmlns:a="http://schemas.openxmlformats.org/drawingml/2006/main"/>
         </p:blipFill>
         <p:spPr>
@@ -8700,7 +8720,7 @@
           <p:cNvPr id="12" name="">
             <a:extLst xmlns:a="http://schemas.openxmlformats.org/drawingml/2006/main">
               <a:ext uri="{FF2B5EF4-FFF2-40B4-BE49-F238E27FC236}">
-                <a16:creationId xmlns:a16="http://schemas.microsoft.com/office/drawing/2014/main" id="{E8429B21-6BDD-4C55-85B5-2F0914A6B33E}"/>
+                <a16:creationId xmlns:a16="http://schemas.microsoft.com/office/drawing/2014/main" id="{2FE55CA2-9839-4862-A203-78ADBB880706}"/>
               </a:ext>
             </a:extLst>
           </p:cNvPr>
@@ -8710,13 +8730,13 @@
           <p:nvPr/>
         </p:nvPicPr>
         <p:blipFill>
-          <a:blip xmlns:r="http://schemas.openxmlformats.org/officeDocument/2006/relationships" xmlns:a="http://schemas.openxmlformats.org/drawingml/2006/main" r:embed="R1b000d0d9af2439a"/>
+          <a:blip xmlns:r="http://schemas.openxmlformats.org/officeDocument/2006/relationships" xmlns:a="http://schemas.openxmlformats.org/drawingml/2006/main" r:embed="Rc9216b78093f4822"/>
           <a:stretch xmlns:a="http://schemas.openxmlformats.org/drawingml/2006/main"/>
         </p:blipFill>
         <p:spPr>
           <a:xfrm xmlns:a="http://schemas.openxmlformats.org/drawingml/2006/main">
             <a:off x="6953250" y="2933700"/>
-            <a:ext cx="2346293" cy="1278160"/>
+            <a:ext cx="2436305" cy="1278160"/>
           </a:xfrm>
           <a:prstGeom xmlns:a="http://schemas.openxmlformats.org/drawingml/2006/main" prst="rect">
             <a:avLst/>
@@ -8726,7 +8746,7 @@
     </p:spTree>
     <p:extLst>
       <p:ext uri="{BB962C8B-B14F-4D97-AF65-F5344CB8AC3E}">
-        <p14:creationId xmlns:p14="http://schemas.microsoft.com/office/powerpoint/2010/main" val="1142374206"/>
+        <p14:creationId xmlns:p14="http://schemas.microsoft.com/office/powerpoint/2010/main" val="79016371"/>
       </p:ext>
     </p:extLst>
   </p:cSld>
@@ -8757,7 +8777,7 @@
           <p:cNvPr id="13" name="">
             <a:extLst xmlns:a="http://schemas.openxmlformats.org/drawingml/2006/main">
               <a:ext uri="{FF2B5EF4-FFF2-40B4-BE49-F238E27FC236}">
-                <a16:creationId xmlns:a16="http://schemas.microsoft.com/office/drawing/2014/main" id="{3A9FFC82-8082-49D0-A3F8-4FCB35E42EFB}"/>
+                <a16:creationId xmlns:a16="http://schemas.microsoft.com/office/drawing/2014/main" id="{D0347CC2-C95F-4DB8-92AB-055E70895A9B}"/>
               </a:ext>
             </a:extLst>
           </p:cNvPr>
@@ -8823,7 +8843,7 @@
           <p:cNvPr id="2" name="">
             <a:extLst xmlns:a="http://schemas.openxmlformats.org/drawingml/2006/main">
               <a:ext uri="{FF2B5EF4-FFF2-40B4-BE49-F238E27FC236}">
-                <a16:creationId xmlns:a16="http://schemas.microsoft.com/office/drawing/2014/main" id="{26A99827-0801-4D3A-98BE-38651483708A}"/>
+                <a16:creationId xmlns:a16="http://schemas.microsoft.com/office/drawing/2014/main" id="{A961BC22-5F0A-4D98-8C70-0459891A180A}"/>
               </a:ext>
             </a:extLst>
           </p:cNvPr>
@@ -8889,7 +8909,7 @@
           <p:cNvPr id="3" name="">
             <a:extLst xmlns:a="http://schemas.openxmlformats.org/drawingml/2006/main">
               <a:ext uri="{FF2B5EF4-FFF2-40B4-BE49-F238E27FC236}">
-                <a16:creationId xmlns:a16="http://schemas.microsoft.com/office/drawing/2014/main" id="{02F1D490-B260-469C-9ACD-812F0DD83E53}"/>
+                <a16:creationId xmlns:a16="http://schemas.microsoft.com/office/drawing/2014/main" id="{A2AE942A-AC58-40A5-B505-531A3FC62BB5}"/>
               </a:ext>
             </a:extLst>
           </p:cNvPr>
@@ -8955,7 +8975,7 @@
           <p:cNvPr id="4" name="">
             <a:extLst xmlns:a="http://schemas.openxmlformats.org/drawingml/2006/main">
               <a:ext uri="{FF2B5EF4-FFF2-40B4-BE49-F238E27FC236}">
-                <a16:creationId xmlns:a16="http://schemas.microsoft.com/office/drawing/2014/main" id="{8F3C1873-6A03-4515-81F8-9C3ECA534B9F}"/>
+                <a16:creationId xmlns:a16="http://schemas.microsoft.com/office/drawing/2014/main" id="{C5C5FEF8-D9CB-433B-9FA6-CDF92F89A4EA}"/>
               </a:ext>
             </a:extLst>
           </p:cNvPr>
@@ -9021,7 +9041,7 @@
           <p:cNvPr id="5" name="">
             <a:extLst xmlns:a="http://schemas.openxmlformats.org/drawingml/2006/main">
               <a:ext uri="{FF2B5EF4-FFF2-40B4-BE49-F238E27FC236}">
-                <a16:creationId xmlns:a16="http://schemas.microsoft.com/office/drawing/2014/main" id="{03F416AC-240F-40D8-9F26-BAB1544CC76E}"/>
+                <a16:creationId xmlns:a16="http://schemas.microsoft.com/office/drawing/2014/main" id="{8C743CC9-1CDD-4DB2-96A1-30F3E5B3F19B}"/>
               </a:ext>
             </a:extLst>
           </p:cNvPr>
@@ -9087,7 +9107,7 @@
           <p:cNvPr id="6" name="">
             <a:extLst xmlns:a="http://schemas.openxmlformats.org/drawingml/2006/main">
               <a:ext uri="{FF2B5EF4-FFF2-40B4-BE49-F238E27FC236}">
-                <a16:creationId xmlns:a16="http://schemas.microsoft.com/office/drawing/2014/main" id="{4A58BB73-F24A-49B2-A05D-F37E6EA99E56}"/>
+                <a16:creationId xmlns:a16="http://schemas.microsoft.com/office/drawing/2014/main" id="{47E7FE03-3748-4029-8FC2-DF13CCF45F9D}"/>
               </a:ext>
             </a:extLst>
           </p:cNvPr>
@@ -9153,7 +9173,7 @@
           <p:cNvPr id="7" name="">
             <a:extLst xmlns:a="http://schemas.openxmlformats.org/drawingml/2006/main">
               <a:ext uri="{FF2B5EF4-FFF2-40B4-BE49-F238E27FC236}">
-                <a16:creationId xmlns:a16="http://schemas.microsoft.com/office/drawing/2014/main" id="{A6C73B9A-3285-4F47-BFD9-D5DDB7C156FF}"/>
+                <a16:creationId xmlns:a16="http://schemas.microsoft.com/office/drawing/2014/main" id="{64C62012-F114-472E-B17A-F5123F2950D2}"/>
               </a:ext>
             </a:extLst>
           </p:cNvPr>
@@ -9209,7 +9229,7 @@
                 <a:ea typeface="DejaVu Sans"/>
                 <a:cs typeface="DejaVu Sans"/>
               </a:rPr>
-              <a:t>Three-engine reference thrust: 2.535 MN. Entry thrust range: 1.44495–2.028 MN.</a:t>
+              <a:t>The active engine configuration sets recovery reference thrust and the entry throttle bounds.</a:t>
             </a:r>
           </a:p>
         </p:txBody>
@@ -9219,7 +9239,7 @@
           <p:cNvPr id="8" name="">
             <a:extLst xmlns:a="http://schemas.openxmlformats.org/drawingml/2006/main">
               <a:ext uri="{FF2B5EF4-FFF2-40B4-BE49-F238E27FC236}">
-                <a16:creationId xmlns:a16="http://schemas.microsoft.com/office/drawing/2014/main" id="{BB23D6DA-B9CB-4E62-B6EA-3DB16FC2520F}"/>
+                <a16:creationId xmlns:a16="http://schemas.microsoft.com/office/drawing/2014/main" id="{B85FDB1A-E25D-4A19-A5BA-C5A142CA8EDC}"/>
               </a:ext>
             </a:extLst>
           </p:cNvPr>
@@ -9285,7 +9305,7 @@
           <p:cNvPr id="9" name="">
             <a:extLst xmlns:a="http://schemas.openxmlformats.org/drawingml/2006/main">
               <a:ext uri="{FF2B5EF4-FFF2-40B4-BE49-F238E27FC236}">
-                <a16:creationId xmlns:a16="http://schemas.microsoft.com/office/drawing/2014/main" id="{981D5B30-30CA-406E-AFB4-EED72411E0D7}"/>
+                <a16:creationId xmlns:a16="http://schemas.microsoft.com/office/drawing/2014/main" id="{D7E865A8-7AD0-4CD7-B5B6-7E6E1467C97F}"/>
               </a:ext>
             </a:extLst>
           </p:cNvPr>
@@ -9295,7 +9315,7 @@
           <p:nvPr/>
         </p:nvPicPr>
         <p:blipFill>
-          <a:blip xmlns:r="http://schemas.openxmlformats.org/officeDocument/2006/relationships" xmlns:a="http://schemas.openxmlformats.org/drawingml/2006/main" r:embed="Ra41448cfcf8845a6"/>
+          <a:blip xmlns:r="http://schemas.openxmlformats.org/officeDocument/2006/relationships" xmlns:a="http://schemas.openxmlformats.org/drawingml/2006/main" r:embed="Rbc738b54c8ce420b"/>
           <a:stretch xmlns:a="http://schemas.openxmlformats.org/drawingml/2006/main"/>
         </p:blipFill>
         <p:spPr>
@@ -9313,7 +9333,7 @@
           <p:cNvPr id="10" name="">
             <a:extLst xmlns:a="http://schemas.openxmlformats.org/drawingml/2006/main">
               <a:ext uri="{FF2B5EF4-FFF2-40B4-BE49-F238E27FC236}">
-                <a16:creationId xmlns:a16="http://schemas.microsoft.com/office/drawing/2014/main" id="{ECC4DA8B-AD41-48DD-841E-C0CB331A37A6}"/>
+                <a16:creationId xmlns:a16="http://schemas.microsoft.com/office/drawing/2014/main" id="{797E81D9-3931-44BF-ABE6-19025B1D846D}"/>
               </a:ext>
             </a:extLst>
           </p:cNvPr>
@@ -9323,7 +9343,7 @@
           <p:nvPr/>
         </p:nvPicPr>
         <p:blipFill>
-          <a:blip xmlns:r="http://schemas.openxmlformats.org/officeDocument/2006/relationships" xmlns:a="http://schemas.openxmlformats.org/drawingml/2006/main" r:embed="Rf194467f9f4942f0"/>
+          <a:blip xmlns:r="http://schemas.openxmlformats.org/officeDocument/2006/relationships" xmlns:a="http://schemas.openxmlformats.org/drawingml/2006/main" r:embed="R71ad5147bec94e40"/>
           <a:stretch xmlns:a="http://schemas.openxmlformats.org/drawingml/2006/main"/>
         </p:blipFill>
         <p:spPr>
@@ -9341,7 +9361,7 @@
           <p:cNvPr id="11" name="">
             <a:extLst xmlns:a="http://schemas.openxmlformats.org/drawingml/2006/main">
               <a:ext uri="{FF2B5EF4-FFF2-40B4-BE49-F238E27FC236}">
-                <a16:creationId xmlns:a16="http://schemas.microsoft.com/office/drawing/2014/main" id="{0AB5EFE0-430B-48CB-8BB6-474E939E15B8}"/>
+                <a16:creationId xmlns:a16="http://schemas.microsoft.com/office/drawing/2014/main" id="{4DDEFA95-40A1-4ECC-AA3A-385ABB508876}"/>
               </a:ext>
             </a:extLst>
           </p:cNvPr>
@@ -9351,13 +9371,13 @@
           <p:nvPr/>
         </p:nvPicPr>
         <p:blipFill>
-          <a:blip xmlns:r="http://schemas.openxmlformats.org/officeDocument/2006/relationships" xmlns:a="http://schemas.openxmlformats.org/drawingml/2006/main" r:embed="R827f2f50c153463b"/>
+          <a:blip xmlns:r="http://schemas.openxmlformats.org/officeDocument/2006/relationships" xmlns:a="http://schemas.openxmlformats.org/drawingml/2006/main" r:embed="Re5b4f64db8174562"/>
           <a:stretch xmlns:a="http://schemas.openxmlformats.org/drawingml/2006/main"/>
         </p:blipFill>
         <p:spPr>
           <a:xfrm xmlns:a="http://schemas.openxmlformats.org/drawingml/2006/main">
             <a:off x="609600" y="2933700"/>
-            <a:ext cx="3010662" cy="2235708"/>
+            <a:ext cx="3010662" cy="2249424"/>
           </a:xfrm>
           <a:prstGeom xmlns:a="http://schemas.openxmlformats.org/drawingml/2006/main" prst="rect">
             <a:avLst/>
@@ -9369,7 +9389,7 @@
           <p:cNvPr id="12" name="">
             <a:extLst xmlns:a="http://schemas.openxmlformats.org/drawingml/2006/main">
               <a:ext uri="{FF2B5EF4-FFF2-40B4-BE49-F238E27FC236}">
-                <a16:creationId xmlns:a16="http://schemas.microsoft.com/office/drawing/2014/main" id="{708E7000-E29B-4D21-A2DE-263F1DDA9E3B}"/>
+                <a16:creationId xmlns:a16="http://schemas.microsoft.com/office/drawing/2014/main" id="{85EEBE5B-6A10-49ED-B5BD-F1B31597A4DF}"/>
               </a:ext>
             </a:extLst>
           </p:cNvPr>
@@ -9379,13 +9399,13 @@
           <p:nvPr/>
         </p:nvPicPr>
         <p:blipFill>
-          <a:blip xmlns:r="http://schemas.openxmlformats.org/officeDocument/2006/relationships" xmlns:a="http://schemas.openxmlformats.org/drawingml/2006/main" r:embed="R6a63432c4dca47ad"/>
+          <a:blip xmlns:r="http://schemas.openxmlformats.org/officeDocument/2006/relationships" xmlns:a="http://schemas.openxmlformats.org/drawingml/2006/main" r:embed="R2abf351431b74e95"/>
           <a:stretch xmlns:a="http://schemas.openxmlformats.org/drawingml/2006/main"/>
         </p:blipFill>
         <p:spPr>
           <a:xfrm xmlns:a="http://schemas.openxmlformats.org/drawingml/2006/main">
             <a:off x="6953250" y="2933700"/>
-            <a:ext cx="4524566" cy="1764221"/>
+            <a:ext cx="4134517" cy="1728216"/>
           </a:xfrm>
           <a:prstGeom xmlns:a="http://schemas.openxmlformats.org/drawingml/2006/main" prst="rect">
             <a:avLst/>
@@ -9395,7 +9415,7 @@
     </p:spTree>
     <p:extLst>
       <p:ext uri="{BB962C8B-B14F-4D97-AF65-F5344CB8AC3E}">
-        <p14:creationId xmlns:p14="http://schemas.microsoft.com/office/powerpoint/2010/main" val="655603694"/>
+        <p14:creationId xmlns:p14="http://schemas.microsoft.com/office/powerpoint/2010/main" val="937939676"/>
       </p:ext>
     </p:extLst>
   </p:cSld>
@@ -9426,7 +9446,7 @@
           <p:cNvPr id="13" name="">
             <a:extLst xmlns:a="http://schemas.openxmlformats.org/drawingml/2006/main">
               <a:ext uri="{FF2B5EF4-FFF2-40B4-BE49-F238E27FC236}">
-                <a16:creationId xmlns:a16="http://schemas.microsoft.com/office/drawing/2014/main" id="{3ECC1F02-EBF8-4B62-8B43-9E18372468A7}"/>
+                <a16:creationId xmlns:a16="http://schemas.microsoft.com/office/drawing/2014/main" id="{7D454487-630E-42F4-A7C4-060E6C7130B4}"/>
               </a:ext>
             </a:extLst>
           </p:cNvPr>
@@ -9492,7 +9512,7 @@
           <p:cNvPr id="2" name="">
             <a:extLst xmlns:a="http://schemas.openxmlformats.org/drawingml/2006/main">
               <a:ext uri="{FF2B5EF4-FFF2-40B4-BE49-F238E27FC236}">
-                <a16:creationId xmlns:a16="http://schemas.microsoft.com/office/drawing/2014/main" id="{2A202ED7-18E4-45BE-A446-A83D6BC1247C}"/>
+                <a16:creationId xmlns:a16="http://schemas.microsoft.com/office/drawing/2014/main" id="{D2E13EA2-C4AA-4757-8D47-BCC58878425B}"/>
               </a:ext>
             </a:extLst>
           </p:cNvPr>
@@ -9558,7 +9578,7 @@
           <p:cNvPr id="3" name="">
             <a:extLst xmlns:a="http://schemas.openxmlformats.org/drawingml/2006/main">
               <a:ext uri="{FF2B5EF4-FFF2-40B4-BE49-F238E27FC236}">
-                <a16:creationId xmlns:a16="http://schemas.microsoft.com/office/drawing/2014/main" id="{0EEE8F5B-9590-4DA2-A967-5499A0FD38D6}"/>
+                <a16:creationId xmlns:a16="http://schemas.microsoft.com/office/drawing/2014/main" id="{D693D4F3-5C7F-479D-ACDF-2A3CAB3F89A1}"/>
               </a:ext>
             </a:extLst>
           </p:cNvPr>
@@ -9624,7 +9644,7 @@
           <p:cNvPr id="4" name="">
             <a:extLst xmlns:a="http://schemas.openxmlformats.org/drawingml/2006/main">
               <a:ext uri="{FF2B5EF4-FFF2-40B4-BE49-F238E27FC236}">
-                <a16:creationId xmlns:a16="http://schemas.microsoft.com/office/drawing/2014/main" id="{627419FE-8121-4B9E-9FCE-A8A383649B36}"/>
+                <a16:creationId xmlns:a16="http://schemas.microsoft.com/office/drawing/2014/main" id="{D5BD5876-C5DD-4934-88DC-0D49B592F95C}"/>
               </a:ext>
             </a:extLst>
           </p:cNvPr>
@@ -9690,7 +9710,7 @@
           <p:cNvPr id="5" name="">
             <a:extLst xmlns:a="http://schemas.openxmlformats.org/drawingml/2006/main">
               <a:ext uri="{FF2B5EF4-FFF2-40B4-BE49-F238E27FC236}">
-                <a16:creationId xmlns:a16="http://schemas.microsoft.com/office/drawing/2014/main" id="{017A32C3-83F4-4B5B-B822-04493FB79F10}"/>
+                <a16:creationId xmlns:a16="http://schemas.microsoft.com/office/drawing/2014/main" id="{137DB4FF-1498-460A-A37C-6FEA70582093}"/>
               </a:ext>
             </a:extLst>
           </p:cNvPr>
@@ -9756,7 +9776,7 @@
           <p:cNvPr id="6" name="">
             <a:extLst xmlns:a="http://schemas.openxmlformats.org/drawingml/2006/main">
               <a:ext uri="{FF2B5EF4-FFF2-40B4-BE49-F238E27FC236}">
-                <a16:creationId xmlns:a16="http://schemas.microsoft.com/office/drawing/2014/main" id="{423F8B64-5F14-42B9-934C-08E9EAA9F679}"/>
+                <a16:creationId xmlns:a16="http://schemas.microsoft.com/office/drawing/2014/main" id="{CAB54BC0-56D4-4FB3-A219-20B9014FDB54}"/>
               </a:ext>
             </a:extLst>
           </p:cNvPr>
@@ -9822,7 +9842,7 @@
           <p:cNvPr id="7" name="">
             <a:extLst xmlns:a="http://schemas.openxmlformats.org/drawingml/2006/main">
               <a:ext uri="{FF2B5EF4-FFF2-40B4-BE49-F238E27FC236}">
-                <a16:creationId xmlns:a16="http://schemas.microsoft.com/office/drawing/2014/main" id="{5DF11C28-0933-4C25-9347-89B00BCE33CC}"/>
+                <a16:creationId xmlns:a16="http://schemas.microsoft.com/office/drawing/2014/main" id="{97553B90-7951-479D-BA9B-641D279FC4B7}"/>
               </a:ext>
             </a:extLst>
           </p:cNvPr>
@@ -9888,7 +9908,7 @@
           <p:cNvPr id="8" name="">
             <a:extLst xmlns:a="http://schemas.openxmlformats.org/drawingml/2006/main">
               <a:ext uri="{FF2B5EF4-FFF2-40B4-BE49-F238E27FC236}">
-                <a16:creationId xmlns:a16="http://schemas.microsoft.com/office/drawing/2014/main" id="{4EC690CA-1B90-4747-8B6B-67A08439EFC4}"/>
+                <a16:creationId xmlns:a16="http://schemas.microsoft.com/office/drawing/2014/main" id="{E9FD5BBD-729D-4602-B3BC-52CBB0E52034}"/>
               </a:ext>
             </a:extLst>
           </p:cNvPr>
@@ -9954,7 +9974,7 @@
           <p:cNvPr id="9" name="">
             <a:extLst xmlns:a="http://schemas.openxmlformats.org/drawingml/2006/main">
               <a:ext uri="{FF2B5EF4-FFF2-40B4-BE49-F238E27FC236}">
-                <a16:creationId xmlns:a16="http://schemas.microsoft.com/office/drawing/2014/main" id="{EF2B1992-01BB-4281-9193-F9DE008A854D}"/>
+                <a16:creationId xmlns:a16="http://schemas.microsoft.com/office/drawing/2014/main" id="{69FF1AA3-C4AD-42A6-A8B9-EE98B04E9B4E}"/>
               </a:ext>
             </a:extLst>
           </p:cNvPr>
@@ -9964,7 +9984,7 @@
           <p:nvPr/>
         </p:nvPicPr>
         <p:blipFill>
-          <a:blip xmlns:r="http://schemas.openxmlformats.org/officeDocument/2006/relationships" xmlns:a="http://schemas.openxmlformats.org/drawingml/2006/main" r:embed="Rbb78b9414fbd4e64"/>
+          <a:blip xmlns:r="http://schemas.openxmlformats.org/officeDocument/2006/relationships" xmlns:a="http://schemas.openxmlformats.org/drawingml/2006/main" r:embed="Red189fc4c1694489"/>
           <a:stretch xmlns:a="http://schemas.openxmlformats.org/drawingml/2006/main"/>
         </p:blipFill>
         <p:spPr>
@@ -9982,7 +10002,7 @@
           <p:cNvPr id="10" name="">
             <a:extLst xmlns:a="http://schemas.openxmlformats.org/drawingml/2006/main">
               <a:ext uri="{FF2B5EF4-FFF2-40B4-BE49-F238E27FC236}">
-                <a16:creationId xmlns:a16="http://schemas.microsoft.com/office/drawing/2014/main" id="{9C7EEFA2-71DD-4025-AA97-164313934B7C}"/>
+                <a16:creationId xmlns:a16="http://schemas.microsoft.com/office/drawing/2014/main" id="{060CEBCF-2B96-4137-A2B5-0176837B7FC2}"/>
               </a:ext>
             </a:extLst>
           </p:cNvPr>
@@ -9992,7 +10012,7 @@
           <p:nvPr/>
         </p:nvPicPr>
         <p:blipFill>
-          <a:blip xmlns:r="http://schemas.openxmlformats.org/officeDocument/2006/relationships" xmlns:a="http://schemas.openxmlformats.org/drawingml/2006/main" r:embed="Racb56538a280463e"/>
+          <a:blip xmlns:r="http://schemas.openxmlformats.org/officeDocument/2006/relationships" xmlns:a="http://schemas.openxmlformats.org/drawingml/2006/main" r:embed="R4b797d1fe5664964"/>
           <a:stretch xmlns:a="http://schemas.openxmlformats.org/drawingml/2006/main"/>
         </p:blipFill>
         <p:spPr>
@@ -10010,7 +10030,7 @@
           <p:cNvPr id="11" name="">
             <a:extLst xmlns:a="http://schemas.openxmlformats.org/drawingml/2006/main">
               <a:ext uri="{FF2B5EF4-FFF2-40B4-BE49-F238E27FC236}">
-                <a16:creationId xmlns:a16="http://schemas.microsoft.com/office/drawing/2014/main" id="{C58205DE-2632-4117-9123-3E96B64025B5}"/>
+                <a16:creationId xmlns:a16="http://schemas.microsoft.com/office/drawing/2014/main" id="{38059AF2-7863-4A9D-A4C4-A70C664D2261}"/>
               </a:ext>
             </a:extLst>
           </p:cNvPr>
@@ -10020,7 +10040,7 @@
           <p:nvPr/>
         </p:nvPicPr>
         <p:blipFill>
-          <a:blip xmlns:r="http://schemas.openxmlformats.org/officeDocument/2006/relationships" xmlns:a="http://schemas.openxmlformats.org/drawingml/2006/main" r:embed="Rdbea7a4099184134"/>
+          <a:blip xmlns:r="http://schemas.openxmlformats.org/officeDocument/2006/relationships" xmlns:a="http://schemas.openxmlformats.org/drawingml/2006/main" r:embed="Raae62361ff3f47ef"/>
           <a:stretch xmlns:a="http://schemas.openxmlformats.org/drawingml/2006/main"/>
         </p:blipFill>
         <p:spPr>
@@ -10038,7 +10058,7 @@
           <p:cNvPr id="12" name="">
             <a:extLst xmlns:a="http://schemas.openxmlformats.org/drawingml/2006/main">
               <a:ext uri="{FF2B5EF4-FFF2-40B4-BE49-F238E27FC236}">
-                <a16:creationId xmlns:a16="http://schemas.microsoft.com/office/drawing/2014/main" id="{4D81F857-5CE8-49C7-8E83-4EC4479972E1}"/>
+                <a16:creationId xmlns:a16="http://schemas.microsoft.com/office/drawing/2014/main" id="{39F7CCC1-412B-4956-8362-64EEFFAB9F06}"/>
               </a:ext>
             </a:extLst>
           </p:cNvPr>
@@ -10048,13 +10068,13 @@
           <p:nvPr/>
         </p:nvPicPr>
         <p:blipFill>
-          <a:blip xmlns:r="http://schemas.openxmlformats.org/officeDocument/2006/relationships" xmlns:a="http://schemas.openxmlformats.org/drawingml/2006/main" r:embed="Rcf9540ef7c35437b"/>
+          <a:blip xmlns:r="http://schemas.openxmlformats.org/officeDocument/2006/relationships" xmlns:a="http://schemas.openxmlformats.org/drawingml/2006/main" r:embed="R5a850914903d43ba"/>
           <a:stretch xmlns:a="http://schemas.openxmlformats.org/drawingml/2006/main"/>
         </p:blipFill>
         <p:spPr>
           <a:xfrm xmlns:a="http://schemas.openxmlformats.org/drawingml/2006/main">
             <a:off x="6953250" y="2933700"/>
-            <a:ext cx="2796350" cy="1314164"/>
+            <a:ext cx="2622328" cy="1278160"/>
           </a:xfrm>
           <a:prstGeom xmlns:a="http://schemas.openxmlformats.org/drawingml/2006/main" prst="rect">
             <a:avLst/>
@@ -10064,7 +10084,7 @@
     </p:spTree>
     <p:extLst>
       <p:ext uri="{BB962C8B-B14F-4D97-AF65-F5344CB8AC3E}">
-        <p14:creationId xmlns:p14="http://schemas.microsoft.com/office/powerpoint/2010/main" val="418431479"/>
+        <p14:creationId xmlns:p14="http://schemas.microsoft.com/office/powerpoint/2010/main" val="164334965"/>
       </p:ext>
     </p:extLst>
   </p:cSld>
@@ -10095,7 +10115,7 @@
           <p:cNvPr id="13" name="">
             <a:extLst xmlns:a="http://schemas.openxmlformats.org/drawingml/2006/main">
               <a:ext uri="{FF2B5EF4-FFF2-40B4-BE49-F238E27FC236}">
-                <a16:creationId xmlns:a16="http://schemas.microsoft.com/office/drawing/2014/main" id="{C0863FA5-8D98-4B55-9231-B807C4A21B15}"/>
+                <a16:creationId xmlns:a16="http://schemas.microsoft.com/office/drawing/2014/main" id="{7E6B0F09-9EF8-444C-88CF-018321838261}"/>
               </a:ext>
             </a:extLst>
           </p:cNvPr>
@@ -10161,7 +10181,7 @@
           <p:cNvPr id="2" name="">
             <a:extLst xmlns:a="http://schemas.openxmlformats.org/drawingml/2006/main">
               <a:ext uri="{FF2B5EF4-FFF2-40B4-BE49-F238E27FC236}">
-                <a16:creationId xmlns:a16="http://schemas.microsoft.com/office/drawing/2014/main" id="{F14480CB-58E2-40E6-8BF7-5A51EB176C12}"/>
+                <a16:creationId xmlns:a16="http://schemas.microsoft.com/office/drawing/2014/main" id="{490C0D0E-E70F-436C-B70D-BAE65C65BACA}"/>
               </a:ext>
             </a:extLst>
           </p:cNvPr>
@@ -10227,7 +10247,7 @@
           <p:cNvPr id="3" name="">
             <a:extLst xmlns:a="http://schemas.openxmlformats.org/drawingml/2006/main">
               <a:ext uri="{FF2B5EF4-FFF2-40B4-BE49-F238E27FC236}">
-                <a16:creationId xmlns:a16="http://schemas.microsoft.com/office/drawing/2014/main" id="{DC8996C4-D19A-48B1-B30A-18F037FA416C}"/>
+                <a16:creationId xmlns:a16="http://schemas.microsoft.com/office/drawing/2014/main" id="{590D9EBC-3FF3-4C83-B364-C25378DBCAEE}"/>
               </a:ext>
             </a:extLst>
           </p:cNvPr>
@@ -10293,7 +10313,7 @@
           <p:cNvPr id="4" name="">
             <a:extLst xmlns:a="http://schemas.openxmlformats.org/drawingml/2006/main">
               <a:ext uri="{FF2B5EF4-FFF2-40B4-BE49-F238E27FC236}">
-                <a16:creationId xmlns:a16="http://schemas.microsoft.com/office/drawing/2014/main" id="{D2FE3265-7D7E-4F34-9775-023EAAFAB508}"/>
+                <a16:creationId xmlns:a16="http://schemas.microsoft.com/office/drawing/2014/main" id="{3B0B90A0-B169-4A8A-AD86-EE62E16A985E}"/>
               </a:ext>
             </a:extLst>
           </p:cNvPr>
@@ -10359,7 +10379,7 @@
           <p:cNvPr id="5" name="">
             <a:extLst xmlns:a="http://schemas.openxmlformats.org/drawingml/2006/main">
               <a:ext uri="{FF2B5EF4-FFF2-40B4-BE49-F238E27FC236}">
-                <a16:creationId xmlns:a16="http://schemas.microsoft.com/office/drawing/2014/main" id="{7197F882-55C2-410D-BD8E-B687240BB93D}"/>
+                <a16:creationId xmlns:a16="http://schemas.microsoft.com/office/drawing/2014/main" id="{42FBF059-1CEE-41A5-98A3-31A392B7C92E}"/>
               </a:ext>
             </a:extLst>
           </p:cNvPr>
@@ -10425,7 +10445,7 @@
           <p:cNvPr id="6" name="">
             <a:extLst xmlns:a="http://schemas.openxmlformats.org/drawingml/2006/main">
               <a:ext uri="{FF2B5EF4-FFF2-40B4-BE49-F238E27FC236}">
-                <a16:creationId xmlns:a16="http://schemas.microsoft.com/office/drawing/2014/main" id="{A9C4BCA0-047F-4BF0-AEAB-74A11296A839}"/>
+                <a16:creationId xmlns:a16="http://schemas.microsoft.com/office/drawing/2014/main" id="{0737D510-573F-40A0-86FD-799E69105B61}"/>
               </a:ext>
             </a:extLst>
           </p:cNvPr>
@@ -10491,7 +10511,7 @@
           <p:cNvPr id="7" name="">
             <a:extLst xmlns:a="http://schemas.openxmlformats.org/drawingml/2006/main">
               <a:ext uri="{FF2B5EF4-FFF2-40B4-BE49-F238E27FC236}">
-                <a16:creationId xmlns:a16="http://schemas.microsoft.com/office/drawing/2014/main" id="{6825677D-C708-45DB-8DAE-0A48051D94EB}"/>
+                <a16:creationId xmlns:a16="http://schemas.microsoft.com/office/drawing/2014/main" id="{4E6ED14F-530D-4E16-8548-3CDFA1EF238C}"/>
               </a:ext>
             </a:extLst>
           </p:cNvPr>
@@ -10547,7 +10567,7 @@
                 <a:ea typeface="DejaVu Sans"/>
                 <a:cs typeface="DejaVu Sans"/>
               </a:rPr>
-              <a:t>Recovery reference: 2.535 MN. Landing thrust: approximately 62.709–845 kN. ASDS leaves downrange free.</a:t>
+              <a:t>Configured landing throttle bounds set thrust capacity. ASDS leaves downrange position free.</a:t>
             </a:r>
           </a:p>
         </p:txBody>
@@ -10557,7 +10577,7 @@
           <p:cNvPr id="8" name="">
             <a:extLst xmlns:a="http://schemas.openxmlformats.org/drawingml/2006/main">
               <a:ext uri="{FF2B5EF4-FFF2-40B4-BE49-F238E27FC236}">
-                <a16:creationId xmlns:a16="http://schemas.microsoft.com/office/drawing/2014/main" id="{FEF07220-9122-4857-93A1-54205746122E}"/>
+                <a16:creationId xmlns:a16="http://schemas.microsoft.com/office/drawing/2014/main" id="{6C760C33-5938-4A9B-AA1C-CCED80010A38}"/>
               </a:ext>
             </a:extLst>
           </p:cNvPr>
@@ -10623,7 +10643,7 @@
           <p:cNvPr id="9" name="">
             <a:extLst xmlns:a="http://schemas.openxmlformats.org/drawingml/2006/main">
               <a:ext uri="{FF2B5EF4-FFF2-40B4-BE49-F238E27FC236}">
-                <a16:creationId xmlns:a16="http://schemas.microsoft.com/office/drawing/2014/main" id="{01808430-9C97-4632-8B44-234C4531786F}"/>
+                <a16:creationId xmlns:a16="http://schemas.microsoft.com/office/drawing/2014/main" id="{DE596D25-1221-4DF3-A906-D29D68321CB9}"/>
               </a:ext>
             </a:extLst>
           </p:cNvPr>
@@ -10633,7 +10653,7 @@
           <p:nvPr/>
         </p:nvPicPr>
         <p:blipFill>
-          <a:blip xmlns:r="http://schemas.openxmlformats.org/officeDocument/2006/relationships" xmlns:a="http://schemas.openxmlformats.org/drawingml/2006/main" r:embed="Rf73270881dc54e61"/>
+          <a:blip xmlns:r="http://schemas.openxmlformats.org/officeDocument/2006/relationships" xmlns:a="http://schemas.openxmlformats.org/drawingml/2006/main" r:embed="R43bbe72722954319"/>
           <a:stretch xmlns:a="http://schemas.openxmlformats.org/drawingml/2006/main"/>
         </p:blipFill>
         <p:spPr>
@@ -10651,7 +10671,7 @@
           <p:cNvPr id="10" name="">
             <a:extLst xmlns:a="http://schemas.openxmlformats.org/drawingml/2006/main">
               <a:ext uri="{FF2B5EF4-FFF2-40B4-BE49-F238E27FC236}">
-                <a16:creationId xmlns:a16="http://schemas.microsoft.com/office/drawing/2014/main" id="{6B6103C7-6D61-4394-A120-597DB58AEB75}"/>
+                <a16:creationId xmlns:a16="http://schemas.microsoft.com/office/drawing/2014/main" id="{0C091FFB-9EF2-49A4-820A-DB2F5DFFE724}"/>
               </a:ext>
             </a:extLst>
           </p:cNvPr>
@@ -10661,7 +10681,7 @@
           <p:nvPr/>
         </p:nvPicPr>
         <p:blipFill>
-          <a:blip xmlns:r="http://schemas.openxmlformats.org/officeDocument/2006/relationships" xmlns:a="http://schemas.openxmlformats.org/drawingml/2006/main" r:embed="R5de04bcb95534b0e"/>
+          <a:blip xmlns:r="http://schemas.openxmlformats.org/officeDocument/2006/relationships" xmlns:a="http://schemas.openxmlformats.org/drawingml/2006/main" r:embed="R4307d178c8e0494c"/>
           <a:stretch xmlns:a="http://schemas.openxmlformats.org/drawingml/2006/main"/>
         </p:blipFill>
         <p:spPr>
@@ -10679,7 +10699,7 @@
           <p:cNvPr id="11" name="">
             <a:extLst xmlns:a="http://schemas.openxmlformats.org/drawingml/2006/main">
               <a:ext uri="{FF2B5EF4-FFF2-40B4-BE49-F238E27FC236}">
-                <a16:creationId xmlns:a16="http://schemas.microsoft.com/office/drawing/2014/main" id="{4807F51B-B1D0-4343-85A4-D04FF0134D83}"/>
+                <a16:creationId xmlns:a16="http://schemas.microsoft.com/office/drawing/2014/main" id="{5E5EE215-9899-4D0D-8A36-5AB67785E0C7}"/>
               </a:ext>
             </a:extLst>
           </p:cNvPr>
@@ -10689,13 +10709,13 @@
           <p:nvPr/>
         </p:nvPicPr>
         <p:blipFill>
-          <a:blip xmlns:r="http://schemas.openxmlformats.org/officeDocument/2006/relationships" xmlns:a="http://schemas.openxmlformats.org/drawingml/2006/main" r:embed="Rad7f0c6a7aa04b04"/>
+          <a:blip xmlns:r="http://schemas.openxmlformats.org/officeDocument/2006/relationships" xmlns:a="http://schemas.openxmlformats.org/drawingml/2006/main" r:embed="Rdd669630dba64196"/>
           <a:stretch xmlns:a="http://schemas.openxmlformats.org/drawingml/2006/main"/>
         </p:blipFill>
         <p:spPr>
           <a:xfrm xmlns:a="http://schemas.openxmlformats.org/drawingml/2006/main">
             <a:off x="609600" y="2933700"/>
-            <a:ext cx="3010662" cy="2235708"/>
+            <a:ext cx="3010662" cy="2249424"/>
           </a:xfrm>
           <a:prstGeom xmlns:a="http://schemas.openxmlformats.org/drawingml/2006/main" prst="rect">
             <a:avLst/>
@@ -10707,7 +10727,7 @@
           <p:cNvPr id="12" name="">
             <a:extLst xmlns:a="http://schemas.openxmlformats.org/drawingml/2006/main">
               <a:ext uri="{FF2B5EF4-FFF2-40B4-BE49-F238E27FC236}">
-                <a16:creationId xmlns:a16="http://schemas.microsoft.com/office/drawing/2014/main" id="{3D1963CF-1FF0-4376-9321-6C7C65E87531}"/>
+                <a16:creationId xmlns:a16="http://schemas.microsoft.com/office/drawing/2014/main" id="{7432D6B7-A1F5-4850-9F46-51B3DBCE1A8A}"/>
               </a:ext>
             </a:extLst>
           </p:cNvPr>
@@ -10717,13 +10737,13 @@
           <p:nvPr/>
         </p:nvPicPr>
         <p:blipFill>
-          <a:blip xmlns:r="http://schemas.openxmlformats.org/officeDocument/2006/relationships" xmlns:a="http://schemas.openxmlformats.org/drawingml/2006/main" r:embed="R78ca975d8bc14df1"/>
+          <a:blip xmlns:r="http://schemas.openxmlformats.org/officeDocument/2006/relationships" xmlns:a="http://schemas.openxmlformats.org/drawingml/2006/main" r:embed="R32389cdffcb94933"/>
           <a:stretch xmlns:a="http://schemas.openxmlformats.org/drawingml/2006/main"/>
         </p:blipFill>
         <p:spPr>
           <a:xfrm xmlns:a="http://schemas.openxmlformats.org/drawingml/2006/main">
             <a:off x="6953250" y="2933700"/>
-            <a:ext cx="3720957" cy="2524125"/>
+            <a:ext cx="3605071" cy="2524125"/>
           </a:xfrm>
           <a:prstGeom xmlns:a="http://schemas.openxmlformats.org/drawingml/2006/main" prst="rect">
             <a:avLst/>
@@ -10733,7 +10753,7 @@
     </p:spTree>
     <p:extLst>
       <p:ext uri="{BB962C8B-B14F-4D97-AF65-F5344CB8AC3E}">
-        <p14:creationId xmlns:p14="http://schemas.microsoft.com/office/powerpoint/2010/main" val="1156645134"/>
+        <p14:creationId xmlns:p14="http://schemas.microsoft.com/office/powerpoint/2010/main" val="345256509"/>
       </p:ext>
     </p:extLst>
   </p:cSld>
@@ -10764,7 +10784,7 @@
           <p:cNvPr id="33" name="">
             <a:extLst xmlns:a="http://schemas.openxmlformats.org/drawingml/2006/main">
               <a:ext uri="{FF2B5EF4-FFF2-40B4-BE49-F238E27FC236}">
-                <a16:creationId xmlns:a16="http://schemas.microsoft.com/office/drawing/2014/main" id="{7294C0FD-1732-4BE9-A6BE-F59F74CB722A}"/>
+                <a16:creationId xmlns:a16="http://schemas.microsoft.com/office/drawing/2014/main" id="{6B375467-1EAB-4ECE-8849-9971569BBEE2}"/>
               </a:ext>
             </a:extLst>
           </p:cNvPr>
@@ -10795,7 +10815,7 @@
           <p:cNvPr id="32" name="">
             <a:extLst xmlns:a="http://schemas.openxmlformats.org/drawingml/2006/main">
               <a:ext uri="{FF2B5EF4-FFF2-40B4-BE49-F238E27FC236}">
-                <a16:creationId xmlns:a16="http://schemas.microsoft.com/office/drawing/2014/main" id="{7423FEF6-D6A7-4FF5-A4EB-8919F8499A29}"/>
+                <a16:creationId xmlns:a16="http://schemas.microsoft.com/office/drawing/2014/main" id="{4DAC4378-5000-41FA-86DC-39395F26505C}"/>
               </a:ext>
             </a:extLst>
           </p:cNvPr>
@@ -10826,7 +10846,7 @@
           <p:cNvPr id="31" name="">
             <a:extLst xmlns:a="http://schemas.openxmlformats.org/drawingml/2006/main">
               <a:ext uri="{FF2B5EF4-FFF2-40B4-BE49-F238E27FC236}">
-                <a16:creationId xmlns:a16="http://schemas.microsoft.com/office/drawing/2014/main" id="{4029D2F1-42A6-4196-980B-7AAD67914D4A}"/>
+                <a16:creationId xmlns:a16="http://schemas.microsoft.com/office/drawing/2014/main" id="{030A9DB8-E068-4EA1-AB2F-AB4D26DD6A2D}"/>
               </a:ext>
             </a:extLst>
           </p:cNvPr>
@@ -10857,7 +10877,7 @@
           <p:cNvPr id="21" name="">
             <a:extLst xmlns:a="http://schemas.openxmlformats.org/drawingml/2006/main">
               <a:ext uri="{FF2B5EF4-FFF2-40B4-BE49-F238E27FC236}">
-                <a16:creationId xmlns:a16="http://schemas.microsoft.com/office/drawing/2014/main" id="{356CE998-6243-4B52-80C7-3E65BC9C5C9F}"/>
+                <a16:creationId xmlns:a16="http://schemas.microsoft.com/office/drawing/2014/main" id="{5D145560-3C5A-4C4E-BCB4-931DE1631C30}"/>
               </a:ext>
             </a:extLst>
           </p:cNvPr>
@@ -10888,7 +10908,7 @@
           <p:cNvPr id="20" name="">
             <a:extLst xmlns:a="http://schemas.openxmlformats.org/drawingml/2006/main">
               <a:ext uri="{FF2B5EF4-FFF2-40B4-BE49-F238E27FC236}">
-                <a16:creationId xmlns:a16="http://schemas.microsoft.com/office/drawing/2014/main" id="{12995957-5E3C-467C-BE43-73EADAA39A22}"/>
+                <a16:creationId xmlns:a16="http://schemas.microsoft.com/office/drawing/2014/main" id="{C85FEF30-B9FE-4C72-9D80-071CDDDAB94B}"/>
               </a:ext>
             </a:extLst>
           </p:cNvPr>
@@ -10919,7 +10939,7 @@
           <p:cNvPr id="19" name="">
             <a:extLst xmlns:a="http://schemas.openxmlformats.org/drawingml/2006/main">
               <a:ext uri="{FF2B5EF4-FFF2-40B4-BE49-F238E27FC236}">
-                <a16:creationId xmlns:a16="http://schemas.microsoft.com/office/drawing/2014/main" id="{0E345DDE-0C5E-4833-9C18-AD6FF2309F52}"/>
+                <a16:creationId xmlns:a16="http://schemas.microsoft.com/office/drawing/2014/main" id="{4895C6EF-3C71-43A4-B2E8-B179C81A2BD6}"/>
               </a:ext>
             </a:extLst>
           </p:cNvPr>
@@ -10950,7 +10970,7 @@
           <p:cNvPr id="9" name="">
             <a:extLst xmlns:a="http://schemas.openxmlformats.org/drawingml/2006/main">
               <a:ext uri="{FF2B5EF4-FFF2-40B4-BE49-F238E27FC236}">
-                <a16:creationId xmlns:a16="http://schemas.microsoft.com/office/drawing/2014/main" id="{BCC0BE06-4C55-4710-A9F9-4B47B910C039}"/>
+                <a16:creationId xmlns:a16="http://schemas.microsoft.com/office/drawing/2014/main" id="{C23AAF07-7B07-4498-8D42-E7E2A2064490}"/>
               </a:ext>
             </a:extLst>
           </p:cNvPr>
@@ -10981,7 +11001,7 @@
           <p:cNvPr id="8" name="">
             <a:extLst xmlns:a="http://schemas.openxmlformats.org/drawingml/2006/main">
               <a:ext uri="{FF2B5EF4-FFF2-40B4-BE49-F238E27FC236}">
-                <a16:creationId xmlns:a16="http://schemas.microsoft.com/office/drawing/2014/main" id="{9D35B29D-677C-4D96-AF17-E0A9DB30C0F7}"/>
+                <a16:creationId xmlns:a16="http://schemas.microsoft.com/office/drawing/2014/main" id="{A06F6C8E-F830-4E04-972C-FBEB2A6C175A}"/>
               </a:ext>
             </a:extLst>
           </p:cNvPr>
@@ -11012,7 +11032,7 @@
           <p:cNvPr id="47" name="">
             <a:extLst xmlns:a="http://schemas.openxmlformats.org/drawingml/2006/main">
               <a:ext uri="{FF2B5EF4-FFF2-40B4-BE49-F238E27FC236}">
-                <a16:creationId xmlns:a16="http://schemas.microsoft.com/office/drawing/2014/main" id="{4DD7E42C-C7A0-4618-9A30-85CFC843ECEA}"/>
+                <a16:creationId xmlns:a16="http://schemas.microsoft.com/office/drawing/2014/main" id="{F788F6F3-E93B-411F-92EB-73322240C653}"/>
               </a:ext>
             </a:extLst>
           </p:cNvPr>
@@ -11078,7 +11098,7 @@
           <p:cNvPr id="2" name="">
             <a:extLst xmlns:a="http://schemas.openxmlformats.org/drawingml/2006/main">
               <a:ext uri="{FF2B5EF4-FFF2-40B4-BE49-F238E27FC236}">
-                <a16:creationId xmlns:a16="http://schemas.microsoft.com/office/drawing/2014/main" id="{E4A0E8F6-8D4C-4811-971D-EB162DC46998}"/>
+                <a16:creationId xmlns:a16="http://schemas.microsoft.com/office/drawing/2014/main" id="{2D3582F7-3F61-4146-9113-C94E4CB66EA9}"/>
               </a:ext>
             </a:extLst>
           </p:cNvPr>
@@ -11110,7 +11130,7 @@
           <p:cNvPr id="3" name="">
             <a:extLst xmlns:a="http://schemas.openxmlformats.org/drawingml/2006/main">
               <a:ext uri="{FF2B5EF4-FFF2-40B4-BE49-F238E27FC236}">
-                <a16:creationId xmlns:a16="http://schemas.microsoft.com/office/drawing/2014/main" id="{668563DA-1F5E-4AA3-A5B3-64BC04FFB774}"/>
+                <a16:creationId xmlns:a16="http://schemas.microsoft.com/office/drawing/2014/main" id="{DB63190C-F4FC-48BA-928F-F29228B40FCE}"/>
               </a:ext>
             </a:extLst>
           </p:cNvPr>
@@ -11176,7 +11196,7 @@
           <p:cNvPr id="4" name="">
             <a:extLst xmlns:a="http://schemas.openxmlformats.org/drawingml/2006/main">
               <a:ext uri="{FF2B5EF4-FFF2-40B4-BE49-F238E27FC236}">
-                <a16:creationId xmlns:a16="http://schemas.microsoft.com/office/drawing/2014/main" id="{FE312888-C236-4CF7-83C8-634465829CA0}"/>
+                <a16:creationId xmlns:a16="http://schemas.microsoft.com/office/drawing/2014/main" id="{B9EFC14B-ACE3-42B7-8293-E186EECE57DD}"/>
               </a:ext>
             </a:extLst>
           </p:cNvPr>
@@ -11208,7 +11228,7 @@
           <p:cNvPr id="5" name="">
             <a:extLst xmlns:a="http://schemas.openxmlformats.org/drawingml/2006/main">
               <a:ext uri="{FF2B5EF4-FFF2-40B4-BE49-F238E27FC236}">
-                <a16:creationId xmlns:a16="http://schemas.microsoft.com/office/drawing/2014/main" id="{D7E745D6-3D48-440E-9BC3-026EA60143A6}"/>
+                <a16:creationId xmlns:a16="http://schemas.microsoft.com/office/drawing/2014/main" id="{16B7D657-D477-43D7-A4EE-1CB8BA0B3A0F}"/>
               </a:ext>
             </a:extLst>
           </p:cNvPr>
@@ -11274,7 +11294,7 @@
           <p:cNvPr id="6" name="">
             <a:extLst xmlns:a="http://schemas.openxmlformats.org/drawingml/2006/main">
               <a:ext uri="{FF2B5EF4-FFF2-40B4-BE49-F238E27FC236}">
-                <a16:creationId xmlns:a16="http://schemas.microsoft.com/office/drawing/2014/main" id="{7166B0B0-6925-40DD-9786-0BD2AAB44598}"/>
+                <a16:creationId xmlns:a16="http://schemas.microsoft.com/office/drawing/2014/main" id="{AAB471FA-A3FA-4AA5-A4E6-810C24E72A8F}"/>
               </a:ext>
             </a:extLst>
           </p:cNvPr>
@@ -11306,7 +11326,7 @@
           <p:cNvPr id="7" name="">
             <a:extLst xmlns:a="http://schemas.openxmlformats.org/drawingml/2006/main">
               <a:ext uri="{FF2B5EF4-FFF2-40B4-BE49-F238E27FC236}">
-                <a16:creationId xmlns:a16="http://schemas.microsoft.com/office/drawing/2014/main" id="{4B349CD4-7BB5-4CF8-87E5-5B57B652DCBF}"/>
+                <a16:creationId xmlns:a16="http://schemas.microsoft.com/office/drawing/2014/main" id="{3FA176F1-850E-4332-BA38-587155F22217}"/>
               </a:ext>
             </a:extLst>
           </p:cNvPr>
@@ -11372,7 +11392,7 @@
           <p:cNvPr id="10" name="">
             <a:extLst xmlns:a="http://schemas.openxmlformats.org/drawingml/2006/main">
               <a:ext uri="{FF2B5EF4-FFF2-40B4-BE49-F238E27FC236}">
-                <a16:creationId xmlns:a16="http://schemas.microsoft.com/office/drawing/2014/main" id="{8C77DDA1-4176-4991-BEAE-ACF32CAEEDA5}"/>
+                <a16:creationId xmlns:a16="http://schemas.microsoft.com/office/drawing/2014/main" id="{7BA4B652-C4BB-452B-915E-B0AC4DB44B00}"/>
               </a:ext>
             </a:extLst>
           </p:cNvPr>
@@ -11438,7 +11458,7 @@
           <p:cNvPr id="11" name="">
             <a:extLst xmlns:a="http://schemas.openxmlformats.org/drawingml/2006/main">
               <a:ext uri="{FF2B5EF4-FFF2-40B4-BE49-F238E27FC236}">
-                <a16:creationId xmlns:a16="http://schemas.microsoft.com/office/drawing/2014/main" id="{410A4301-E677-46B1-BCAD-8D09D956417A}"/>
+                <a16:creationId xmlns:a16="http://schemas.microsoft.com/office/drawing/2014/main" id="{9DF4B3B8-E6E3-4C24-AD94-A7A2C18CC3DA}"/>
               </a:ext>
             </a:extLst>
           </p:cNvPr>
@@ -11470,7 +11490,7 @@
           <p:cNvPr id="12" name="">
             <a:extLst xmlns:a="http://schemas.openxmlformats.org/drawingml/2006/main">
               <a:ext uri="{FF2B5EF4-FFF2-40B4-BE49-F238E27FC236}">
-                <a16:creationId xmlns:a16="http://schemas.microsoft.com/office/drawing/2014/main" id="{40EC6094-342A-4C8C-87A0-7EA3CCDAFD9A}"/>
+                <a16:creationId xmlns:a16="http://schemas.microsoft.com/office/drawing/2014/main" id="{76D45A39-764D-40C3-A1D7-8B8F9C70047A}"/>
               </a:ext>
             </a:extLst>
           </p:cNvPr>
@@ -11536,7 +11556,7 @@
           <p:cNvPr id="13" name="">
             <a:extLst xmlns:a="http://schemas.openxmlformats.org/drawingml/2006/main">
               <a:ext uri="{FF2B5EF4-FFF2-40B4-BE49-F238E27FC236}">
-                <a16:creationId xmlns:a16="http://schemas.microsoft.com/office/drawing/2014/main" id="{5F927DF1-7FF0-41AF-93C1-6AFFC0920148}"/>
+                <a16:creationId xmlns:a16="http://schemas.microsoft.com/office/drawing/2014/main" id="{8561C577-778D-4957-9A4C-F2A69CC145B4}"/>
               </a:ext>
             </a:extLst>
           </p:cNvPr>
@@ -11568,7 +11588,7 @@
           <p:cNvPr id="14" name="">
             <a:extLst xmlns:a="http://schemas.openxmlformats.org/drawingml/2006/main">
               <a:ext uri="{FF2B5EF4-FFF2-40B4-BE49-F238E27FC236}">
-                <a16:creationId xmlns:a16="http://schemas.microsoft.com/office/drawing/2014/main" id="{6739A4B1-6D6B-4597-AC55-C9B32BF10CC4}"/>
+                <a16:creationId xmlns:a16="http://schemas.microsoft.com/office/drawing/2014/main" id="{69213278-7ECC-4946-93EA-F157159C19DE}"/>
               </a:ext>
             </a:extLst>
           </p:cNvPr>
@@ -11634,7 +11654,7 @@
           <p:cNvPr id="15" name="">
             <a:extLst xmlns:a="http://schemas.openxmlformats.org/drawingml/2006/main">
               <a:ext uri="{FF2B5EF4-FFF2-40B4-BE49-F238E27FC236}">
-                <a16:creationId xmlns:a16="http://schemas.microsoft.com/office/drawing/2014/main" id="{65362358-27FB-4E87-8CE9-579A889F8FCB}"/>
+                <a16:creationId xmlns:a16="http://schemas.microsoft.com/office/drawing/2014/main" id="{7369849D-329D-449F-9CA1-83832EC3E9F0}"/>
               </a:ext>
             </a:extLst>
           </p:cNvPr>
@@ -11666,7 +11686,7 @@
           <p:cNvPr id="16" name="">
             <a:extLst xmlns:a="http://schemas.openxmlformats.org/drawingml/2006/main">
               <a:ext uri="{FF2B5EF4-FFF2-40B4-BE49-F238E27FC236}">
-                <a16:creationId xmlns:a16="http://schemas.microsoft.com/office/drawing/2014/main" id="{F60FAAD8-E403-48DF-AA56-33FBE80E42B2}"/>
+                <a16:creationId xmlns:a16="http://schemas.microsoft.com/office/drawing/2014/main" id="{47AC9B6C-C9E6-4FD5-8817-75F7EC334E80}"/>
               </a:ext>
             </a:extLst>
           </p:cNvPr>
@@ -11732,7 +11752,7 @@
           <p:cNvPr id="17" name="">
             <a:extLst xmlns:a="http://schemas.openxmlformats.org/drawingml/2006/main">
               <a:ext uri="{FF2B5EF4-FFF2-40B4-BE49-F238E27FC236}">
-                <a16:creationId xmlns:a16="http://schemas.microsoft.com/office/drawing/2014/main" id="{199A169E-E483-46C4-8B94-B595A84759A3}"/>
+                <a16:creationId xmlns:a16="http://schemas.microsoft.com/office/drawing/2014/main" id="{3610DE10-A533-4457-951B-9B2C640495A9}"/>
               </a:ext>
             </a:extLst>
           </p:cNvPr>
@@ -11764,7 +11784,7 @@
           <p:cNvPr id="18" name="">
             <a:extLst xmlns:a="http://schemas.openxmlformats.org/drawingml/2006/main">
               <a:ext uri="{FF2B5EF4-FFF2-40B4-BE49-F238E27FC236}">
-                <a16:creationId xmlns:a16="http://schemas.microsoft.com/office/drawing/2014/main" id="{4E2C34A6-31F0-40AD-B733-6989E98487EF}"/>
+                <a16:creationId xmlns:a16="http://schemas.microsoft.com/office/drawing/2014/main" id="{29C9FE3A-2919-4A47-99F5-616E6B308D23}"/>
               </a:ext>
             </a:extLst>
           </p:cNvPr>
@@ -11830,7 +11850,7 @@
           <p:cNvPr id="22" name="">
             <a:extLst xmlns:a="http://schemas.openxmlformats.org/drawingml/2006/main">
               <a:ext uri="{FF2B5EF4-FFF2-40B4-BE49-F238E27FC236}">
-                <a16:creationId xmlns:a16="http://schemas.microsoft.com/office/drawing/2014/main" id="{BAFD0CE9-78CC-4A01-A7DE-A141F8116754}"/>
+                <a16:creationId xmlns:a16="http://schemas.microsoft.com/office/drawing/2014/main" id="{CCB92FB4-23CF-43ED-8DD8-5B62AB162DA5}"/>
               </a:ext>
             </a:extLst>
           </p:cNvPr>
@@ -11896,7 +11916,7 @@
           <p:cNvPr id="23" name="">
             <a:extLst xmlns:a="http://schemas.openxmlformats.org/drawingml/2006/main">
               <a:ext uri="{FF2B5EF4-FFF2-40B4-BE49-F238E27FC236}">
-                <a16:creationId xmlns:a16="http://schemas.microsoft.com/office/drawing/2014/main" id="{D59DBA95-A6DB-4729-8B5B-BA80FCA6085A}"/>
+                <a16:creationId xmlns:a16="http://schemas.microsoft.com/office/drawing/2014/main" id="{72AD7F33-96D7-4291-AA1A-A3AB8F23D7C7}"/>
               </a:ext>
             </a:extLst>
           </p:cNvPr>
@@ -11928,7 +11948,7 @@
           <p:cNvPr id="24" name="">
             <a:extLst xmlns:a="http://schemas.openxmlformats.org/drawingml/2006/main">
               <a:ext uri="{FF2B5EF4-FFF2-40B4-BE49-F238E27FC236}">
-                <a16:creationId xmlns:a16="http://schemas.microsoft.com/office/drawing/2014/main" id="{37C9B60F-83C7-490C-A22E-0D66C8E829BA}"/>
+                <a16:creationId xmlns:a16="http://schemas.microsoft.com/office/drawing/2014/main" id="{732A76A1-D82F-4119-8F0A-696E30BF5A52}"/>
               </a:ext>
             </a:extLst>
           </p:cNvPr>
@@ -11994,7 +12014,7 @@
           <p:cNvPr id="25" name="">
             <a:extLst xmlns:a="http://schemas.openxmlformats.org/drawingml/2006/main">
               <a:ext uri="{FF2B5EF4-FFF2-40B4-BE49-F238E27FC236}">
-                <a16:creationId xmlns:a16="http://schemas.microsoft.com/office/drawing/2014/main" id="{6D8D1F54-7FA3-4F8D-94CC-4C6096193278}"/>
+                <a16:creationId xmlns:a16="http://schemas.microsoft.com/office/drawing/2014/main" id="{2991E08A-7390-4B80-BCF7-50AE4E78DB08}"/>
               </a:ext>
             </a:extLst>
           </p:cNvPr>
@@ -12026,7 +12046,7 @@
           <p:cNvPr id="26" name="">
             <a:extLst xmlns:a="http://schemas.openxmlformats.org/drawingml/2006/main">
               <a:ext uri="{FF2B5EF4-FFF2-40B4-BE49-F238E27FC236}">
-                <a16:creationId xmlns:a16="http://schemas.microsoft.com/office/drawing/2014/main" id="{A5E28C71-8DDB-4D35-8040-687A61AC292B}"/>
+                <a16:creationId xmlns:a16="http://schemas.microsoft.com/office/drawing/2014/main" id="{0FE6AA86-19A6-4D33-B64A-AC6BF340E35A}"/>
               </a:ext>
             </a:extLst>
           </p:cNvPr>
@@ -12092,7 +12112,7 @@
           <p:cNvPr id="27" name="">
             <a:extLst xmlns:a="http://schemas.openxmlformats.org/drawingml/2006/main">
               <a:ext uri="{FF2B5EF4-FFF2-40B4-BE49-F238E27FC236}">
-                <a16:creationId xmlns:a16="http://schemas.microsoft.com/office/drawing/2014/main" id="{4204A834-EAA7-4770-ADA7-242D199EB449}"/>
+                <a16:creationId xmlns:a16="http://schemas.microsoft.com/office/drawing/2014/main" id="{53702585-1B41-414B-A9DE-9123CBFDAA23}"/>
               </a:ext>
             </a:extLst>
           </p:cNvPr>
@@ -12124,7 +12144,7 @@
           <p:cNvPr id="28" name="">
             <a:extLst xmlns:a="http://schemas.openxmlformats.org/drawingml/2006/main">
               <a:ext uri="{FF2B5EF4-FFF2-40B4-BE49-F238E27FC236}">
-                <a16:creationId xmlns:a16="http://schemas.microsoft.com/office/drawing/2014/main" id="{F30FFFA2-D19B-46FC-9A50-2F7765BD41CE}"/>
+                <a16:creationId xmlns:a16="http://schemas.microsoft.com/office/drawing/2014/main" id="{7A2443FF-FA3B-4B23-8081-4AC5A4331AF0}"/>
               </a:ext>
             </a:extLst>
           </p:cNvPr>
@@ -12190,7 +12210,7 @@
           <p:cNvPr id="29" name="">
             <a:extLst xmlns:a="http://schemas.openxmlformats.org/drawingml/2006/main">
               <a:ext uri="{FF2B5EF4-FFF2-40B4-BE49-F238E27FC236}">
-                <a16:creationId xmlns:a16="http://schemas.microsoft.com/office/drawing/2014/main" id="{F8F235EA-3FAD-4607-8238-CB862EF04DC6}"/>
+                <a16:creationId xmlns:a16="http://schemas.microsoft.com/office/drawing/2014/main" id="{A8DA3697-82AF-4BB1-9C7A-CFD53DD84C3C}"/>
               </a:ext>
             </a:extLst>
           </p:cNvPr>
@@ -12222,7 +12242,7 @@
           <p:cNvPr id="30" name="">
             <a:extLst xmlns:a="http://schemas.openxmlformats.org/drawingml/2006/main">
               <a:ext uri="{FF2B5EF4-FFF2-40B4-BE49-F238E27FC236}">
-                <a16:creationId xmlns:a16="http://schemas.microsoft.com/office/drawing/2014/main" id="{952D3516-F08B-4E1D-B16E-A1E73DB2DF1D}"/>
+                <a16:creationId xmlns:a16="http://schemas.microsoft.com/office/drawing/2014/main" id="{C8A219EB-BEDE-4969-812F-868D683FA143}"/>
               </a:ext>
             </a:extLst>
           </p:cNvPr>
@@ -12288,7 +12308,7 @@
           <p:cNvPr id="34" name="">
             <a:extLst xmlns:a="http://schemas.openxmlformats.org/drawingml/2006/main">
               <a:ext uri="{FF2B5EF4-FFF2-40B4-BE49-F238E27FC236}">
-                <a16:creationId xmlns:a16="http://schemas.microsoft.com/office/drawing/2014/main" id="{4359107A-DF18-44B5-8919-DA36D6FB5EE1}"/>
+                <a16:creationId xmlns:a16="http://schemas.microsoft.com/office/drawing/2014/main" id="{C5684790-965C-41D2-97A4-56C320F0FD04}"/>
               </a:ext>
             </a:extLst>
           </p:cNvPr>
@@ -12344,7 +12364,7 @@
                 <a:ea typeface="DejaVu Sans"/>
                 <a:cs typeface="DejaVu Sans"/>
               </a:rPr>
-              <a:t>Nominal Falcon 9 • GitHub 5295f20 • SES-1 starts after 10 s coast • landing ignition time is optimized.</a:t>
+              <a:t>Phase gates and time bounds are input parameters. Landing ignition follows endpoint feasibility.</a:t>
             </a:r>
           </a:p>
         </p:txBody>
@@ -12354,7 +12374,7 @@
           <p:cNvPr id="35" name="">
             <a:extLst xmlns:a="http://schemas.openxmlformats.org/drawingml/2006/main">
               <a:ext uri="{FF2B5EF4-FFF2-40B4-BE49-F238E27FC236}">
-                <a16:creationId xmlns:a16="http://schemas.microsoft.com/office/drawing/2014/main" id="{DF9B478C-0DFA-4E94-BAF1-A9260EF73371}"/>
+                <a16:creationId xmlns:a16="http://schemas.microsoft.com/office/drawing/2014/main" id="{4CB2234E-6ACB-41A3-8D22-EA185A1DD0B7}"/>
               </a:ext>
             </a:extLst>
           </p:cNvPr>
@@ -12420,7 +12440,7 @@
           <p:cNvPr id="36" name="">
             <a:extLst xmlns:a="http://schemas.openxmlformats.org/drawingml/2006/main">
               <a:ext uri="{FF2B5EF4-FFF2-40B4-BE49-F238E27FC236}">
-                <a16:creationId xmlns:a16="http://schemas.microsoft.com/office/drawing/2014/main" id="{7B8FBBE0-AB39-4B6D-97E5-EE2DC9DED317}"/>
+                <a16:creationId xmlns:a16="http://schemas.microsoft.com/office/drawing/2014/main" id="{26408004-908B-4933-92AC-B345C23DF243}"/>
               </a:ext>
             </a:extLst>
           </p:cNvPr>
@@ -12430,13 +12450,13 @@
           <p:nvPr/>
         </p:nvPicPr>
         <p:blipFill>
-          <a:blip xmlns:r="http://schemas.openxmlformats.org/officeDocument/2006/relationships" xmlns:a="http://schemas.openxmlformats.org/drawingml/2006/main" r:embed="R6fa6bb7397d244be"/>
+          <a:blip xmlns:r="http://schemas.openxmlformats.org/officeDocument/2006/relationships" xmlns:a="http://schemas.openxmlformats.org/drawingml/2006/main" r:embed="Rfed19576d74f4278"/>
           <a:stretch xmlns:a="http://schemas.openxmlformats.org/drawingml/2006/main"/>
         </p:blipFill>
         <p:spPr>
           <a:xfrm xmlns:a="http://schemas.openxmlformats.org/drawingml/2006/main">
             <a:off x="762000" y="1714500"/>
-            <a:ext cx="817817" cy="231458"/>
+            <a:ext cx="905256" cy="221171"/>
           </a:xfrm>
           <a:prstGeom xmlns:a="http://schemas.openxmlformats.org/drawingml/2006/main" prst="rect">
             <a:avLst/>
@@ -12448,7 +12468,7 @@
           <p:cNvPr id="37" name="">
             <a:extLst xmlns:a="http://schemas.openxmlformats.org/drawingml/2006/main">
               <a:ext uri="{FF2B5EF4-FFF2-40B4-BE49-F238E27FC236}">
-                <a16:creationId xmlns:a16="http://schemas.microsoft.com/office/drawing/2014/main" id="{2C3E6390-C744-4202-ADE6-36EFA5C9F9F9}"/>
+                <a16:creationId xmlns:a16="http://schemas.microsoft.com/office/drawing/2014/main" id="{BCF797EB-32C6-4AFF-92EF-5FCDC5F1CAD0}"/>
               </a:ext>
             </a:extLst>
           </p:cNvPr>
@@ -12458,13 +12478,13 @@
           <p:nvPr/>
         </p:nvPicPr>
         <p:blipFill>
-          <a:blip xmlns:r="http://schemas.openxmlformats.org/officeDocument/2006/relationships" xmlns:a="http://schemas.openxmlformats.org/drawingml/2006/main" r:embed="R98783d1ea1e74edd"/>
+          <a:blip xmlns:r="http://schemas.openxmlformats.org/officeDocument/2006/relationships" xmlns:a="http://schemas.openxmlformats.org/drawingml/2006/main" r:embed="R474bf520bd72499b"/>
           <a:stretch xmlns:a="http://schemas.openxmlformats.org/drawingml/2006/main"/>
         </p:blipFill>
         <p:spPr>
           <a:xfrm xmlns:a="http://schemas.openxmlformats.org/drawingml/2006/main">
             <a:off x="3733800" y="1724025"/>
-            <a:ext cx="2713839" cy="243030"/>
+            <a:ext cx="2497812" cy="247531"/>
           </a:xfrm>
           <a:prstGeom xmlns:a="http://schemas.openxmlformats.org/drawingml/2006/main" prst="rect">
             <a:avLst/>
@@ -12476,7 +12496,7 @@
           <p:cNvPr id="38" name="">
             <a:extLst xmlns:a="http://schemas.openxmlformats.org/drawingml/2006/main">
               <a:ext uri="{FF2B5EF4-FFF2-40B4-BE49-F238E27FC236}">
-                <a16:creationId xmlns:a16="http://schemas.microsoft.com/office/drawing/2014/main" id="{6FC46CD8-B26D-489E-9898-24B3F120589C}"/>
+                <a16:creationId xmlns:a16="http://schemas.microsoft.com/office/drawing/2014/main" id="{4E1E6614-D84A-414C-A4F5-8DB5528699A5}"/>
               </a:ext>
             </a:extLst>
           </p:cNvPr>
@@ -12486,13 +12506,13 @@
           <p:nvPr/>
         </p:nvPicPr>
         <p:blipFill>
-          <a:blip xmlns:r="http://schemas.openxmlformats.org/officeDocument/2006/relationships" xmlns:a="http://schemas.openxmlformats.org/drawingml/2006/main" r:embed="Rd1d192b171c24e21"/>
+          <a:blip xmlns:r="http://schemas.openxmlformats.org/officeDocument/2006/relationships" xmlns:a="http://schemas.openxmlformats.org/drawingml/2006/main" r:embed="R6e52cbe5f02c4dcf"/>
           <a:stretch xmlns:a="http://schemas.openxmlformats.org/drawingml/2006/main"/>
         </p:blipFill>
         <p:spPr>
           <a:xfrm xmlns:a="http://schemas.openxmlformats.org/drawingml/2006/main">
             <a:off x="7334250" y="1714500"/>
-            <a:ext cx="3775972" cy="247531"/>
+            <a:ext cx="3780473" cy="247531"/>
           </a:xfrm>
           <a:prstGeom xmlns:a="http://schemas.openxmlformats.org/drawingml/2006/main" prst="rect">
             <a:avLst/>
@@ -12504,7 +12524,7 @@
           <p:cNvPr id="39" name="">
             <a:extLst xmlns:a="http://schemas.openxmlformats.org/drawingml/2006/main">
               <a:ext uri="{FF2B5EF4-FFF2-40B4-BE49-F238E27FC236}">
-                <a16:creationId xmlns:a16="http://schemas.microsoft.com/office/drawing/2014/main" id="{FB51E17C-10B0-46BC-A369-5F8F8B7503A4}"/>
+                <a16:creationId xmlns:a16="http://schemas.microsoft.com/office/drawing/2014/main" id="{285E4BE4-CFE4-4A49-ADF2-8E2DBF3637E2}"/>
               </a:ext>
             </a:extLst>
           </p:cNvPr>
@@ -12514,7 +12534,7 @@
           <p:nvPr/>
         </p:nvPicPr>
         <p:blipFill>
-          <a:blip xmlns:r="http://schemas.openxmlformats.org/officeDocument/2006/relationships" xmlns:a="http://schemas.openxmlformats.org/drawingml/2006/main" r:embed="Rc1fda60280a24139"/>
+          <a:blip xmlns:r="http://schemas.openxmlformats.org/officeDocument/2006/relationships" xmlns:a="http://schemas.openxmlformats.org/drawingml/2006/main" r:embed="Rc32f6cd929e94959"/>
           <a:stretch xmlns:a="http://schemas.openxmlformats.org/drawingml/2006/main"/>
         </p:blipFill>
         <p:spPr>
@@ -12532,7 +12552,7 @@
           <p:cNvPr id="40" name="">
             <a:extLst xmlns:a="http://schemas.openxmlformats.org/drawingml/2006/main">
               <a:ext uri="{FF2B5EF4-FFF2-40B4-BE49-F238E27FC236}">
-                <a16:creationId xmlns:a16="http://schemas.microsoft.com/office/drawing/2014/main" id="{1A07D03A-D9F0-4015-BB8A-596A763E4840}"/>
+                <a16:creationId xmlns:a16="http://schemas.microsoft.com/office/drawing/2014/main" id="{DA27536C-DDC0-442F-BD41-EF1CC12283FD}"/>
               </a:ext>
             </a:extLst>
           </p:cNvPr>
@@ -12542,7 +12562,7 @@
           <p:nvPr/>
         </p:nvPicPr>
         <p:blipFill>
-          <a:blip xmlns:r="http://schemas.openxmlformats.org/officeDocument/2006/relationships" xmlns:a="http://schemas.openxmlformats.org/drawingml/2006/main" r:embed="R8170b5a7c524435d"/>
+          <a:blip xmlns:r="http://schemas.openxmlformats.org/officeDocument/2006/relationships" xmlns:a="http://schemas.openxmlformats.org/drawingml/2006/main" r:embed="R038cfd6239b64fd5"/>
           <a:stretch xmlns:a="http://schemas.openxmlformats.org/drawingml/2006/main"/>
         </p:blipFill>
         <p:spPr>
@@ -12560,7 +12580,7 @@
           <p:cNvPr id="41" name="">
             <a:extLst xmlns:a="http://schemas.openxmlformats.org/drawingml/2006/main">
               <a:ext uri="{FF2B5EF4-FFF2-40B4-BE49-F238E27FC236}">
-                <a16:creationId xmlns:a16="http://schemas.microsoft.com/office/drawing/2014/main" id="{BBF414ED-5612-456F-9BE6-47F6B82B73A0}"/>
+                <a16:creationId xmlns:a16="http://schemas.microsoft.com/office/drawing/2014/main" id="{29A2D785-4197-4FB4-BBCC-D57D956F202F}"/>
               </a:ext>
             </a:extLst>
           </p:cNvPr>
@@ -12570,7 +12590,7 @@
           <p:nvPr/>
         </p:nvPicPr>
         <p:blipFill>
-          <a:blip xmlns:r="http://schemas.openxmlformats.org/officeDocument/2006/relationships" xmlns:a="http://schemas.openxmlformats.org/drawingml/2006/main" r:embed="R189e8d6374d04e35"/>
+          <a:blip xmlns:r="http://schemas.openxmlformats.org/officeDocument/2006/relationships" xmlns:a="http://schemas.openxmlformats.org/drawingml/2006/main" r:embed="Rcf5c022a9edd4f1c"/>
           <a:stretch xmlns:a="http://schemas.openxmlformats.org/drawingml/2006/main"/>
         </p:blipFill>
         <p:spPr>
@@ -12588,7 +12608,7 @@
           <p:cNvPr id="42" name="">
             <a:extLst xmlns:a="http://schemas.openxmlformats.org/drawingml/2006/main">
               <a:ext uri="{FF2B5EF4-FFF2-40B4-BE49-F238E27FC236}">
-                <a16:creationId xmlns:a16="http://schemas.microsoft.com/office/drawing/2014/main" id="{31E69D28-6ED6-4888-8683-2AB624D62824}"/>
+                <a16:creationId xmlns:a16="http://schemas.microsoft.com/office/drawing/2014/main" id="{2A91F942-3DBE-47BB-B87E-E7F714241C61}"/>
               </a:ext>
             </a:extLst>
           </p:cNvPr>
@@ -12598,7 +12618,7 @@
           <p:nvPr/>
         </p:nvPicPr>
         <p:blipFill>
-          <a:blip xmlns:r="http://schemas.openxmlformats.org/officeDocument/2006/relationships" xmlns:a="http://schemas.openxmlformats.org/drawingml/2006/main" r:embed="R1a28271805644ceb"/>
+          <a:blip xmlns:r="http://schemas.openxmlformats.org/officeDocument/2006/relationships" xmlns:a="http://schemas.openxmlformats.org/drawingml/2006/main" r:embed="Rb0ab3fcf01ef4bb3"/>
           <a:stretch xmlns:a="http://schemas.openxmlformats.org/drawingml/2006/main"/>
         </p:blipFill>
         <p:spPr>
@@ -12616,7 +12636,7 @@
           <p:cNvPr id="43" name="">
             <a:extLst xmlns:a="http://schemas.openxmlformats.org/drawingml/2006/main">
               <a:ext uri="{FF2B5EF4-FFF2-40B4-BE49-F238E27FC236}">
-                <a16:creationId xmlns:a16="http://schemas.microsoft.com/office/drawing/2014/main" id="{427F8DE4-BDB9-4721-8958-8FEEF463E23E}"/>
+                <a16:creationId xmlns:a16="http://schemas.microsoft.com/office/drawing/2014/main" id="{A5930C01-1C0F-44E6-AB29-04847089EA90}"/>
               </a:ext>
             </a:extLst>
           </p:cNvPr>
@@ -12626,13 +12646,13 @@
           <p:nvPr/>
         </p:nvPicPr>
         <p:blipFill>
-          <a:blip xmlns:r="http://schemas.openxmlformats.org/officeDocument/2006/relationships" xmlns:a="http://schemas.openxmlformats.org/drawingml/2006/main" r:embed="R688a285cae3a4917"/>
+          <a:blip xmlns:r="http://schemas.openxmlformats.org/officeDocument/2006/relationships" xmlns:a="http://schemas.openxmlformats.org/drawingml/2006/main" r:embed="R2847f3f48f5b4678"/>
           <a:stretch xmlns:a="http://schemas.openxmlformats.org/drawingml/2006/main"/>
         </p:blipFill>
         <p:spPr>
           <a:xfrm xmlns:a="http://schemas.openxmlformats.org/drawingml/2006/main">
             <a:off x="762000" y="5200650"/>
-            <a:ext cx="1528348" cy="581025"/>
+            <a:ext cx="1376777" cy="581025"/>
           </a:xfrm>
           <a:prstGeom xmlns:a="http://schemas.openxmlformats.org/drawingml/2006/main" prst="rect">
             <a:avLst/>
@@ -12644,7 +12664,7 @@
           <p:cNvPr id="44" name="">
             <a:extLst xmlns:a="http://schemas.openxmlformats.org/drawingml/2006/main">
               <a:ext uri="{FF2B5EF4-FFF2-40B4-BE49-F238E27FC236}">
-                <a16:creationId xmlns:a16="http://schemas.microsoft.com/office/drawing/2014/main" id="{7F5F3F8C-935D-4BF3-9F9B-B20CBC6DB249}"/>
+                <a16:creationId xmlns:a16="http://schemas.microsoft.com/office/drawing/2014/main" id="{D12CF57C-E984-4229-A3B8-A0D1D7EC8641}"/>
               </a:ext>
             </a:extLst>
           </p:cNvPr>
@@ -12654,13 +12674,13 @@
           <p:nvPr/>
         </p:nvPicPr>
         <p:blipFill>
-          <a:blip xmlns:r="http://schemas.openxmlformats.org/officeDocument/2006/relationships" xmlns:a="http://schemas.openxmlformats.org/drawingml/2006/main" r:embed="R48a5af2b704940b1"/>
+          <a:blip xmlns:r="http://schemas.openxmlformats.org/officeDocument/2006/relationships" xmlns:a="http://schemas.openxmlformats.org/drawingml/2006/main" r:embed="R1cad456b5d1f4114"/>
           <a:stretch xmlns:a="http://schemas.openxmlformats.org/drawingml/2006/main"/>
         </p:blipFill>
         <p:spPr>
           <a:xfrm xmlns:a="http://schemas.openxmlformats.org/drawingml/2006/main">
             <a:off x="3533775" y="5200650"/>
-            <a:ext cx="1250467" cy="581025"/>
+            <a:ext cx="1553610" cy="581025"/>
           </a:xfrm>
           <a:prstGeom xmlns:a="http://schemas.openxmlformats.org/drawingml/2006/main" prst="rect">
             <a:avLst/>
@@ -12672,7 +12692,7 @@
           <p:cNvPr id="45" name="">
             <a:extLst xmlns:a="http://schemas.openxmlformats.org/drawingml/2006/main">
               <a:ext uri="{FF2B5EF4-FFF2-40B4-BE49-F238E27FC236}">
-                <a16:creationId xmlns:a16="http://schemas.microsoft.com/office/drawing/2014/main" id="{60C6FC92-3717-4432-8316-BAD229357F14}"/>
+                <a16:creationId xmlns:a16="http://schemas.microsoft.com/office/drawing/2014/main" id="{7249813A-9D17-476F-AE12-3954A0BCD23D}"/>
               </a:ext>
             </a:extLst>
           </p:cNvPr>
@@ -12682,13 +12702,13 @@
           <p:nvPr/>
         </p:nvPicPr>
         <p:blipFill>
-          <a:blip xmlns:r="http://schemas.openxmlformats.org/officeDocument/2006/relationships" xmlns:a="http://schemas.openxmlformats.org/drawingml/2006/main" r:embed="Rcd4b8fd687104b07"/>
+          <a:blip xmlns:r="http://schemas.openxmlformats.org/officeDocument/2006/relationships" xmlns:a="http://schemas.openxmlformats.org/drawingml/2006/main" r:embed="R55dbb55bf0de4d03"/>
           <a:stretch xmlns:a="http://schemas.openxmlformats.org/drawingml/2006/main"/>
         </p:blipFill>
         <p:spPr>
           <a:xfrm xmlns:a="http://schemas.openxmlformats.org/drawingml/2006/main">
             <a:off x="6305550" y="5200650"/>
-            <a:ext cx="1365206" cy="581025"/>
+            <a:ext cx="976796" cy="581025"/>
           </a:xfrm>
           <a:prstGeom xmlns:a="http://schemas.openxmlformats.org/drawingml/2006/main" prst="rect">
             <a:avLst/>
@@ -12700,7 +12720,7 @@
           <p:cNvPr id="46" name="">
             <a:extLst xmlns:a="http://schemas.openxmlformats.org/drawingml/2006/main">
               <a:ext uri="{FF2B5EF4-FFF2-40B4-BE49-F238E27FC236}">
-                <a16:creationId xmlns:a16="http://schemas.microsoft.com/office/drawing/2014/main" id="{B9E362AB-3C49-4EAE-A85E-AEEFE1C43825}"/>
+                <a16:creationId xmlns:a16="http://schemas.microsoft.com/office/drawing/2014/main" id="{357D5606-53C7-4CBA-8D9D-A9DCCB4F6959}"/>
               </a:ext>
             </a:extLst>
           </p:cNvPr>
@@ -12710,13 +12730,13 @@
           <p:nvPr/>
         </p:nvPicPr>
         <p:blipFill>
-          <a:blip xmlns:r="http://schemas.openxmlformats.org/officeDocument/2006/relationships" xmlns:a="http://schemas.openxmlformats.org/drawingml/2006/main" r:embed="Rf87a45310cf54a0e"/>
+          <a:blip xmlns:r="http://schemas.openxmlformats.org/officeDocument/2006/relationships" xmlns:a="http://schemas.openxmlformats.org/drawingml/2006/main" r:embed="Rb9383f4de9034785"/>
           <a:stretch xmlns:a="http://schemas.openxmlformats.org/drawingml/2006/main"/>
         </p:blipFill>
         <p:spPr>
           <a:xfrm xmlns:a="http://schemas.openxmlformats.org/drawingml/2006/main">
             <a:off x="9077325" y="5105400"/>
-            <a:ext cx="939800" cy="676275"/>
+            <a:ext cx="1050925" cy="676275"/>
           </a:xfrm>
           <a:prstGeom xmlns:a="http://schemas.openxmlformats.org/drawingml/2006/main" prst="rect">
             <a:avLst/>
@@ -12726,7 +12746,7 @@
     </p:spTree>
     <p:extLst>
       <p:ext uri="{BB962C8B-B14F-4D97-AF65-F5344CB8AC3E}">
-        <p14:creationId xmlns:p14="http://schemas.microsoft.com/office/powerpoint/2010/main" val="1129689316"/>
+        <p14:creationId xmlns:p14="http://schemas.microsoft.com/office/powerpoint/2010/main" val="351079676"/>
       </p:ext>
     </p:extLst>
   </p:cSld>
@@ -13221,7 +13241,7 @@
                 <a:ea typeface="DejaVu Sans"/>
                 <a:cs typeface="DejaVu Sans"/>
               </a:rPr>
-              <a:t>Falcon 9 provides a case study for comparing recovery modes</a:t>
+              <a:t>Vehicle inputs support comparisons between recovery modes</a:t>
             </a:r>
           </a:p>
           <a:p xmlns:a="http://schemas.openxmlformats.org/drawingml/2006/main">
@@ -13322,7 +13342,7 @@
           <p:cNvPr id="9" name="">
             <a:extLst xmlns:a="http://schemas.openxmlformats.org/drawingml/2006/main">
               <a:ext uri="{FF2B5EF4-FFF2-40B4-BE49-F238E27FC236}">
-                <a16:creationId xmlns:a16="http://schemas.microsoft.com/office/drawing/2014/main" id="{66795D02-14D1-4CFF-9A1A-FE978826E4A9}"/>
+                <a16:creationId xmlns:a16="http://schemas.microsoft.com/office/drawing/2014/main" id="{2497CED1-580E-4FDF-94E1-A5008014657F}"/>
               </a:ext>
             </a:extLst>
           </p:cNvPr>
@@ -13417,7 +13437,7 @@
           <p:cNvPr id="6" name="">
             <a:extLst xmlns:a="http://schemas.openxmlformats.org/drawingml/2006/main">
               <a:ext uri="{FF2B5EF4-FFF2-40B4-BE49-F238E27FC236}">
-                <a16:creationId xmlns:a16="http://schemas.microsoft.com/office/drawing/2014/main" id="{B14C9724-07A1-4C63-80CE-2B24CDBA3702}"/>
+                <a16:creationId xmlns:a16="http://schemas.microsoft.com/office/drawing/2014/main" id="{C956DD98-BDB7-412C-A0F2-927E7E58ABD6}"/>
               </a:ext>
             </a:extLst>
           </p:cNvPr>
@@ -13483,7 +13503,7 @@
           <p:cNvPr id="2" name="">
             <a:extLst xmlns:a="http://schemas.openxmlformats.org/drawingml/2006/main">
               <a:ext uri="{FF2B5EF4-FFF2-40B4-BE49-F238E27FC236}">
-                <a16:creationId xmlns:a16="http://schemas.microsoft.com/office/drawing/2014/main" id="{70FEB516-FF62-4C8E-991D-D94A59131CC4}"/>
+                <a16:creationId xmlns:a16="http://schemas.microsoft.com/office/drawing/2014/main" id="{4327109B-8E54-4998-86C6-73907F727947}"/>
               </a:ext>
             </a:extLst>
           </p:cNvPr>
@@ -13539,7 +13559,7 @@
                 <a:ea typeface="DejaVu Sans"/>
                 <a:cs typeface="DejaVu Sans"/>
               </a:rPr>
-              <a:t>Stage 1 (9 engines)</a:t>
+              <a:t>Engine inputs</a:t>
             </a:r>
           </a:p>
           <a:p xmlns:a="http://schemas.openxmlformats.org/drawingml/2006/main">
@@ -13562,7 +13582,7 @@
                 <a:ea typeface="DejaVu Sans"/>
                 <a:cs typeface="DejaVu Sans"/>
               </a:rPr>
-              <a:t>SL / vacuum thrust: 7.605 / 8.226 MN</a:t>
+              <a:t>Sea-level and vacuum thrust</a:t>
             </a:r>
           </a:p>
           <a:p xmlns:a="http://schemas.openxmlformats.org/drawingml/2006/main">
@@ -13585,7 +13605,7 @@
                 <a:ea typeface="DejaVu Sans"/>
                 <a:cs typeface="DejaVu Sans"/>
               </a:rPr>
-              <a:t>SL / vacuum Isp: 282 / 305 s</a:t>
+              <a:t>Reference specific impulse</a:t>
             </a:r>
           </a:p>
           <a:p xmlns:a="http://schemas.openxmlformats.org/drawingml/2006/main">
@@ -13608,7 +13628,7 @@
                 <a:ea typeface="DejaVu Sans"/>
                 <a:cs typeface="DejaVu Sans"/>
               </a:rPr>
-              <a:t>Throttle: 0.57–1</a:t>
+              <a:t>Minimum throttle</a:t>
             </a:r>
           </a:p>
           <a:p xmlns:a="http://schemas.openxmlformats.org/drawingml/2006/main">
@@ -13636,7 +13656,12 @@
                 <a:ea typeface="DejaVu Sans"/>
                 <a:cs typeface="DejaVu Sans"/>
               </a:rPr>
-              <a:t>Stage 2</a:t>
+              <a:t>Active engine configuration sets thrust capacity.</a:t>
+            </a:r>
+          </a:p>
+          <a:p xmlns:a="http://schemas.openxmlformats.org/drawingml/2006/main">
+            <a:r>
+              <a:t/>
             </a:r>
           </a:p>
           <a:p xmlns:a="http://schemas.openxmlformats.org/drawingml/2006/main">
@@ -13659,53 +13684,7 @@
                 <a:ea typeface="DejaVu Sans"/>
                 <a:cs typeface="DejaVu Sans"/>
               </a:rPr>
-              <a:t>Thrust: 981 kN</a:t>
-            </a:r>
-          </a:p>
-          <a:p xmlns:a="http://schemas.openxmlformats.org/drawingml/2006/main">
-            <a:pPr>
-              <a:defRPr sz="1875" b="0">
-                <a:solidFill>
-                  <a:srgbClr val="4D6271"/>
-                </a:solidFill>
-                <a:latin typeface="DejaVu Sans"/>
-                <a:ea typeface="DejaVu Sans"/>
-                <a:cs typeface="DejaVu Sans"/>
-              </a:defRPr>
-            </a:pPr>
-            <a:r>
-              <a:rPr sz="1875" b="0">
-                <a:solidFill>
-                  <a:srgbClr val="4D6271"/>
-                </a:solidFill>
-                <a:latin typeface="DejaVu Sans"/>
-                <a:ea typeface="DejaVu Sans"/>
-                <a:cs typeface="DejaVu Sans"/>
-              </a:rPr>
-              <a:t>Isp at full thrust: 348 s</a:t>
-            </a:r>
-          </a:p>
-          <a:p xmlns:a="http://schemas.openxmlformats.org/drawingml/2006/main">
-            <a:pPr>
-              <a:defRPr sz="1875" b="0">
-                <a:solidFill>
-                  <a:srgbClr val="4D6271"/>
-                </a:solidFill>
-                <a:latin typeface="DejaVu Sans"/>
-                <a:ea typeface="DejaVu Sans"/>
-                <a:cs typeface="DejaVu Sans"/>
-              </a:defRPr>
-            </a:pPr>
-            <a:r>
-              <a:rPr sz="1875" b="0">
-                <a:solidFill>
-                  <a:srgbClr val="4D6271"/>
-                </a:solidFill>
-                <a:latin typeface="DejaVu Sans"/>
-                <a:ea typeface="DejaVu Sans"/>
-                <a:cs typeface="DejaVu Sans"/>
-              </a:rPr>
-              <a:t>Throttle: 0.638–1</a:t>
+              <a:t>η₂,min sets upper-stage Isp at minimum throttle.</a:t>
             </a:r>
           </a:p>
         </p:txBody>
@@ -13715,7 +13694,7 @@
           <p:cNvPr id="3" name="">
             <a:extLst xmlns:a="http://schemas.openxmlformats.org/drawingml/2006/main">
               <a:ext uri="{FF2B5EF4-FFF2-40B4-BE49-F238E27FC236}">
-                <a16:creationId xmlns:a16="http://schemas.microsoft.com/office/drawing/2014/main" id="{9A68B3F5-9CA9-4378-826B-450479ADB3B7}"/>
+                <a16:creationId xmlns:a16="http://schemas.microsoft.com/office/drawing/2014/main" id="{4CF40EC2-B466-4930-BF70-97E112C3100B}"/>
               </a:ext>
             </a:extLst>
           </p:cNvPr>
@@ -13771,7 +13750,7 @@
                 <a:ea typeface="DejaVu Sans"/>
                 <a:cs typeface="DejaVu Sans"/>
               </a:rPr>
-              <a:t>Stage-2 throttle is fT = ‖F‖ / 981 kN. Engine-off segments have zero thrust and mass flow.</a:t>
+              <a:t>Upper-stage throttle is fT = ‖F‖ / T₂,max. Engine-off segments have zero thrust and mass flow.</a:t>
             </a:r>
           </a:p>
         </p:txBody>
@@ -13781,7 +13760,7 @@
           <p:cNvPr id="4" name="">
             <a:extLst xmlns:a="http://schemas.openxmlformats.org/drawingml/2006/main">
               <a:ext uri="{FF2B5EF4-FFF2-40B4-BE49-F238E27FC236}">
-                <a16:creationId xmlns:a16="http://schemas.microsoft.com/office/drawing/2014/main" id="{C61EFB67-3223-4F77-A4CC-30C7C3548D12}"/>
+                <a16:creationId xmlns:a16="http://schemas.microsoft.com/office/drawing/2014/main" id="{BB13308A-685D-4A6B-B556-81B7234E1CAD}"/>
               </a:ext>
             </a:extLst>
           </p:cNvPr>
@@ -13847,7 +13826,7 @@
           <p:cNvPr id="5" name="">
             <a:extLst xmlns:a="http://schemas.openxmlformats.org/drawingml/2006/main">
               <a:ext uri="{FF2B5EF4-FFF2-40B4-BE49-F238E27FC236}">
-                <a16:creationId xmlns:a16="http://schemas.microsoft.com/office/drawing/2014/main" id="{3DEB5EDE-EA06-4DD3-B1C1-87558F8D0384}"/>
+                <a16:creationId xmlns:a16="http://schemas.microsoft.com/office/drawing/2014/main" id="{AFFC29F8-C5D2-4D8B-8A67-CC804DE5A6A6}"/>
               </a:ext>
             </a:extLst>
           </p:cNvPr>
@@ -13857,13 +13836,13 @@
           <p:nvPr/>
         </p:nvPicPr>
         <p:blipFill>
-          <a:blip xmlns:r="http://schemas.openxmlformats.org/officeDocument/2006/relationships" xmlns:a="http://schemas.openxmlformats.org/drawingml/2006/main" r:embed="R1c8daa7a12534ef8"/>
+          <a:blip xmlns:r="http://schemas.openxmlformats.org/officeDocument/2006/relationships" xmlns:a="http://schemas.openxmlformats.org/drawingml/2006/main" r:embed="Rfaa3c779adeb49fc"/>
           <a:stretch xmlns:a="http://schemas.openxmlformats.org/drawingml/2006/main"/>
         </p:blipFill>
         <p:spPr>
           <a:xfrm xmlns:a="http://schemas.openxmlformats.org/drawingml/2006/main">
             <a:off x="609600" y="1714500"/>
-            <a:ext cx="4782967" cy="3333750"/>
+            <a:ext cx="5853317" cy="3333750"/>
           </a:xfrm>
           <a:prstGeom xmlns:a="http://schemas.openxmlformats.org/drawingml/2006/main" prst="rect">
             <a:avLst/>
@@ -13873,7 +13852,7 @@
     </p:spTree>
     <p:extLst>
       <p:ext uri="{BB962C8B-B14F-4D97-AF65-F5344CB8AC3E}">
-        <p14:creationId xmlns:p14="http://schemas.microsoft.com/office/powerpoint/2010/main" val="294091319"/>
+        <p14:creationId xmlns:p14="http://schemas.microsoft.com/office/powerpoint/2010/main" val="1144676676"/>
       </p:ext>
     </p:extLst>
   </p:cSld>
@@ -13904,7 +13883,7 @@
           <p:cNvPr id="6" name="">
             <a:extLst xmlns:a="http://schemas.openxmlformats.org/drawingml/2006/main">
               <a:ext uri="{FF2B5EF4-FFF2-40B4-BE49-F238E27FC236}">
-                <a16:creationId xmlns:a16="http://schemas.microsoft.com/office/drawing/2014/main" id="{E5B6A5D6-14F7-4C7E-ABDF-EA5C64C11CD7}"/>
+                <a16:creationId xmlns:a16="http://schemas.microsoft.com/office/drawing/2014/main" id="{AB06C781-C27C-404B-BA87-19CB9BC45F59}"/>
               </a:ext>
             </a:extLst>
           </p:cNvPr>
@@ -13970,7 +13949,7 @@
           <p:cNvPr id="2" name="">
             <a:extLst xmlns:a="http://schemas.openxmlformats.org/drawingml/2006/main">
               <a:ext uri="{FF2B5EF4-FFF2-40B4-BE49-F238E27FC236}">
-                <a16:creationId xmlns:a16="http://schemas.microsoft.com/office/drawing/2014/main" id="{8E910A22-D326-4683-ACCC-C3C8CC39E31B}"/>
+                <a16:creationId xmlns:a16="http://schemas.microsoft.com/office/drawing/2014/main" id="{AB92E9F6-311A-456A-83D3-6E82B01365B4}"/>
               </a:ext>
             </a:extLst>
           </p:cNvPr>
@@ -14026,7 +14005,7 @@
                 <a:ea typeface="DejaVu Sans"/>
                 <a:cs typeface="DejaVu Sans"/>
               </a:rPr>
-              <a:t>Stage 1 dry / propellant:</a:t>
+              <a:t>Mass inputs</a:t>
             </a:r>
           </a:p>
           <a:p xmlns:a="http://schemas.openxmlformats.org/drawingml/2006/main">
@@ -14049,12 +14028,7 @@
                 <a:ea typeface="DejaVu Sans"/>
                 <a:cs typeface="DejaVu Sans"/>
               </a:rPr>
-              <a:t>25.6 / 395.7 t</a:t>
-            </a:r>
-          </a:p>
-          <a:p xmlns:a="http://schemas.openxmlformats.org/drawingml/2006/main">
-            <a:r>
-              <a:t/>
+              <a:t>Stage dry masses</a:t>
             </a:r>
           </a:p>
           <a:p xmlns:a="http://schemas.openxmlformats.org/drawingml/2006/main">
@@ -14077,7 +14051,7 @@
                 <a:ea typeface="DejaVu Sans"/>
                 <a:cs typeface="DejaVu Sans"/>
               </a:rPr>
-              <a:t>Stage 2 dry / propellant:</a:t>
+              <a:t>Stage propellant loads</a:t>
             </a:r>
           </a:p>
           <a:p xmlns:a="http://schemas.openxmlformats.org/drawingml/2006/main">
@@ -14100,7 +14074,7 @@
                 <a:ea typeface="DejaVu Sans"/>
                 <a:cs typeface="DejaVu Sans"/>
               </a:rPr>
-              <a:t>4.0 / 92.670 t</a:t>
+              <a:t>Fairing mass</a:t>
             </a:r>
           </a:p>
           <a:p xmlns:a="http://schemas.openxmlformats.org/drawingml/2006/main">
@@ -14128,7 +14102,12 @@
                 <a:ea typeface="DejaVu Sans"/>
                 <a:cs typeface="DejaVu Sans"/>
               </a:rPr>
-              <a:t>Fairing: 1.9 t</a:t>
+              <a:t>Payload mass is the objective.</a:t>
+            </a:r>
+          </a:p>
+          <a:p xmlns:a="http://schemas.openxmlformats.org/drawingml/2006/main">
+            <a:r>
+              <a:t/>
             </a:r>
           </a:p>
           <a:p xmlns:a="http://schemas.openxmlformats.org/drawingml/2006/main">
@@ -14151,7 +14130,7 @@
                 <a:ea typeface="DejaVu Sans"/>
                 <a:cs typeface="DejaVu Sans"/>
               </a:rPr>
-              <a:t>Total before payload: 519.870 t</a:t>
+              <a:t>Recovery feasibility sets the booster propellant reserve.</a:t>
             </a:r>
           </a:p>
         </p:txBody>
@@ -14161,7 +14140,7 @@
           <p:cNvPr id="3" name="">
             <a:extLst xmlns:a="http://schemas.openxmlformats.org/drawingml/2006/main">
               <a:ext uri="{FF2B5EF4-FFF2-40B4-BE49-F238E27FC236}">
-                <a16:creationId xmlns:a16="http://schemas.microsoft.com/office/drawing/2014/main" id="{506CC332-5220-49CE-8354-20ED89E0B8A8}"/>
+                <a16:creationId xmlns:a16="http://schemas.microsoft.com/office/drawing/2014/main" id="{E47D9ABB-CB08-4B17-A2CC-12B1B8B0DE18}"/>
               </a:ext>
             </a:extLst>
           </p:cNvPr>
@@ -14227,7 +14206,7 @@
           <p:cNvPr id="4" name="">
             <a:extLst xmlns:a="http://schemas.openxmlformats.org/drawingml/2006/main">
               <a:ext uri="{FF2B5EF4-FFF2-40B4-BE49-F238E27FC236}">
-                <a16:creationId xmlns:a16="http://schemas.microsoft.com/office/drawing/2014/main" id="{AF0E2376-82E1-4BDC-A91C-8581E65ECB3B}"/>
+                <a16:creationId xmlns:a16="http://schemas.microsoft.com/office/drawing/2014/main" id="{32B0A93B-B11E-4873-A68F-81793FE98E9C}"/>
               </a:ext>
             </a:extLst>
           </p:cNvPr>
@@ -14293,7 +14272,7 @@
           <p:cNvPr id="5" name="">
             <a:extLst xmlns:a="http://schemas.openxmlformats.org/drawingml/2006/main">
               <a:ext uri="{FF2B5EF4-FFF2-40B4-BE49-F238E27FC236}">
-                <a16:creationId xmlns:a16="http://schemas.microsoft.com/office/drawing/2014/main" id="{74280E5D-F5B2-4C1D-B82D-F1F8D89AC325}"/>
+                <a16:creationId xmlns:a16="http://schemas.microsoft.com/office/drawing/2014/main" id="{34BA8BE6-77FD-4D84-8803-1A32721D4FA7}"/>
               </a:ext>
             </a:extLst>
           </p:cNvPr>
@@ -14303,7 +14282,7 @@
           <p:nvPr/>
         </p:nvPicPr>
         <p:blipFill>
-          <a:blip xmlns:r="http://schemas.openxmlformats.org/officeDocument/2006/relationships" xmlns:a="http://schemas.openxmlformats.org/drawingml/2006/main" r:embed="R13fd60bf31574dc1"/>
+          <a:blip xmlns:r="http://schemas.openxmlformats.org/officeDocument/2006/relationships" xmlns:a="http://schemas.openxmlformats.org/drawingml/2006/main" r:embed="R0fa20b25c380449b"/>
           <a:stretch xmlns:a="http://schemas.openxmlformats.org/drawingml/2006/main"/>
         </p:blipFill>
         <p:spPr>
@@ -14319,7 +14298,7 @@
     </p:spTree>
     <p:extLst>
       <p:ext uri="{BB962C8B-B14F-4D97-AF65-F5344CB8AC3E}">
-        <p14:creationId xmlns:p14="http://schemas.microsoft.com/office/powerpoint/2010/main" val="25138579"/>
+        <p14:creationId xmlns:p14="http://schemas.microsoft.com/office/powerpoint/2010/main" val="246528095"/>
       </p:ext>
     </p:extLst>
   </p:cSld>
@@ -14350,7 +14329,7 @@
           <p:cNvPr id="7" name="">
             <a:extLst xmlns:a="http://schemas.openxmlformats.org/drawingml/2006/main">
               <a:ext uri="{FF2B5EF4-FFF2-40B4-BE49-F238E27FC236}">
-                <a16:creationId xmlns:a16="http://schemas.microsoft.com/office/drawing/2014/main" id="{38C4DB07-118B-4C3B-8B3D-C58512042A29}"/>
+                <a16:creationId xmlns:a16="http://schemas.microsoft.com/office/drawing/2014/main" id="{707BFFD1-F2BC-40E9-826D-FD68E7897AD5}"/>
               </a:ext>
             </a:extLst>
           </p:cNvPr>
@@ -14416,7 +14395,7 @@
           <p:cNvPr id="2" name="">
             <a:extLst xmlns:a="http://schemas.openxmlformats.org/drawingml/2006/main">
               <a:ext uri="{FF2B5EF4-FFF2-40B4-BE49-F238E27FC236}">
-                <a16:creationId xmlns:a16="http://schemas.microsoft.com/office/drawing/2014/main" id="{611680B3-50EA-4A2D-A278-4D388E6F5C2C}"/>
+                <a16:creationId xmlns:a16="http://schemas.microsoft.com/office/drawing/2014/main" id="{25766B5A-54B8-430D-A076-24A756A5CFBC}"/>
               </a:ext>
             </a:extLst>
           </p:cNvPr>
@@ -14472,7 +14451,12 @@
                 <a:ea typeface="DejaVu Sans"/>
                 <a:cs typeface="DejaVu Sans"/>
               </a:rPr>
-              <a:t>Diameter: 3.66 m</a:t>
+              <a:t>Reference area and aerodynamic coefficients are inputs.</a:t>
+            </a:r>
+          </a:p>
+          <a:p xmlns:a="http://schemas.openxmlformats.org/drawingml/2006/main">
+            <a:r>
+              <a:t/>
             </a:r>
           </a:p>
           <a:p xmlns:a="http://schemas.openxmlformats.org/drawingml/2006/main">
@@ -14495,7 +14479,7 @@
                 <a:ea typeface="DejaVu Sans"/>
                 <a:cs typeface="DejaVu Sans"/>
               </a:rPr>
-              <a:t>Reference area: 10.52088 m²</a:t>
+              <a:t>Ascent uses constant base drag and an α² correction.</a:t>
             </a:r>
           </a:p>
           <a:p xmlns:a="http://schemas.openxmlformats.org/drawingml/2006/main">
@@ -14523,35 +14507,7 @@
                 <a:ea typeface="DejaVu Sans"/>
                 <a:cs typeface="DejaVu Sans"/>
               </a:rPr>
-              <a:t>Ascent uses constant base drag and an α² correction.</a:t>
-            </a:r>
-          </a:p>
-          <a:p xmlns:a="http://schemas.openxmlformats.org/drawingml/2006/main">
-            <a:r>
-              <a:t/>
-            </a:r>
-          </a:p>
-          <a:p xmlns:a="http://schemas.openxmlformats.org/drawingml/2006/main">
-            <a:pPr>
-              <a:defRPr sz="1875" b="0">
-                <a:solidFill>
-                  <a:srgbClr val="4D6271"/>
-                </a:solidFill>
-                <a:latin typeface="DejaVu Sans"/>
-                <a:ea typeface="DejaVu Sans"/>
-                <a:cs typeface="DejaVu Sans"/>
-              </a:defRPr>
-            </a:pPr>
-            <a:r>
-              <a:rPr sz="1875" b="0">
-                <a:solidFill>
-                  <a:srgbClr val="4D6271"/>
-                </a:solidFill>
-                <a:latin typeface="DejaVu Sans"/>
-                <a:ea typeface="DejaVu Sans"/>
-                <a:cs typeface="DejaVu Sans"/>
-              </a:rPr>
-              <a:t>Return drag uses CD = 1.6 and neglects lift.</a:t>
+              <a:t>Return flight neglects lift.</a:t>
             </a:r>
           </a:p>
         </p:txBody>
@@ -14561,7 +14517,7 @@
           <p:cNvPr id="3" name="">
             <a:extLst xmlns:a="http://schemas.openxmlformats.org/drawingml/2006/main">
               <a:ext uri="{FF2B5EF4-FFF2-40B4-BE49-F238E27FC236}">
-                <a16:creationId xmlns:a16="http://schemas.microsoft.com/office/drawing/2014/main" id="{B02DACF6-CC89-4E5B-8CBE-344BE9CB2B52}"/>
+                <a16:creationId xmlns:a16="http://schemas.microsoft.com/office/drawing/2014/main" id="{E07E958A-3A10-4A05-9317-05241780BA6C}"/>
               </a:ext>
             </a:extLst>
           </p:cNvPr>
@@ -14627,7 +14583,7 @@
           <p:cNvPr id="4" name="">
             <a:extLst xmlns:a="http://schemas.openxmlformats.org/drawingml/2006/main">
               <a:ext uri="{FF2B5EF4-FFF2-40B4-BE49-F238E27FC236}">
-                <a16:creationId xmlns:a16="http://schemas.microsoft.com/office/drawing/2014/main" id="{E950400B-EAC6-4FCF-B5E9-E7E987AF34AD}"/>
+                <a16:creationId xmlns:a16="http://schemas.microsoft.com/office/drawing/2014/main" id="{016F204B-5314-423B-B69F-FA8304626D07}"/>
               </a:ext>
             </a:extLst>
           </p:cNvPr>
@@ -14693,7 +14649,7 @@
           <p:cNvPr id="5" name="">
             <a:extLst xmlns:a="http://schemas.openxmlformats.org/drawingml/2006/main">
               <a:ext uri="{FF2B5EF4-FFF2-40B4-BE49-F238E27FC236}">
-                <a16:creationId xmlns:a16="http://schemas.microsoft.com/office/drawing/2014/main" id="{DFE6A8DB-763F-40DA-92C0-EB9E131EFAA7}"/>
+                <a16:creationId xmlns:a16="http://schemas.microsoft.com/office/drawing/2014/main" id="{3A158A34-4A14-4EE1-A05D-79F19993A4BA}"/>
               </a:ext>
             </a:extLst>
           </p:cNvPr>
@@ -14703,13 +14659,13 @@
           <p:nvPr/>
         </p:nvPicPr>
         <p:blipFill>
-          <a:blip xmlns:r="http://schemas.openxmlformats.org/officeDocument/2006/relationships" xmlns:a="http://schemas.openxmlformats.org/drawingml/2006/main" r:embed="R51a906b735604fac"/>
+          <a:blip xmlns:r="http://schemas.openxmlformats.org/officeDocument/2006/relationships" xmlns:a="http://schemas.openxmlformats.org/drawingml/2006/main" r:embed="R49030dbd5b164408"/>
           <a:stretch xmlns:a="http://schemas.openxmlformats.org/drawingml/2006/main"/>
         </p:blipFill>
         <p:spPr>
           <a:xfrm xmlns:a="http://schemas.openxmlformats.org/drawingml/2006/main">
             <a:off x="609600" y="1714500"/>
-            <a:ext cx="3063811" cy="3333750"/>
+            <a:ext cx="3494091" cy="3333750"/>
           </a:xfrm>
           <a:prstGeom xmlns:a="http://schemas.openxmlformats.org/drawingml/2006/main" prst="rect">
             <a:avLst/>
@@ -14721,7 +14677,7 @@
           <p:cNvPr id="6" name="">
             <a:extLst xmlns:a="http://schemas.openxmlformats.org/drawingml/2006/main">
               <a:ext uri="{FF2B5EF4-FFF2-40B4-BE49-F238E27FC236}">
-                <a16:creationId xmlns:a16="http://schemas.microsoft.com/office/drawing/2014/main" id="{230D7A79-F9A0-4964-8A03-5B78C0636B5E}"/>
+                <a16:creationId xmlns:a16="http://schemas.microsoft.com/office/drawing/2014/main" id="{0BBCA8DD-7391-44BF-8CCB-EA6B4C98ED82}"/>
               </a:ext>
             </a:extLst>
           </p:cNvPr>
@@ -14731,7 +14687,7 @@
           <p:nvPr/>
         </p:nvPicPr>
         <p:blipFill>
-          <a:blip xmlns:r="http://schemas.openxmlformats.org/officeDocument/2006/relationships" xmlns:a="http://schemas.openxmlformats.org/drawingml/2006/main" r:embed="R78171da0f34a43ee"/>
+          <a:blip xmlns:r="http://schemas.openxmlformats.org/officeDocument/2006/relationships" xmlns:a="http://schemas.openxmlformats.org/drawingml/2006/main" r:embed="R8344822a75ce45a5"/>
           <a:stretch xmlns:a="http://schemas.openxmlformats.org/drawingml/2006/main"/>
         </p:blipFill>
         <p:spPr>
@@ -14747,7 +14703,7 @@
     </p:spTree>
     <p:extLst>
       <p:ext uri="{BB962C8B-B14F-4D97-AF65-F5344CB8AC3E}">
-        <p14:creationId xmlns:p14="http://schemas.microsoft.com/office/powerpoint/2010/main" val="1953670600"/>
+        <p14:creationId xmlns:p14="http://schemas.microsoft.com/office/powerpoint/2010/main" val="983831007"/>
       </p:ext>
     </p:extLst>
   </p:cSld>
@@ -14778,7 +14734,7 @@
           <p:cNvPr id="6" name="">
             <a:extLst xmlns:a="http://schemas.openxmlformats.org/drawingml/2006/main">
               <a:ext uri="{FF2B5EF4-FFF2-40B4-BE49-F238E27FC236}">
-                <a16:creationId xmlns:a16="http://schemas.microsoft.com/office/drawing/2014/main" id="{BD24FDC2-38D5-4D04-B302-99B7EF6EEA27}"/>
+                <a16:creationId xmlns:a16="http://schemas.microsoft.com/office/drawing/2014/main" id="{C43BD997-8039-493F-9ABC-AEE519641B85}"/>
               </a:ext>
             </a:extLst>
           </p:cNvPr>
@@ -14844,7 +14800,7 @@
           <p:cNvPr id="2" name="">
             <a:extLst xmlns:a="http://schemas.openxmlformats.org/drawingml/2006/main">
               <a:ext uri="{FF2B5EF4-FFF2-40B4-BE49-F238E27FC236}">
-                <a16:creationId xmlns:a16="http://schemas.microsoft.com/office/drawing/2014/main" id="{73B1672F-C6B1-4757-A334-C32313EEAD48}"/>
+                <a16:creationId xmlns:a16="http://schemas.microsoft.com/office/drawing/2014/main" id="{67FAFAB4-B4D5-4EA3-A588-183C80FFEB25}"/>
               </a:ext>
             </a:extLst>
           </p:cNvPr>
@@ -14900,7 +14856,12 @@
                 <a:ea typeface="DejaVu Sans"/>
                 <a:cs typeface="DejaVu Sans"/>
               </a:rPr>
-              <a:t>Sea-level values</a:t>
+              <a:t>Altitude-dependent density, pressure, and sound speed come from atmosphere tables.</a:t>
+            </a:r>
+          </a:p>
+          <a:p xmlns:a="http://schemas.openxmlformats.org/drawingml/2006/main">
+            <a:r>
+              <a:t/>
             </a:r>
           </a:p>
           <a:p xmlns:a="http://schemas.openxmlformats.org/drawingml/2006/main">
@@ -14923,7 +14884,12 @@
                 <a:ea typeface="DejaVu Sans"/>
                 <a:cs typeface="DejaVu Sans"/>
               </a:rPr>
-              <a:t>Density: 1.225 kg/m³</a:t>
+              <a:t>Density and pressure interpolate in log space.</a:t>
+            </a:r>
+          </a:p>
+          <a:p xmlns:a="http://schemas.openxmlformats.org/drawingml/2006/main">
+            <a:r>
+              <a:t/>
             </a:r>
           </a:p>
           <a:p xmlns:a="http://schemas.openxmlformats.org/drawingml/2006/main">
@@ -14946,58 +14912,7 @@
                 <a:ea typeface="DejaVu Sans"/>
                 <a:cs typeface="DejaVu Sans"/>
               </a:rPr>
-              <a:t>Pressure: 101,325 Pa</a:t>
-            </a:r>
-          </a:p>
-          <a:p xmlns:a="http://schemas.openxmlformats.org/drawingml/2006/main">
-            <a:pPr>
-              <a:defRPr sz="1875" b="0">
-                <a:solidFill>
-                  <a:srgbClr val="4D6271"/>
-                </a:solidFill>
-                <a:latin typeface="DejaVu Sans"/>
-                <a:ea typeface="DejaVu Sans"/>
-                <a:cs typeface="DejaVu Sans"/>
-              </a:defRPr>
-            </a:pPr>
-            <a:r>
-              <a:rPr sz="1875" b="0">
-                <a:solidFill>
-                  <a:srgbClr val="4D6271"/>
-                </a:solidFill>
-                <a:latin typeface="DejaVu Sans"/>
-                <a:ea typeface="DejaVu Sans"/>
-                <a:cs typeface="DejaVu Sans"/>
-              </a:rPr>
-              <a:t>Sound speed: 340.3 m/s</a:t>
-            </a:r>
-          </a:p>
-          <a:p xmlns:a="http://schemas.openxmlformats.org/drawingml/2006/main">
-            <a:r>
-              <a:t/>
-            </a:r>
-          </a:p>
-          <a:p xmlns:a="http://schemas.openxmlformats.org/drawingml/2006/main">
-            <a:pPr>
-              <a:defRPr sz="1875" b="0">
-                <a:solidFill>
-                  <a:srgbClr val="4D6271"/>
-                </a:solidFill>
-                <a:latin typeface="DejaVu Sans"/>
-                <a:ea typeface="DejaVu Sans"/>
-                <a:cs typeface="DejaVu Sans"/>
-              </a:defRPr>
-            </a:pPr>
-            <a:r>
-              <a:rPr sz="1875" b="0">
-                <a:solidFill>
-                  <a:srgbClr val="4D6271"/>
-                </a:solidFill>
-                <a:latin typeface="DejaVu Sans"/>
-                <a:ea typeface="DejaVu Sans"/>
-                <a:cs typeface="DejaVu Sans"/>
-              </a:rPr>
-              <a:t>Density and pressure interpolate in log space. Sound speed interpolates linearly.</a:t>
+              <a:t>Sound speed interpolates linearly.</a:t>
             </a:r>
           </a:p>
         </p:txBody>
@@ -15007,7 +14922,7 @@
           <p:cNvPr id="3" name="">
             <a:extLst xmlns:a="http://schemas.openxmlformats.org/drawingml/2006/main">
               <a:ext uri="{FF2B5EF4-FFF2-40B4-BE49-F238E27FC236}">
-                <a16:creationId xmlns:a16="http://schemas.microsoft.com/office/drawing/2014/main" id="{BB43FDD2-8373-42AD-A87B-ACF8E81AEF3F}"/>
+                <a16:creationId xmlns:a16="http://schemas.microsoft.com/office/drawing/2014/main" id="{0B2E1A6B-6260-4F5F-A943-486558611F1B}"/>
               </a:ext>
             </a:extLst>
           </p:cNvPr>
@@ -15073,7 +14988,7 @@
           <p:cNvPr id="4" name="">
             <a:extLst xmlns:a="http://schemas.openxmlformats.org/drawingml/2006/main">
               <a:ext uri="{FF2B5EF4-FFF2-40B4-BE49-F238E27FC236}">
-                <a16:creationId xmlns:a16="http://schemas.microsoft.com/office/drawing/2014/main" id="{45F25984-EF4B-4147-8559-CC452A4AD573}"/>
+                <a16:creationId xmlns:a16="http://schemas.microsoft.com/office/drawing/2014/main" id="{0B6FE81B-987A-4212-A89F-4C9F2945340C}"/>
               </a:ext>
             </a:extLst>
           </p:cNvPr>
@@ -15139,7 +15054,7 @@
           <p:cNvPr id="5" name="">
             <a:extLst xmlns:a="http://schemas.openxmlformats.org/drawingml/2006/main">
               <a:ext uri="{FF2B5EF4-FFF2-40B4-BE49-F238E27FC236}">
-                <a16:creationId xmlns:a16="http://schemas.microsoft.com/office/drawing/2014/main" id="{A6C3E6A5-D429-4CF0-826B-4C05B34BE85E}"/>
+                <a16:creationId xmlns:a16="http://schemas.microsoft.com/office/drawing/2014/main" id="{6AAC1120-E721-4DAF-8516-A587AB9FB661}"/>
               </a:ext>
             </a:extLst>
           </p:cNvPr>
@@ -15149,7 +15064,7 @@
           <p:nvPr/>
         </p:nvPicPr>
         <p:blipFill>
-          <a:blip xmlns:r="http://schemas.openxmlformats.org/officeDocument/2006/relationships" xmlns:a="http://schemas.openxmlformats.org/drawingml/2006/main" r:embed="R5285c7c7e7774def"/>
+          <a:blip xmlns:r="http://schemas.openxmlformats.org/officeDocument/2006/relationships" xmlns:a="http://schemas.openxmlformats.org/drawingml/2006/main" r:embed="R241b5d4482c14327"/>
           <a:stretch xmlns:a="http://schemas.openxmlformats.org/drawingml/2006/main"/>
         </p:blipFill>
         <p:spPr>
@@ -15165,7 +15080,7 @@
     </p:spTree>
     <p:extLst>
       <p:ext uri="{BB962C8B-B14F-4D97-AF65-F5344CB8AC3E}">
-        <p14:creationId xmlns:p14="http://schemas.microsoft.com/office/powerpoint/2010/main" val="1436179520"/>
+        <p14:creationId xmlns:p14="http://schemas.microsoft.com/office/powerpoint/2010/main" val="673273144"/>
       </p:ext>
     </p:extLst>
   </p:cSld>
@@ -15196,7 +15111,7 @@
           <p:cNvPr id="6" name="">
             <a:extLst xmlns:a="http://schemas.openxmlformats.org/drawingml/2006/main">
               <a:ext uri="{FF2B5EF4-FFF2-40B4-BE49-F238E27FC236}">
-                <a16:creationId xmlns:a16="http://schemas.microsoft.com/office/drawing/2014/main" id="{A0F3D562-2A35-46AF-98DA-57C6FDE31A90}"/>
+                <a16:creationId xmlns:a16="http://schemas.microsoft.com/office/drawing/2014/main" id="{AC5A58EF-C118-4CF6-8386-A7965DE90007}"/>
               </a:ext>
             </a:extLst>
           </p:cNvPr>
@@ -15262,7 +15177,7 @@
           <p:cNvPr id="2" name="">
             <a:extLst xmlns:a="http://schemas.openxmlformats.org/drawingml/2006/main">
               <a:ext uri="{FF2B5EF4-FFF2-40B4-BE49-F238E27FC236}">
-                <a16:creationId xmlns:a16="http://schemas.microsoft.com/office/drawing/2014/main" id="{20A21B6A-882D-4A73-A9F9-1E9F938E91FB}"/>
+                <a16:creationId xmlns:a16="http://schemas.microsoft.com/office/drawing/2014/main" id="{0B50667D-B5A7-4454-91AC-60D42EB3D4FD}"/>
               </a:ext>
             </a:extLst>
           </p:cNvPr>
@@ -15318,7 +15233,12 @@
                 <a:ea typeface="DejaVu Sans"/>
                 <a:cs typeface="DejaVu Sans"/>
               </a:rPr>
-              <a:t>Earth radius: 6,378,137 m</a:t>
+              <a:t>Earth radius and gravitational parameter define the gravity model.</a:t>
+            </a:r>
+          </a:p>
+          <a:p xmlns:a="http://schemas.openxmlformats.org/drawingml/2006/main">
+            <a:r>
+              <a:t/>
             </a:r>
           </a:p>
           <a:p xmlns:a="http://schemas.openxmlformats.org/drawingml/2006/main">
@@ -15341,7 +15261,12 @@
                 <a:ea typeface="DejaVu Sans"/>
                 <a:cs typeface="DejaVu Sans"/>
               </a:rPr>
-              <a:t>μ = 3.986004418 × 10¹⁴ m³/s²</a:t>
+              <a:t>Local frame: planar ascent and booster return</a:t>
+            </a:r>
+          </a:p>
+          <a:p xmlns:a="http://schemas.openxmlformats.org/drawingml/2006/main">
+            <a:r>
+              <a:t/>
             </a:r>
           </a:p>
           <a:p xmlns:a="http://schemas.openxmlformats.org/drawingml/2006/main">
@@ -15364,58 +15289,7 @@
                 <a:ea typeface="DejaVu Sans"/>
                 <a:cs typeface="DejaVu Sans"/>
               </a:rPr>
-              <a:t>g₀ = μ / R² = 9.798285 m/s²</a:t>
-            </a:r>
-          </a:p>
-          <a:p xmlns:a="http://schemas.openxmlformats.org/drawingml/2006/main">
-            <a:r>
-              <a:t/>
-            </a:r>
-          </a:p>
-          <a:p xmlns:a="http://schemas.openxmlformats.org/drawingml/2006/main">
-            <a:pPr>
-              <a:defRPr sz="1875" b="0">
-                <a:solidFill>
-                  <a:srgbClr val="4D6271"/>
-                </a:solidFill>
-                <a:latin typeface="DejaVu Sans"/>
-                <a:ea typeface="DejaVu Sans"/>
-                <a:cs typeface="DejaVu Sans"/>
-              </a:defRPr>
-            </a:pPr>
-            <a:r>
-              <a:rPr sz="1875" b="0">
-                <a:solidFill>
-                  <a:srgbClr val="4D6271"/>
-                </a:solidFill>
-                <a:latin typeface="DejaVu Sans"/>
-                <a:ea typeface="DejaVu Sans"/>
-                <a:cs typeface="DejaVu Sans"/>
-              </a:rPr>
-              <a:t>Local frame: planar ascent / return</a:t>
-            </a:r>
-          </a:p>
-          <a:p xmlns:a="http://schemas.openxmlformats.org/drawingml/2006/main">
-            <a:pPr>
-              <a:defRPr sz="1875" b="0">
-                <a:solidFill>
-                  <a:srgbClr val="4D6271"/>
-                </a:solidFill>
-                <a:latin typeface="DejaVu Sans"/>
-                <a:ea typeface="DejaVu Sans"/>
-                <a:cs typeface="DejaVu Sans"/>
-              </a:defRPr>
-            </a:pPr>
-            <a:r>
-              <a:rPr sz="1875" b="0">
-                <a:solidFill>
-                  <a:srgbClr val="4D6271"/>
-                </a:solidFill>
-                <a:latin typeface="DejaVu Sans"/>
-                <a:ea typeface="DejaVu Sans"/>
-                <a:cs typeface="DejaVu Sans"/>
-              </a:rPr>
-              <a:t>ECI: 3D upper-stage flight</a:t>
+              <a:t>ECI frame: upper-stage flight</a:t>
             </a:r>
           </a:p>
         </p:txBody>
@@ -15425,7 +15299,7 @@
           <p:cNvPr id="3" name="">
             <a:extLst xmlns:a="http://schemas.openxmlformats.org/drawingml/2006/main">
               <a:ext uri="{FF2B5EF4-FFF2-40B4-BE49-F238E27FC236}">
-                <a16:creationId xmlns:a16="http://schemas.microsoft.com/office/drawing/2014/main" id="{BD4CE826-549C-4475-A172-7E5AF0EDB048}"/>
+                <a16:creationId xmlns:a16="http://schemas.microsoft.com/office/drawing/2014/main" id="{BA8A7CD8-6970-48E3-984A-99424CF46453}"/>
               </a:ext>
             </a:extLst>
           </p:cNvPr>
@@ -15491,7 +15365,7 @@
           <p:cNvPr id="4" name="">
             <a:extLst xmlns:a="http://schemas.openxmlformats.org/drawingml/2006/main">
               <a:ext uri="{FF2B5EF4-FFF2-40B4-BE49-F238E27FC236}">
-                <a16:creationId xmlns:a16="http://schemas.microsoft.com/office/drawing/2014/main" id="{A0FC2542-31DD-43F4-8CCA-2AC746441156}"/>
+                <a16:creationId xmlns:a16="http://schemas.microsoft.com/office/drawing/2014/main" id="{B9CEEE0D-9CC6-48D2-832F-9A22467C6112}"/>
               </a:ext>
             </a:extLst>
           </p:cNvPr>
@@ -15557,7 +15431,7 @@
           <p:cNvPr id="5" name="">
             <a:extLst xmlns:a="http://schemas.openxmlformats.org/drawingml/2006/main">
               <a:ext uri="{FF2B5EF4-FFF2-40B4-BE49-F238E27FC236}">
-                <a16:creationId xmlns:a16="http://schemas.microsoft.com/office/drawing/2014/main" id="{78B01908-7B2D-4F7C-8015-093CABEB9F84}"/>
+                <a16:creationId xmlns:a16="http://schemas.microsoft.com/office/drawing/2014/main" id="{B7BDB8BA-77CD-4A34-A5EB-182CD34D81AA}"/>
               </a:ext>
             </a:extLst>
           </p:cNvPr>
@@ -15567,7 +15441,7 @@
           <p:nvPr/>
         </p:nvPicPr>
         <p:blipFill>
-          <a:blip xmlns:r="http://schemas.openxmlformats.org/officeDocument/2006/relationships" xmlns:a="http://schemas.openxmlformats.org/drawingml/2006/main" r:embed="R9cea77c6621d4c81"/>
+          <a:blip xmlns:r="http://schemas.openxmlformats.org/officeDocument/2006/relationships" xmlns:a="http://schemas.openxmlformats.org/drawingml/2006/main" r:embed="R82826795532b4e09"/>
           <a:stretch xmlns:a="http://schemas.openxmlformats.org/drawingml/2006/main"/>
         </p:blipFill>
         <p:spPr>
@@ -15583,7 +15457,7 @@
     </p:spTree>
     <p:extLst>
       <p:ext uri="{BB962C8B-B14F-4D97-AF65-F5344CB8AC3E}">
-        <p14:creationId xmlns:p14="http://schemas.microsoft.com/office/powerpoint/2010/main" val="1019472953"/>
+        <p14:creationId xmlns:p14="http://schemas.microsoft.com/office/powerpoint/2010/main" val="86132783"/>
       </p:ext>
     </p:extLst>
   </p:cSld>
@@ -15614,7 +15488,7 @@
           <p:cNvPr id="6" name="">
             <a:extLst xmlns:a="http://schemas.openxmlformats.org/drawingml/2006/main">
               <a:ext uri="{FF2B5EF4-FFF2-40B4-BE49-F238E27FC236}">
-                <a16:creationId xmlns:a16="http://schemas.microsoft.com/office/drawing/2014/main" id="{B70B93C1-9C39-4088-A5E3-5DFFB0C6F174}"/>
+                <a16:creationId xmlns:a16="http://schemas.microsoft.com/office/drawing/2014/main" id="{527BE4F9-194D-4614-BF7C-E3ADF5F0B47C}"/>
               </a:ext>
             </a:extLst>
           </p:cNvPr>
@@ -15680,7 +15554,7 @@
           <p:cNvPr id="2" name="">
             <a:extLst xmlns:a="http://schemas.openxmlformats.org/drawingml/2006/main">
               <a:ext uri="{FF2B5EF4-FFF2-40B4-BE49-F238E27FC236}">
-                <a16:creationId xmlns:a16="http://schemas.microsoft.com/office/drawing/2014/main" id="{EA2ADDFB-67AC-4628-9426-5FAC0ECC48AB}"/>
+                <a16:creationId xmlns:a16="http://schemas.microsoft.com/office/drawing/2014/main" id="{A89FC7AB-F81E-4291-AECB-F5C64FF4C961}"/>
               </a:ext>
             </a:extLst>
           </p:cNvPr>
@@ -15736,7 +15610,7 @@
                 <a:ea typeface="DejaVu Sans"/>
                 <a:cs typeface="DejaVu Sans"/>
               </a:rPr>
-              <a:t>Empirical coefficient κ = 2 × 10⁻⁴ in the code’s SI convention.</a:t>
+              <a:t>The empirical heating coefficient represents geometry effects.</a:t>
             </a:r>
           </a:p>
           <a:p xmlns:a="http://schemas.openxmlformats.org/drawingml/2006/main">
@@ -15764,7 +15638,12 @@
                 <a:ea typeface="DejaVu Sans"/>
                 <a:cs typeface="DejaVu Sans"/>
               </a:rPr>
-              <a:t>Return limits</a:t>
+              <a:t>Maximum heat flux and dynamic pressure are inputs.</a:t>
+            </a:r>
+          </a:p>
+          <a:p xmlns:a="http://schemas.openxmlformats.org/drawingml/2006/main">
+            <a:r>
+              <a:t/>
             </a:r>
           </a:p>
           <a:p xmlns:a="http://schemas.openxmlformats.org/drawingml/2006/main">
@@ -15787,57 +15666,6 @@
                 <a:ea typeface="DejaVu Sans"/>
                 <a:cs typeface="DejaVu Sans"/>
               </a:rPr>
-              <a:t>Heat flux: 110 kW/m²</a:t>
-            </a:r>
-          </a:p>
-          <a:p xmlns:a="http://schemas.openxmlformats.org/drawingml/2006/main">
-            <a:pPr>
-              <a:defRPr sz="1875" b="0">
-                <a:solidFill>
-                  <a:srgbClr val="4D6271"/>
-                </a:solidFill>
-                <a:latin typeface="DejaVu Sans"/>
-                <a:ea typeface="DejaVu Sans"/>
-                <a:cs typeface="DejaVu Sans"/>
-              </a:defRPr>
-            </a:pPr>
-            <a:r>
-              <a:rPr sz="1875" b="0">
-                <a:solidFill>
-                  <a:srgbClr val="4D6271"/>
-                </a:solidFill>
-                <a:latin typeface="DejaVu Sans"/>
-                <a:ea typeface="DejaVu Sans"/>
-                <a:cs typeface="DejaVu Sans"/>
-              </a:rPr>
-              <a:t>Dynamic pressure: 75 kPa</a:t>
-            </a:r>
-          </a:p>
-          <a:p xmlns:a="http://schemas.openxmlformats.org/drawingml/2006/main">
-            <a:r>
-              <a:t/>
-            </a:r>
-          </a:p>
-          <a:p xmlns:a="http://schemas.openxmlformats.org/drawingml/2006/main">
-            <a:pPr>
-              <a:defRPr sz="1875" b="0">
-                <a:solidFill>
-                  <a:srgbClr val="4D6271"/>
-                </a:solidFill>
-                <a:latin typeface="DejaVu Sans"/>
-                <a:ea typeface="DejaVu Sans"/>
-                <a:cs typeface="DejaVu Sans"/>
-              </a:defRPr>
-            </a:pPr>
-            <a:r>
-              <a:rPr sz="1875" b="0">
-                <a:solidFill>
-                  <a:srgbClr val="4D6271"/>
-                </a:solidFill>
-                <a:latin typeface="DejaVu Sans"/>
-                <a:ea typeface="DejaVu Sans"/>
-                <a:cs typeface="DejaVu Sans"/>
-              </a:rPr>
               <a:t>Entry burn reduces speed before descent.</a:t>
             </a:r>
           </a:p>
@@ -15848,7 +15676,7 @@
           <p:cNvPr id="3" name="">
             <a:extLst xmlns:a="http://schemas.openxmlformats.org/drawingml/2006/main">
               <a:ext uri="{FF2B5EF4-FFF2-40B4-BE49-F238E27FC236}">
-                <a16:creationId xmlns:a16="http://schemas.microsoft.com/office/drawing/2014/main" id="{6B3B8536-6380-4820-963D-C1A4F92E3C74}"/>
+                <a16:creationId xmlns:a16="http://schemas.microsoft.com/office/drawing/2014/main" id="{C9168181-6A78-4462-9154-5AFD682E2056}"/>
               </a:ext>
             </a:extLst>
           </p:cNvPr>
@@ -15914,7 +15742,7 @@
           <p:cNvPr id="4" name="">
             <a:extLst xmlns:a="http://schemas.openxmlformats.org/drawingml/2006/main">
               <a:ext uri="{FF2B5EF4-FFF2-40B4-BE49-F238E27FC236}">
-                <a16:creationId xmlns:a16="http://schemas.microsoft.com/office/drawing/2014/main" id="{466D5AB5-84BA-4024-8996-ADA77BB86B10}"/>
+                <a16:creationId xmlns:a16="http://schemas.microsoft.com/office/drawing/2014/main" id="{5B2E8F0C-2235-4611-9635-7841A811CD9D}"/>
               </a:ext>
             </a:extLst>
           </p:cNvPr>
@@ -15980,7 +15808,7 @@
           <p:cNvPr id="5" name="">
             <a:extLst xmlns:a="http://schemas.openxmlformats.org/drawingml/2006/main">
               <a:ext uri="{FF2B5EF4-FFF2-40B4-BE49-F238E27FC236}">
-                <a16:creationId xmlns:a16="http://schemas.microsoft.com/office/drawing/2014/main" id="{8B260A6A-1D82-491F-A253-9C8FB0506439}"/>
+                <a16:creationId xmlns:a16="http://schemas.microsoft.com/office/drawing/2014/main" id="{32AF5780-60DA-4AC6-BA19-1C6584B64EB3}"/>
               </a:ext>
             </a:extLst>
           </p:cNvPr>
@@ -15990,13 +15818,13 @@
           <p:nvPr/>
         </p:nvPicPr>
         <p:blipFill>
-          <a:blip xmlns:r="http://schemas.openxmlformats.org/officeDocument/2006/relationships" xmlns:a="http://schemas.openxmlformats.org/drawingml/2006/main" r:embed="Rc74025e6321346d5"/>
+          <a:blip xmlns:r="http://schemas.openxmlformats.org/officeDocument/2006/relationships" xmlns:a="http://schemas.openxmlformats.org/drawingml/2006/main" r:embed="R8c12492416f84840"/>
           <a:stretch xmlns:a="http://schemas.openxmlformats.org/drawingml/2006/main"/>
         </p:blipFill>
         <p:spPr>
           <a:xfrm xmlns:a="http://schemas.openxmlformats.org/drawingml/2006/main">
             <a:off x="609600" y="1714500"/>
-            <a:ext cx="2861356" cy="3333750"/>
+            <a:ext cx="1796367" cy="1951958"/>
           </a:xfrm>
           <a:prstGeom xmlns:a="http://schemas.openxmlformats.org/drawingml/2006/main" prst="rect">
             <a:avLst/>
@@ -16006,7 +15834,7 @@
     </p:spTree>
     <p:extLst>
       <p:ext uri="{BB962C8B-B14F-4D97-AF65-F5344CB8AC3E}">
-        <p14:creationId xmlns:p14="http://schemas.microsoft.com/office/powerpoint/2010/main" val="1046281389"/>
+        <p14:creationId xmlns:p14="http://schemas.microsoft.com/office/powerpoint/2010/main" val="120079444"/>
       </p:ext>
     </p:extLst>
   </p:cSld>
@@ -16037,7 +15865,7 @@
           <p:cNvPr id="14" name="">
             <a:extLst xmlns:a="http://schemas.openxmlformats.org/drawingml/2006/main">
               <a:ext uri="{FF2B5EF4-FFF2-40B4-BE49-F238E27FC236}">
-                <a16:creationId xmlns:a16="http://schemas.microsoft.com/office/drawing/2014/main" id="{1BD959E9-ED62-4DD6-B9A9-0247F6693D86}"/>
+                <a16:creationId xmlns:a16="http://schemas.microsoft.com/office/drawing/2014/main" id="{1053FE8A-5364-40D9-BB94-9AE6FAE9F884}"/>
               </a:ext>
             </a:extLst>
           </p:cNvPr>
@@ -16103,7 +15931,7 @@
           <p:cNvPr id="2" name="">
             <a:extLst xmlns:a="http://schemas.openxmlformats.org/drawingml/2006/main">
               <a:ext uri="{FF2B5EF4-FFF2-40B4-BE49-F238E27FC236}">
-                <a16:creationId xmlns:a16="http://schemas.microsoft.com/office/drawing/2014/main" id="{12B4DC2E-4A23-4C5E-97B4-CDD2E498DF6D}"/>
+                <a16:creationId xmlns:a16="http://schemas.microsoft.com/office/drawing/2014/main" id="{DD2D90C3-E46F-42BC-B811-A4762351701A}"/>
               </a:ext>
             </a:extLst>
           </p:cNvPr>
@@ -16169,7 +15997,7 @@
           <p:cNvPr id="3" name="">
             <a:extLst xmlns:a="http://schemas.openxmlformats.org/drawingml/2006/main">
               <a:ext uri="{FF2B5EF4-FFF2-40B4-BE49-F238E27FC236}">
-                <a16:creationId xmlns:a16="http://schemas.microsoft.com/office/drawing/2014/main" id="{8C3257BE-240B-4FA0-873D-D66D10A594DA}"/>
+                <a16:creationId xmlns:a16="http://schemas.microsoft.com/office/drawing/2014/main" id="{67C71E11-3F0F-4669-91B4-325A012FFC30}"/>
               </a:ext>
             </a:extLst>
           </p:cNvPr>
@@ -16235,7 +16063,7 @@
           <p:cNvPr id="4" name="">
             <a:extLst xmlns:a="http://schemas.openxmlformats.org/drawingml/2006/main">
               <a:ext uri="{FF2B5EF4-FFF2-40B4-BE49-F238E27FC236}">
-                <a16:creationId xmlns:a16="http://schemas.microsoft.com/office/drawing/2014/main" id="{8BC86E52-5670-475A-A223-8E005E5EA31B}"/>
+                <a16:creationId xmlns:a16="http://schemas.microsoft.com/office/drawing/2014/main" id="{D011CF89-0F39-4DB8-98DB-1A1F80FE1291}"/>
               </a:ext>
             </a:extLst>
           </p:cNvPr>
@@ -16301,7 +16129,7 @@
           <p:cNvPr id="5" name="">
             <a:extLst xmlns:a="http://schemas.openxmlformats.org/drawingml/2006/main">
               <a:ext uri="{FF2B5EF4-FFF2-40B4-BE49-F238E27FC236}">
-                <a16:creationId xmlns:a16="http://schemas.microsoft.com/office/drawing/2014/main" id="{A0189774-9EA8-46DB-B3B2-D563C63EF529}"/>
+                <a16:creationId xmlns:a16="http://schemas.microsoft.com/office/drawing/2014/main" id="{286073AC-9A4C-4563-A986-3B398998A399}"/>
               </a:ext>
             </a:extLst>
           </p:cNvPr>
@@ -16367,7 +16195,7 @@
           <p:cNvPr id="6" name="">
             <a:extLst xmlns:a="http://schemas.openxmlformats.org/drawingml/2006/main">
               <a:ext uri="{FF2B5EF4-FFF2-40B4-BE49-F238E27FC236}">
-                <a16:creationId xmlns:a16="http://schemas.microsoft.com/office/drawing/2014/main" id="{E8F06D68-A362-4B68-99AD-F46D087089C1}"/>
+                <a16:creationId xmlns:a16="http://schemas.microsoft.com/office/drawing/2014/main" id="{6D36A683-6D3B-4E20-9828-76A14DF03DB3}"/>
               </a:ext>
             </a:extLst>
           </p:cNvPr>
@@ -16433,7 +16261,7 @@
           <p:cNvPr id="7" name="">
             <a:extLst xmlns:a="http://schemas.openxmlformats.org/drawingml/2006/main">
               <a:ext uri="{FF2B5EF4-FFF2-40B4-BE49-F238E27FC236}">
-                <a16:creationId xmlns:a16="http://schemas.microsoft.com/office/drawing/2014/main" id="{775C9B82-1EFA-4C2A-8182-7AAAE61B4AE8}"/>
+                <a16:creationId xmlns:a16="http://schemas.microsoft.com/office/drawing/2014/main" id="{BA7A111C-0E17-426F-8414-4B773DEC29E0}"/>
               </a:ext>
             </a:extLst>
           </p:cNvPr>
@@ -16489,7 +16317,7 @@
                 <a:ea typeface="DejaVu Sans"/>
                 <a:cs typeface="DejaVu Sans"/>
               </a:rPr>
-              <a:t>Initial rise: 5 s. αmax = 0.1745 rad ≈ 10°. Payload load cap = 3.75 × 9.81 m/s².</a:t>
+              <a:t>Rise duration, angle-of-attack limit, and maximum payload load are prescribed parameters.</a:t>
             </a:r>
           </a:p>
         </p:txBody>
@@ -16499,7 +16327,7 @@
           <p:cNvPr id="8" name="">
             <a:extLst xmlns:a="http://schemas.openxmlformats.org/drawingml/2006/main">
               <a:ext uri="{FF2B5EF4-FFF2-40B4-BE49-F238E27FC236}">
-                <a16:creationId xmlns:a16="http://schemas.microsoft.com/office/drawing/2014/main" id="{6D3AEDA3-AC8A-4FB4-ABC2-D8B49A66FD18}"/>
+                <a16:creationId xmlns:a16="http://schemas.microsoft.com/office/drawing/2014/main" id="{342E86A4-4619-4997-B48C-F94A4D638B94}"/>
               </a:ext>
             </a:extLst>
           </p:cNvPr>
@@ -16565,7 +16393,7 @@
           <p:cNvPr id="9" name="">
             <a:extLst xmlns:a="http://schemas.openxmlformats.org/drawingml/2006/main">
               <a:ext uri="{FF2B5EF4-FFF2-40B4-BE49-F238E27FC236}">
-                <a16:creationId xmlns:a16="http://schemas.microsoft.com/office/drawing/2014/main" id="{0D78D5CA-3712-41AB-B125-6F24E333E014}"/>
+                <a16:creationId xmlns:a16="http://schemas.microsoft.com/office/drawing/2014/main" id="{4FF0B1F2-0C32-40B0-A4E2-C355EF7063C4}"/>
               </a:ext>
             </a:extLst>
           </p:cNvPr>
@@ -16575,7 +16403,7 @@
           <p:nvPr/>
         </p:nvPicPr>
         <p:blipFill>
-          <a:blip xmlns:r="http://schemas.openxmlformats.org/officeDocument/2006/relationships" xmlns:a="http://schemas.openxmlformats.org/drawingml/2006/main" r:embed="R3c205d1d8e414e05"/>
+          <a:blip xmlns:r="http://schemas.openxmlformats.org/officeDocument/2006/relationships" xmlns:a="http://schemas.openxmlformats.org/drawingml/2006/main" r:embed="Rc1fd3be1edd54799"/>
           <a:stretch xmlns:a="http://schemas.openxmlformats.org/drawingml/2006/main"/>
         </p:blipFill>
         <p:spPr>
@@ -16593,7 +16421,7 @@
           <p:cNvPr id="10" name="">
             <a:extLst xmlns:a="http://schemas.openxmlformats.org/drawingml/2006/main">
               <a:ext uri="{FF2B5EF4-FFF2-40B4-BE49-F238E27FC236}">
-                <a16:creationId xmlns:a16="http://schemas.microsoft.com/office/drawing/2014/main" id="{4D5516F6-7A5B-4637-A9CD-EE5D4166A5CD}"/>
+                <a16:creationId xmlns:a16="http://schemas.microsoft.com/office/drawing/2014/main" id="{6B477A32-86F2-4634-8C96-24AC5E5E2E22}"/>
               </a:ext>
             </a:extLst>
           </p:cNvPr>
@@ -16603,7 +16431,7 @@
           <p:nvPr/>
         </p:nvPicPr>
         <p:blipFill>
-          <a:blip xmlns:r="http://schemas.openxmlformats.org/officeDocument/2006/relationships" xmlns:a="http://schemas.openxmlformats.org/drawingml/2006/main" r:embed="R88963085856c462c"/>
+          <a:blip xmlns:r="http://schemas.openxmlformats.org/officeDocument/2006/relationships" xmlns:a="http://schemas.openxmlformats.org/drawingml/2006/main" r:embed="Rd73874983416414c"/>
           <a:stretch xmlns:a="http://schemas.openxmlformats.org/drawingml/2006/main"/>
         </p:blipFill>
         <p:spPr>
@@ -16621,7 +16449,7 @@
           <p:cNvPr id="11" name="">
             <a:extLst xmlns:a="http://schemas.openxmlformats.org/drawingml/2006/main">
               <a:ext uri="{FF2B5EF4-FFF2-40B4-BE49-F238E27FC236}">
-                <a16:creationId xmlns:a16="http://schemas.microsoft.com/office/drawing/2014/main" id="{03AF0AA9-B424-432A-859E-2B0B3E0685A7}"/>
+                <a16:creationId xmlns:a16="http://schemas.microsoft.com/office/drawing/2014/main" id="{183729ED-F956-4912-9549-3F3BA90AB5CA}"/>
               </a:ext>
             </a:extLst>
           </p:cNvPr>
@@ -16631,7 +16459,7 @@
           <p:nvPr/>
         </p:nvPicPr>
         <p:blipFill>
-          <a:blip xmlns:r="http://schemas.openxmlformats.org/officeDocument/2006/relationships" xmlns:a="http://schemas.openxmlformats.org/drawingml/2006/main" r:embed="R8cf77b65bed24aa3"/>
+          <a:blip xmlns:r="http://schemas.openxmlformats.org/officeDocument/2006/relationships" xmlns:a="http://schemas.openxmlformats.org/drawingml/2006/main" r:embed="R7497530ae30848b2"/>
           <a:stretch xmlns:a="http://schemas.openxmlformats.org/drawingml/2006/main"/>
         </p:blipFill>
         <p:spPr>
@@ -16649,7 +16477,7 @@
           <p:cNvPr id="12" name="">
             <a:extLst xmlns:a="http://schemas.openxmlformats.org/drawingml/2006/main">
               <a:ext uri="{FF2B5EF4-FFF2-40B4-BE49-F238E27FC236}">
-                <a16:creationId xmlns:a16="http://schemas.microsoft.com/office/drawing/2014/main" id="{F64F5419-86FF-4995-92EC-6D9D31DB175B}"/>
+                <a16:creationId xmlns:a16="http://schemas.microsoft.com/office/drawing/2014/main" id="{6AD6E254-E780-468D-9AC2-D4B0CD87BB67}"/>
               </a:ext>
             </a:extLst>
           </p:cNvPr>
@@ -16659,7 +16487,7 @@
           <p:nvPr/>
         </p:nvPicPr>
         <p:blipFill>
-          <a:blip xmlns:r="http://schemas.openxmlformats.org/officeDocument/2006/relationships" xmlns:a="http://schemas.openxmlformats.org/drawingml/2006/main" r:embed="R7be38f59a9b24abe"/>
+          <a:blip xmlns:r="http://schemas.openxmlformats.org/officeDocument/2006/relationships" xmlns:a="http://schemas.openxmlformats.org/drawingml/2006/main" r:embed="R4e84ef8f37f14ecc"/>
           <a:stretch xmlns:a="http://schemas.openxmlformats.org/drawingml/2006/main"/>
         </p:blipFill>
         <p:spPr>
@@ -16677,7 +16505,7 @@
           <p:cNvPr id="13" name="">
             <a:extLst xmlns:a="http://schemas.openxmlformats.org/drawingml/2006/main">
               <a:ext uri="{FF2B5EF4-FFF2-40B4-BE49-F238E27FC236}">
-                <a16:creationId xmlns:a16="http://schemas.microsoft.com/office/drawing/2014/main" id="{558D32CD-7EF1-4DCA-8C05-BEB36D13587C}"/>
+                <a16:creationId xmlns:a16="http://schemas.microsoft.com/office/drawing/2014/main" id="{A549EC44-D611-4754-A76E-714FAD27D05B}"/>
               </a:ext>
             </a:extLst>
           </p:cNvPr>
@@ -16687,13 +16515,13 @@
           <p:nvPr/>
         </p:nvPicPr>
         <p:blipFill>
-          <a:blip xmlns:r="http://schemas.openxmlformats.org/officeDocument/2006/relationships" xmlns:a="http://schemas.openxmlformats.org/drawingml/2006/main" r:embed="R74c08f7149534818"/>
+          <a:blip xmlns:r="http://schemas.openxmlformats.org/officeDocument/2006/relationships" xmlns:a="http://schemas.openxmlformats.org/drawingml/2006/main" r:embed="R052367565d5e45a8"/>
           <a:stretch xmlns:a="http://schemas.openxmlformats.org/drawingml/2006/main"/>
         </p:blipFill>
         <p:spPr>
           <a:xfrm xmlns:a="http://schemas.openxmlformats.org/drawingml/2006/main">
             <a:off x="6953250" y="2933700"/>
-            <a:ext cx="4629150" cy="2067986"/>
+            <a:ext cx="3330416" cy="2184273"/>
           </a:xfrm>
           <a:prstGeom xmlns:a="http://schemas.openxmlformats.org/drawingml/2006/main" prst="rect">
             <a:avLst/>
@@ -16703,7 +16531,7 @@
     </p:spTree>
     <p:extLst>
       <p:ext uri="{BB962C8B-B14F-4D97-AF65-F5344CB8AC3E}">
-        <p14:creationId xmlns:p14="http://schemas.microsoft.com/office/powerpoint/2010/main" val="952411764"/>
+        <p14:creationId xmlns:p14="http://schemas.microsoft.com/office/powerpoint/2010/main" val="1008169083"/>
       </p:ext>
     </p:extLst>
   </p:cSld>
@@ -16734,7 +16562,7 @@
           <p:cNvPr id="13" name="">
             <a:extLst xmlns:a="http://schemas.openxmlformats.org/drawingml/2006/main">
               <a:ext uri="{FF2B5EF4-FFF2-40B4-BE49-F238E27FC236}">
-                <a16:creationId xmlns:a16="http://schemas.microsoft.com/office/drawing/2014/main" id="{41FF3EB6-0342-483E-AD77-7DA09A0D8FBA}"/>
+                <a16:creationId xmlns:a16="http://schemas.microsoft.com/office/drawing/2014/main" id="{B23EFE11-3445-49C5-A83D-74922E75E2C0}"/>
               </a:ext>
             </a:extLst>
           </p:cNvPr>
@@ -16800,7 +16628,7 @@
           <p:cNvPr id="2" name="">
             <a:extLst xmlns:a="http://schemas.openxmlformats.org/drawingml/2006/main">
               <a:ext uri="{FF2B5EF4-FFF2-40B4-BE49-F238E27FC236}">
-                <a16:creationId xmlns:a16="http://schemas.microsoft.com/office/drawing/2014/main" id="{1E4F084B-32C5-4C47-8F2F-3E78403992CA}"/>
+                <a16:creationId xmlns:a16="http://schemas.microsoft.com/office/drawing/2014/main" id="{4FC1E984-C904-44A1-9B34-42363C1E740A}"/>
               </a:ext>
             </a:extLst>
           </p:cNvPr>
@@ -16866,7 +16694,7 @@
           <p:cNvPr id="3" name="">
             <a:extLst xmlns:a="http://schemas.openxmlformats.org/drawingml/2006/main">
               <a:ext uri="{FF2B5EF4-FFF2-40B4-BE49-F238E27FC236}">
-                <a16:creationId xmlns:a16="http://schemas.microsoft.com/office/drawing/2014/main" id="{177BDDE3-1422-4227-976A-1A9CCBE4B461}"/>
+                <a16:creationId xmlns:a16="http://schemas.microsoft.com/office/drawing/2014/main" id="{DDC7AC40-C207-4FD4-9C5D-E78B0E461EDA}"/>
               </a:ext>
             </a:extLst>
           </p:cNvPr>
@@ -16932,7 +16760,7 @@
           <p:cNvPr id="4" name="">
             <a:extLst xmlns:a="http://schemas.openxmlformats.org/drawingml/2006/main">
               <a:ext uri="{FF2B5EF4-FFF2-40B4-BE49-F238E27FC236}">
-                <a16:creationId xmlns:a16="http://schemas.microsoft.com/office/drawing/2014/main" id="{4E02E461-E473-473D-A52E-38B2E6541C57}"/>
+                <a16:creationId xmlns:a16="http://schemas.microsoft.com/office/drawing/2014/main" id="{D388368A-5A12-425B-AB5C-A16C192208B3}"/>
               </a:ext>
             </a:extLst>
           </p:cNvPr>
@@ -16998,7 +16826,7 @@
           <p:cNvPr id="5" name="">
             <a:extLst xmlns:a="http://schemas.openxmlformats.org/drawingml/2006/main">
               <a:ext uri="{FF2B5EF4-FFF2-40B4-BE49-F238E27FC236}">
-                <a16:creationId xmlns:a16="http://schemas.microsoft.com/office/drawing/2014/main" id="{E30C192B-736F-45AF-BB0E-6AA146F697F7}"/>
+                <a16:creationId xmlns:a16="http://schemas.microsoft.com/office/drawing/2014/main" id="{AA470737-BE48-492C-B2F3-87FF55591C92}"/>
               </a:ext>
             </a:extLst>
           </p:cNvPr>
@@ -17064,7 +16892,7 @@
           <p:cNvPr id="6" name="">
             <a:extLst xmlns:a="http://schemas.openxmlformats.org/drawingml/2006/main">
               <a:ext uri="{FF2B5EF4-FFF2-40B4-BE49-F238E27FC236}">
-                <a16:creationId xmlns:a16="http://schemas.microsoft.com/office/drawing/2014/main" id="{911E24A2-2B35-44D7-8484-EA8AA10B133D}"/>
+                <a16:creationId xmlns:a16="http://schemas.microsoft.com/office/drawing/2014/main" id="{186AEEC1-2AE7-413D-8BC5-4A8D0EBD79B9}"/>
               </a:ext>
             </a:extLst>
           </p:cNvPr>
@@ -17120,7 +16948,7 @@
                 <a:ea typeface="DejaVu Sans"/>
                 <a:cs typeface="DejaVu Sans"/>
               </a:rPr>
-              <a:t>Separation sets the ECI initial state. A prescribed 10 s coast precedes SES-1.</a:t>
+              <a:t>Separation sets the ECI initial state. A prescribed coast duration precedes SES-1.</a:t>
             </a:r>
           </a:p>
         </p:txBody>
@@ -17130,7 +16958,7 @@
           <p:cNvPr id="7" name="">
             <a:extLst xmlns:a="http://schemas.openxmlformats.org/drawingml/2006/main">
               <a:ext uri="{FF2B5EF4-FFF2-40B4-BE49-F238E27FC236}">
-                <a16:creationId xmlns:a16="http://schemas.microsoft.com/office/drawing/2014/main" id="{25D8B8A2-A728-40C4-83E9-F7411145E99B}"/>
+                <a16:creationId xmlns:a16="http://schemas.microsoft.com/office/drawing/2014/main" id="{36A8596E-C359-4CAD-B0E7-C06699CB8A0E}"/>
               </a:ext>
             </a:extLst>
           </p:cNvPr>
@@ -17196,7 +17024,7 @@
           <p:cNvPr id="8" name="">
             <a:extLst xmlns:a="http://schemas.openxmlformats.org/drawingml/2006/main">
               <a:ext uri="{FF2B5EF4-FFF2-40B4-BE49-F238E27FC236}">
-                <a16:creationId xmlns:a16="http://schemas.microsoft.com/office/drawing/2014/main" id="{C7D257F4-E44A-435E-95BC-BDC2A4EBEA4F}"/>
+                <a16:creationId xmlns:a16="http://schemas.microsoft.com/office/drawing/2014/main" id="{D8F292AD-D162-46A6-BF54-E621432016B8}"/>
               </a:ext>
             </a:extLst>
           </p:cNvPr>
@@ -17262,7 +17090,7 @@
           <p:cNvPr id="9" name="">
             <a:extLst xmlns:a="http://schemas.openxmlformats.org/drawingml/2006/main">
               <a:ext uri="{FF2B5EF4-FFF2-40B4-BE49-F238E27FC236}">
-                <a16:creationId xmlns:a16="http://schemas.microsoft.com/office/drawing/2014/main" id="{65F3A64E-DD86-4038-A253-4492133EFF99}"/>
+                <a16:creationId xmlns:a16="http://schemas.microsoft.com/office/drawing/2014/main" id="{BDFFE739-33F5-4C12-99D9-4CD7005E839D}"/>
               </a:ext>
             </a:extLst>
           </p:cNvPr>
@@ -17272,7 +17100,7 @@
           <p:nvPr/>
         </p:nvPicPr>
         <p:blipFill>
-          <a:blip xmlns:r="http://schemas.openxmlformats.org/officeDocument/2006/relationships" xmlns:a="http://schemas.openxmlformats.org/drawingml/2006/main" r:embed="R7363f34eb7704e8e"/>
+          <a:blip xmlns:r="http://schemas.openxmlformats.org/officeDocument/2006/relationships" xmlns:a="http://schemas.openxmlformats.org/drawingml/2006/main" r:embed="R612260cc5ee3456a"/>
           <a:stretch xmlns:a="http://schemas.openxmlformats.org/drawingml/2006/main"/>
         </p:blipFill>
         <p:spPr>
@@ -17290,7 +17118,7 @@
           <p:cNvPr id="10" name="">
             <a:extLst xmlns:a="http://schemas.openxmlformats.org/drawingml/2006/main">
               <a:ext uri="{FF2B5EF4-FFF2-40B4-BE49-F238E27FC236}">
-                <a16:creationId xmlns:a16="http://schemas.microsoft.com/office/drawing/2014/main" id="{6730CAA3-BE8E-462A-9BB4-ED936F24B16F}"/>
+                <a16:creationId xmlns:a16="http://schemas.microsoft.com/office/drawing/2014/main" id="{F9E42DE1-9E2F-4DD2-AD4B-05E235F235E7}"/>
               </a:ext>
             </a:extLst>
           </p:cNvPr>
@@ -17300,7 +17128,7 @@
           <p:nvPr/>
         </p:nvPicPr>
         <p:blipFill>
-          <a:blip xmlns:r="http://schemas.openxmlformats.org/officeDocument/2006/relationships" xmlns:a="http://schemas.openxmlformats.org/drawingml/2006/main" r:embed="R09bedceb6acb4760"/>
+          <a:blip xmlns:r="http://schemas.openxmlformats.org/officeDocument/2006/relationships" xmlns:a="http://schemas.openxmlformats.org/drawingml/2006/main" r:embed="R61ab2eb5a9f544d5"/>
           <a:stretch xmlns:a="http://schemas.openxmlformats.org/drawingml/2006/main"/>
         </p:blipFill>
         <p:spPr>
@@ -17318,7 +17146,7 @@
           <p:cNvPr id="11" name="">
             <a:extLst xmlns:a="http://schemas.openxmlformats.org/drawingml/2006/main">
               <a:ext uri="{FF2B5EF4-FFF2-40B4-BE49-F238E27FC236}">
-                <a16:creationId xmlns:a16="http://schemas.microsoft.com/office/drawing/2014/main" id="{0F2CB96F-4248-4601-952D-6D4C5B658EA5}"/>
+                <a16:creationId xmlns:a16="http://schemas.microsoft.com/office/drawing/2014/main" id="{D137EFD0-B8B7-4DAB-8A80-B4E1F47CCFB5}"/>
               </a:ext>
             </a:extLst>
           </p:cNvPr>
@@ -17328,7 +17156,7 @@
           <p:nvPr/>
         </p:nvPicPr>
         <p:blipFill>
-          <a:blip xmlns:r="http://schemas.openxmlformats.org/officeDocument/2006/relationships" xmlns:a="http://schemas.openxmlformats.org/drawingml/2006/main" r:embed="R878cd64dddc14e42"/>
+          <a:blip xmlns:r="http://schemas.openxmlformats.org/officeDocument/2006/relationships" xmlns:a="http://schemas.openxmlformats.org/drawingml/2006/main" r:embed="Rbcea00e7135e49ff"/>
           <a:stretch xmlns:a="http://schemas.openxmlformats.org/drawingml/2006/main"/>
         </p:blipFill>
         <p:spPr>
@@ -17346,7 +17174,7 @@
           <p:cNvPr id="12" name="">
             <a:extLst xmlns:a="http://schemas.openxmlformats.org/drawingml/2006/main">
               <a:ext uri="{FF2B5EF4-FFF2-40B4-BE49-F238E27FC236}">
-                <a16:creationId xmlns:a16="http://schemas.microsoft.com/office/drawing/2014/main" id="{56270186-E7A9-4A2F-A11B-242BF177F20B}"/>
+                <a16:creationId xmlns:a16="http://schemas.microsoft.com/office/drawing/2014/main" id="{D27026A4-7218-44A4-A298-35E90F04D9A3}"/>
               </a:ext>
             </a:extLst>
           </p:cNvPr>
@@ -17356,13 +17184,13 @@
           <p:nvPr/>
         </p:nvPicPr>
         <p:blipFill>
-          <a:blip xmlns:r="http://schemas.openxmlformats.org/officeDocument/2006/relationships" xmlns:a="http://schemas.openxmlformats.org/drawingml/2006/main" r:embed="R80d0897acce54151"/>
+          <a:blip xmlns:r="http://schemas.openxmlformats.org/officeDocument/2006/relationships" xmlns:a="http://schemas.openxmlformats.org/drawingml/2006/main" r:embed="R8d6e0a08182148e4"/>
           <a:stretch xmlns:a="http://schemas.openxmlformats.org/drawingml/2006/main"/>
         </p:blipFill>
         <p:spPr>
           <a:xfrm xmlns:a="http://schemas.openxmlformats.org/drawingml/2006/main">
             <a:off x="6953250" y="2933700"/>
-            <a:ext cx="3450431" cy="1788224"/>
+            <a:ext cx="2934367" cy="1788224"/>
           </a:xfrm>
           <a:prstGeom xmlns:a="http://schemas.openxmlformats.org/drawingml/2006/main" prst="rect">
             <a:avLst/>
@@ -17372,7 +17200,7 @@
     </p:spTree>
     <p:extLst>
       <p:ext uri="{BB962C8B-B14F-4D97-AF65-F5344CB8AC3E}">
-        <p14:creationId xmlns:p14="http://schemas.microsoft.com/office/powerpoint/2010/main" val="1387660455"/>
+        <p14:creationId xmlns:p14="http://schemas.microsoft.com/office/powerpoint/2010/main" val="520616776"/>
       </p:ext>
     </p:extLst>
   </p:cSld>

</xml_diff>